<commit_message>
Tampilkan hasil Create ML di layar, rapikan isi deck sesuai template Day 3
</commit_message>
<xml_diff>
--- a/presentasi/PantangMakan.pptx
+++ b/presentasi/PantangMakan.pptx
@@ -866,7 +866,7 @@
           <a:p>
             <a:r>
               <a:rPr lang="en-US" dirty="0"/>
-              <a:t>Satu kalimat penutup: kami cek 10 kemasan sungguhan, lalu catat yang benar dan satu yang gagal. Selesai. Tidak ada slide penutup.</a:t>
+              <a:t>Satu kalimat penutup: kemasan yang salah kami masukkan ke data latih Create ML, lalu latih ulang. Sebut contoh gagal dari slide Validasi kalau sudah ada. Tidak ada slide penutup.</a:t>
             </a:r>
             <a:endParaRPr lang="en-US" dirty="0"/>
           </a:p>
@@ -1218,7 +1218,7 @@
           <a:p>
             <a:r>
               <a:rPr lang="en-US" dirty="0"/>
-              <a:t>User memilih pantangan, memfoto daftar komposisi, lalu membaca satu kalimat. Foto kedua mengganti kalimat tanpa menutup app.</a:t>
+              <a:t>Buka dengan cerita satu orang sebelum fitur (syarat D4 Skilled). Sebut nama dan pantangan orang sungguhan yang kalian kenal, jangan dikarang. Contoh alur: dia di minimarket, membalik bungkus selai, huruf komposisinya kecil. Lalu: pilih pantangan sekali, foto, baca satu kalimat. Dampak lain: arachis hypogaea dikenali sebagai kacang.</a:t>
             </a:r>
             <a:endParaRPr lang="en-US" dirty="0"/>
           </a:p>
@@ -1306,7 +1306,7 @@
           <a:p>
             <a:r>
               <a:rPr lang="en-US" dirty="0"/>
-              <a:t>Sebut kelompoknya: diajarkan atau side-app. Jangan bilang semuanya on-device. Create ML dipanggil, labelnya tidak tampil. Kartu hijau dan merah dari daftar kata sesuai pilihan user.</a:t>
+              <a:t>Sebut kelompoknya: dua diajarkan (Create ML, Foundation Models) dan dua side-app (baca teks dari foto, API). Jangan bilang semuanya on-device. Di layar hasil, tunjuk bagian HASIL AI.</a:t>
             </a:r>
             <a:endParaRPr lang="en-US" dirty="0"/>
           </a:p>
@@ -1394,7 +1394,7 @@
           <a:p>
             <a:r>
               <a:rPr lang="en-US" dirty="0"/>
-              <a:t>Kartu hijau dan merah bukan dari Create ML. User pilih garam, kemasan tidak memuat garam: Aman, bisa kamu makan, tidak mengandung garam. Ada arachis dan user pilih kacang: Tidak aman, mengandung kacang. System Language Model hanya menyusun kalimat itu.</a:t>
+              <a:t>Urutan di app: foto, Vision membaca teks, Create ML memberi label (tampil di HASIL AI), Foundation Models menyusun kalimat; API Dicoding hanya kalau model Apple tidak ada. Warna kartu tetap dari daftar kata sesuai pantangan user. User pilih garam, kemasan tidak memuat garam: Aman, bisa kamu makan, tidak mengandung garam. Ada arachis dan user pilih kacang: Tidak aman, mengandung kacang. System Language Model hanya menyusun kalimat itu.</a:t>
             </a:r>
             <a:endParaRPr lang="en-US" dirty="0"/>
           </a:p>
@@ -2470,7 +2470,7 @@
                 <a:ea typeface="Calibri" pitchFamily="34" charset="-122"/>
                 <a:cs typeface="Calibri" pitchFamily="34" charset="-120"/>
               </a:rPr>
-              <a:t>10 foto, belum dijalankan</a:t>
+              <a:t>Isi: jumlah foto kemasan sungguhan</a:t>
             </a:r>
             <a:endParaRPr lang="en-US" sz="1400" dirty="0"/>
           </a:p>
@@ -2609,7 +2609,7 @@
                 <a:ea typeface="Calibri" pitchFamily="34" charset="-122"/>
                 <a:cs typeface="Calibri" pitchFamily="34" charset="-120"/>
               </a:rPr>
-              <a:t>Belum diisi</a:t>
+              <a:t>Isi: berapa yang kalimatnya benar</a:t>
             </a:r>
             <a:endParaRPr lang="en-US" sz="1400" dirty="0"/>
           </a:p>
@@ -2748,7 +2748,7 @@
                 <a:ea typeface="Calibri" pitchFamily="34" charset="-122"/>
                 <a:cs typeface="Calibri" pitchFamily="34" charset="-120"/>
               </a:rPr>
-              <a:t>Belum ada contoh</a:t>
+              <a:t>Isi: satu kemasan yang salah dan sebabnya</a:t>
             </a:r>
             <a:endParaRPr lang="en-US" sz="1400" dirty="0"/>
           </a:p>
@@ -3103,11 +3103,11 @@
         <p:spPr>
           <a:xfrm>
             <a:off x="502920" y="1325880"/>
-            <a:ext cx="11155680" cy="4023360"/>
+            <a:ext cx="11155680" cy="3291840"/>
           </a:xfrm>
           <a:prstGeom prst="roundRect">
             <a:avLst>
-              <a:gd name="adj" fmla="val 2727"/>
+              <a:gd name="adj" fmla="val 3333"/>
             </a:avLst>
           </a:prstGeom>
           <a:solidFill>
@@ -3188,7 +3188,7 @@
                 <a:ea typeface="Georgia" pitchFamily="34" charset="-122"/>
                 <a:cs typeface="Georgia" pitchFamily="34" charset="-120"/>
               </a:rPr>
-              <a:t>Foto 10 kemasan sungguhan.</a:t>
+              <a:t>Tambah data latih dari kemasan sungguhan.</a:t>
             </a:r>
             <a:endParaRPr lang="en-US" sz="3600" dirty="0"/>
           </a:p>
@@ -3227,7 +3227,7 @@
                 <a:ea typeface="Calibri" pitchFamily="34" charset="-122"/>
                 <a:cs typeface="Calibri" pitchFamily="34" charset="-120"/>
               </a:rPr>
-              <a:t>Catat berapa yang benar dan satu contoh yang gagal.</a:t>
+              <a:t>Teks komposisi yang salah di Validasi Produk dimasukkan ke data latih</a:t>
             </a:r>
             <a:endParaRPr lang="en-US" sz="2200" dirty="0"/>
           </a:p>
@@ -3244,7 +3244,7 @@
                 <a:ea typeface="Calibri" pitchFamily="34" charset="-122"/>
                 <a:cs typeface="Calibri" pitchFamily="34" charset="-120"/>
               </a:rPr>
-              <a:t>Angka itu mengisi bagian Validasi Produk.</a:t>
+              <a:t>Create ML PantanganText, lalu model dilatih ulang dan dicoba lagi.</a:t>
             </a:r>
             <a:endParaRPr lang="en-US" sz="2200" dirty="0"/>
           </a:p>
@@ -5044,12 +5044,12 @@
         </p:nvSpPr>
         <p:spPr>
           <a:xfrm>
-            <a:off x="502920" y="1143000"/>
-            <a:ext cx="5532120" cy="1920240"/>
+            <a:off x="502920" y="1051560"/>
+            <a:ext cx="5532120" cy="1481328"/>
           </a:xfrm>
           <a:prstGeom prst="roundRect">
             <a:avLst>
-              <a:gd name="adj" fmla="val 5714"/>
+              <a:gd name="adj" fmla="val 7407"/>
             </a:avLst>
           </a:prstGeom>
           <a:solidFill>
@@ -5066,8 +5066,8 @@
         </p:nvSpPr>
         <p:spPr>
           <a:xfrm>
-            <a:off x="777240" y="1399032"/>
-            <a:ext cx="4937760" cy="320040"/>
+            <a:off x="777240" y="1252728"/>
+            <a:ext cx="4983480" cy="292608"/>
           </a:xfrm>
           <a:prstGeom prst="rect">
             <a:avLst/>
@@ -5105,17 +5105,17 @@
         </p:nvSpPr>
         <p:spPr>
           <a:xfrm>
-            <a:off x="777240" y="1828800"/>
-            <a:ext cx="4937760" cy="960120"/>
-          </a:xfrm>
-          <a:prstGeom prst="rect">
-            <a:avLst/>
-          </a:prstGeom>
-          <a:noFill/>
-          <a:ln/>
-        </p:spPr>
-        <p:txBody>
-          <a:bodyPr wrap="square" lIns="0" tIns="0" rIns="0" bIns="0" rtlCol="0" anchor="ctr"/>
+            <a:off x="777240" y="1600200"/>
+            <a:ext cx="4983480" cy="777240"/>
+          </a:xfrm>
+          <a:prstGeom prst="rect">
+            <a:avLst/>
+          </a:prstGeom>
+          <a:noFill/>
+          <a:ln/>
+        </p:spPr>
+        <p:txBody>
+          <a:bodyPr wrap="square" lIns="0" tIns="0" rIns="0" bIns="0" rtlCol="0" anchor="t"/>
           <a:lstStyle/>
           <a:p>
             <a:pPr indent="0" marL="0">
@@ -5130,7 +5130,7 @@
                 <a:ea typeface="Calibri" pitchFamily="34" charset="-122"/>
                 <a:cs typeface="Calibri" pitchFamily="34" charset="-120"/>
               </a:rPr>
-              <a:t>User sudah tahu pantangan makannya, alergi atau yang sengaja dihindari.</a:t>
+              <a:t>Orang yang sudah tahu pantangan makannya, karena alergi atau sengaja dihindari.</a:t>
             </a:r>
             <a:endParaRPr lang="en-US" sz="1800" dirty="0"/>
           </a:p>
@@ -5144,12 +5144,12 @@
         </p:nvSpPr>
         <p:spPr>
           <a:xfrm>
-            <a:off x="6309360" y="1143000"/>
-            <a:ext cx="5532120" cy="1920240"/>
+            <a:off x="6309360" y="1051560"/>
+            <a:ext cx="5532120" cy="1481328"/>
           </a:xfrm>
           <a:prstGeom prst="roundRect">
             <a:avLst>
-              <a:gd name="adj" fmla="val 5714"/>
+              <a:gd name="adj" fmla="val 7407"/>
             </a:avLst>
           </a:prstGeom>
           <a:solidFill>
@@ -5166,8 +5166,8 @@
         </p:nvSpPr>
         <p:spPr>
           <a:xfrm>
-            <a:off x="6583680" y="1399032"/>
-            <a:ext cx="4937760" cy="320040"/>
+            <a:off x="6583680" y="1252728"/>
+            <a:ext cx="4983480" cy="292608"/>
           </a:xfrm>
           <a:prstGeom prst="rect">
             <a:avLst/>
@@ -5205,17 +5205,17 @@
         </p:nvSpPr>
         <p:spPr>
           <a:xfrm>
-            <a:off x="6583680" y="1828800"/>
-            <a:ext cx="4937760" cy="960120"/>
-          </a:xfrm>
-          <a:prstGeom prst="rect">
-            <a:avLst/>
-          </a:prstGeom>
-          <a:noFill/>
-          <a:ln/>
-        </p:spPr>
-        <p:txBody>
-          <a:bodyPr wrap="square" lIns="0" tIns="0" rIns="0" bIns="0" rtlCol="0" anchor="ctr"/>
+            <a:off x="6583680" y="1600200"/>
+            <a:ext cx="4983480" cy="777240"/>
+          </a:xfrm>
+          <a:prstGeom prst="rect">
+            <a:avLst/>
+          </a:prstGeom>
+          <a:noFill/>
+          <a:ln/>
+        </p:spPr>
+        <p:txBody>
+          <a:bodyPr wrap="square" lIns="0" tIns="0" rIns="0" bIns="0" rtlCol="0" anchor="t"/>
           <a:lstStyle/>
           <a:p>
             <a:pPr indent="0" marL="0">
@@ -5230,7 +5230,7 @@
                 <a:ea typeface="Calibri" pitchFamily="34" charset="-122"/>
                 <a:cs typeface="Calibri" pitchFamily="34" charset="-120"/>
               </a:rPr>
-              <a:t>Daftar komposisi di kemasan tertulis terlalu kecil, jadi bahan yang harus dihindari terlewat.</a:t>
+              <a:t>Huruf daftar komposisi di kemasan terlalu kecil, jadi bahan pantangan terlewat.</a:t>
             </a:r>
             <a:endParaRPr lang="en-US" sz="1800" dirty="0"/>
           </a:p>
@@ -5244,12 +5244,12 @@
         </p:nvSpPr>
         <p:spPr>
           <a:xfrm>
-            <a:off x="502920" y="3291840"/>
-            <a:ext cx="5532120" cy="1920240"/>
+            <a:off x="502920" y="2715768"/>
+            <a:ext cx="5532120" cy="1481328"/>
           </a:xfrm>
           <a:prstGeom prst="roundRect">
             <a:avLst>
-              <a:gd name="adj" fmla="val 5714"/>
+              <a:gd name="adj" fmla="val 7407"/>
             </a:avLst>
           </a:prstGeom>
           <a:solidFill>
@@ -5266,8 +5266,8 @@
         </p:nvSpPr>
         <p:spPr>
           <a:xfrm>
-            <a:off x="777240" y="3547872"/>
-            <a:ext cx="4937760" cy="320040"/>
+            <a:off x="777240" y="2916936"/>
+            <a:ext cx="4983480" cy="292608"/>
           </a:xfrm>
           <a:prstGeom prst="rect">
             <a:avLst/>
@@ -5305,17 +5305,17 @@
         </p:nvSpPr>
         <p:spPr>
           <a:xfrm>
-            <a:off x="777240" y="3977640"/>
-            <a:ext cx="4937760" cy="960120"/>
-          </a:xfrm>
-          <a:prstGeom prst="rect">
-            <a:avLst/>
-          </a:prstGeom>
-          <a:noFill/>
-          <a:ln/>
-        </p:spPr>
-        <p:txBody>
-          <a:bodyPr wrap="square" lIns="0" tIns="0" rIns="0" bIns="0" rtlCol="0" anchor="ctr"/>
+            <a:off x="777240" y="3264408"/>
+            <a:ext cx="4983480" cy="777240"/>
+          </a:xfrm>
+          <a:prstGeom prst="rect">
+            <a:avLst/>
+          </a:prstGeom>
+          <a:noFill/>
+          <a:ln/>
+        </p:spPr>
+        <p:txBody>
+          <a:bodyPr wrap="square" lIns="0" tIns="0" rIns="0" bIns="0" rtlCol="0" anchor="t"/>
           <a:lstStyle/>
           <a:p>
             <a:pPr indent="0" marL="0">
@@ -5330,7 +5330,7 @@
                 <a:ea typeface="Calibri" pitchFamily="34" charset="-122"/>
                 <a:cs typeface="Calibri" pitchFamily="34" charset="-120"/>
               </a:rPr>
-              <a:t>Masalah ini datang dari user.</a:t>
+              <a:t>Dari pengguna nyata yang punya pantangan. Ia harus membalik bungkus dan membaca komposisi satu per satu.</a:t>
             </a:r>
             <a:endParaRPr lang="en-US" sz="1800" dirty="0"/>
           </a:p>
@@ -5344,12 +5344,12 @@
         </p:nvSpPr>
         <p:spPr>
           <a:xfrm>
-            <a:off x="6309360" y="3291840"/>
-            <a:ext cx="5532120" cy="1920240"/>
+            <a:off x="6309360" y="2715768"/>
+            <a:ext cx="5532120" cy="1481328"/>
           </a:xfrm>
           <a:prstGeom prst="roundRect">
             <a:avLst>
-              <a:gd name="adj" fmla="val 5714"/>
+              <a:gd name="adj" fmla="val 7407"/>
             </a:avLst>
           </a:prstGeom>
           <a:solidFill>
@@ -5366,8 +5366,8 @@
         </p:nvSpPr>
         <p:spPr>
           <a:xfrm>
-            <a:off x="6583680" y="3547872"/>
-            <a:ext cx="4937760" cy="320040"/>
+            <a:off x="6583680" y="2916936"/>
+            <a:ext cx="4983480" cy="292608"/>
           </a:xfrm>
           <a:prstGeom prst="rect">
             <a:avLst/>
@@ -5391,7 +5391,7 @@
                 <a:ea typeface="Calibri" pitchFamily="34" charset="-122"/>
                 <a:cs typeface="Calibri" pitchFamily="34" charset="-120"/>
               </a:rPr>
-              <a:t>Dampak lain</a:t>
+              <a:t>Cara app menyelesaikannya</a:t>
             </a:r>
             <a:endParaRPr lang="en-US" sz="1300" dirty="0"/>
           </a:p>
@@ -5405,17 +5405,17 @@
         </p:nvSpPr>
         <p:spPr>
           <a:xfrm>
-            <a:off x="6583680" y="3977640"/>
-            <a:ext cx="4937760" cy="960120"/>
-          </a:xfrm>
-          <a:prstGeom prst="rect">
-            <a:avLst/>
-          </a:prstGeom>
-          <a:noFill/>
-          <a:ln/>
-        </p:spPr>
-        <p:txBody>
-          <a:bodyPr wrap="square" lIns="0" tIns="0" rIns="0" bIns="0" rtlCol="0" anchor="ctr"/>
+            <a:off x="6583680" y="3264408"/>
+            <a:ext cx="4983480" cy="777240"/>
+          </a:xfrm>
+          <a:prstGeom prst="rect">
+            <a:avLst/>
+          </a:prstGeom>
+          <a:noFill/>
+          <a:ln/>
+        </p:spPr>
+        <p:txBody>
+          <a:bodyPr wrap="square" lIns="0" tIns="0" rIns="0" bIns="0" rtlCol="0" anchor="t"/>
           <a:lstStyle/>
           <a:p>
             <a:pPr indent="0" marL="0">
@@ -5430,7 +5430,7 @@
                 <a:ea typeface="Calibri" pitchFamily="34" charset="-122"/>
                 <a:cs typeface="Calibri" pitchFamily="34" charset="-120"/>
               </a:rPr>
-              <a:t>Foto depan kemasan ditolak. App tidak menganggapnya aman atau tidak aman.</a:t>
+              <a:t>Pilih pantangan sekali, foto komposisi, lalu baca satu kalimat: aman atau tidak aman.</a:t>
             </a:r>
             <a:endParaRPr lang="en-US" sz="1800" dirty="0"/>
           </a:p>
@@ -5438,7 +5438,107 @@
       </p:sp>
       <p:sp>
         <p:nvSpPr>
-          <p:cNvPr id="15" name="Text 13"/>
+          <p:cNvPr id="15" name="Shape 13"/>
+          <p:cNvSpPr/>
+          <p:nvPr/>
+        </p:nvSpPr>
+        <p:spPr>
+          <a:xfrm>
+            <a:off x="502920" y="4379976"/>
+            <a:ext cx="11338560" cy="1481328"/>
+          </a:xfrm>
+          <a:prstGeom prst="roundRect">
+            <a:avLst>
+              <a:gd name="adj" fmla="val 7407"/>
+            </a:avLst>
+          </a:prstGeom>
+          <a:solidFill>
+            <a:srgbClr val="E3F5E8"/>
+          </a:solidFill>
+          <a:ln/>
+        </p:spPr>
+      </p:sp>
+      <p:sp>
+        <p:nvSpPr>
+          <p:cNvPr id="16" name="Text 14"/>
+          <p:cNvSpPr/>
+          <p:nvPr/>
+        </p:nvSpPr>
+        <p:spPr>
+          <a:xfrm>
+            <a:off x="777240" y="4581144"/>
+            <a:ext cx="10789920" cy="292608"/>
+          </a:xfrm>
+          <a:prstGeom prst="rect">
+            <a:avLst/>
+          </a:prstGeom>
+          <a:noFill/>
+          <a:ln/>
+        </p:spPr>
+        <p:txBody>
+          <a:bodyPr wrap="square" lIns="0" tIns="0" rIns="0" bIns="0" rtlCol="0" anchor="ctr"/>
+          <a:lstStyle/>
+          <a:p>
+            <a:pPr indent="0" marL="0">
+              <a:buNone/>
+            </a:pPr>
+            <a:r>
+              <a:rPr lang="en-US" sz="1300" dirty="0">
+                <a:solidFill>
+                  <a:srgbClr val="1E7345"/>
+                </a:solidFill>
+                <a:latin typeface="Calibri" pitchFamily="34" charset="0"/>
+                <a:ea typeface="Calibri" pitchFamily="34" charset="-122"/>
+                <a:cs typeface="Calibri" pitchFamily="34" charset="-120"/>
+              </a:rPr>
+              <a:t>Dampak lain</a:t>
+            </a:r>
+            <a:endParaRPr lang="en-US" sz="1300" dirty="0"/>
+          </a:p>
+        </p:txBody>
+      </p:sp>
+      <p:sp>
+        <p:nvSpPr>
+          <p:cNvPr id="17" name="Text 15"/>
+          <p:cNvSpPr/>
+          <p:nvPr/>
+        </p:nvSpPr>
+        <p:spPr>
+          <a:xfrm>
+            <a:off x="777240" y="4928616"/>
+            <a:ext cx="10789920" cy="777240"/>
+          </a:xfrm>
+          <a:prstGeom prst="rect">
+            <a:avLst/>
+          </a:prstGeom>
+          <a:noFill/>
+          <a:ln/>
+        </p:spPr>
+        <p:txBody>
+          <a:bodyPr wrap="square" lIns="0" tIns="0" rIns="0" bIns="0" rtlCol="0" anchor="t"/>
+          <a:lstStyle/>
+          <a:p>
+            <a:pPr indent="0" marL="0">
+              <a:buNone/>
+            </a:pPr>
+            <a:r>
+              <a:rPr lang="en-US" sz="1800" dirty="0">
+                <a:solidFill>
+                  <a:srgbClr val="1C1917"/>
+                </a:solidFill>
+                <a:latin typeface="Calibri" pitchFamily="34" charset="0"/>
+                <a:ea typeface="Calibri" pitchFamily="34" charset="-122"/>
+                <a:cs typeface="Calibri" pitchFamily="34" charset="-120"/>
+              </a:rPr>
+              <a:t>Nama bahan asing ikut dikenali. Arachis hypogaea terbaca sebagai kacang, jadi user tidak perlu hafal nama Latin atau Inggris.</a:t>
+            </a:r>
+            <a:endParaRPr lang="en-US" sz="1800" dirty="0"/>
+          </a:p>
+        </p:txBody>
+      </p:sp>
+      <p:sp>
+        <p:nvSpPr>
+          <p:cNvPr id="18" name="Text 16"/>
           <p:cNvSpPr/>
           <p:nvPr/>
         </p:nvSpPr>
@@ -5685,7 +5785,7 @@
         <p:spPr>
           <a:xfrm>
             <a:off x="457200" y="1097280"/>
-            <a:ext cx="2761488" cy="4160520"/>
+            <a:ext cx="2761488" cy="3931920"/>
           </a:xfrm>
           <a:prstGeom prst="roundRect">
             <a:avLst>
@@ -5770,7 +5870,7 @@
                 <a:ea typeface="Calibri" pitchFamily="34" charset="-122"/>
                 <a:cs typeface="Calibri" pitchFamily="34" charset="-120"/>
               </a:rPr>
-              <a:t>Membaca foto</a:t>
+              <a:t>Side-app  ·  baca teks dari foto</a:t>
             </a:r>
             <a:endParaRPr lang="en-US" sz="1200" dirty="0"/>
           </a:p>
@@ -5824,16 +5924,16 @@
         <p:spPr>
           <a:xfrm>
             <a:off x="658368" y="3108960"/>
-            <a:ext cx="2359152" cy="1874520"/>
-          </a:xfrm>
-          <a:prstGeom prst="rect">
-            <a:avLst/>
-          </a:prstGeom>
-          <a:noFill/>
-          <a:ln/>
-        </p:spPr>
-        <p:txBody>
-          <a:bodyPr wrap="square" lIns="0" tIns="0" rIns="0" bIns="0" rtlCol="0" anchor="ctr"/>
+            <a:ext cx="2359152" cy="1737360"/>
+          </a:xfrm>
+          <a:prstGeom prst="rect">
+            <a:avLst/>
+          </a:prstGeom>
+          <a:noFill/>
+          <a:ln/>
+        </p:spPr>
+        <p:txBody>
+          <a:bodyPr wrap="square" lIns="0" tIns="0" rIns="0" bIns="0" rtlCol="0" anchor="t"/>
           <a:lstStyle/>
           <a:p>
             <a:pPr indent="0" marL="0">
@@ -5863,7 +5963,7 @@
         <p:spPr>
           <a:xfrm>
             <a:off x="3383280" y="1097280"/>
-            <a:ext cx="2761488" cy="4160520"/>
+            <a:ext cx="2761488" cy="3931920"/>
           </a:xfrm>
           <a:prstGeom prst="roundRect">
             <a:avLst>
@@ -6002,16 +6102,16 @@
         <p:spPr>
           <a:xfrm>
             <a:off x="3584448" y="3108960"/>
-            <a:ext cx="2359152" cy="1874520"/>
-          </a:xfrm>
-          <a:prstGeom prst="rect">
-            <a:avLst/>
-          </a:prstGeom>
-          <a:noFill/>
-          <a:ln/>
-        </p:spPr>
-        <p:txBody>
-          <a:bodyPr wrap="square" lIns="0" tIns="0" rIns="0" bIns="0" rtlCol="0" anchor="ctr"/>
+            <a:ext cx="2359152" cy="1737360"/>
+          </a:xfrm>
+          <a:prstGeom prst="rect">
+            <a:avLst/>
+          </a:prstGeom>
+          <a:noFill/>
+          <a:ln/>
+        </p:spPr>
+        <p:txBody>
+          <a:bodyPr wrap="square" lIns="0" tIns="0" rIns="0" bIns="0" rtlCol="0" anchor="t"/>
           <a:lstStyle/>
           <a:p>
             <a:pPr indent="0" marL="0">
@@ -6026,7 +6126,7 @@
                 <a:ea typeface="Calibri" pitchFamily="34" charset="-122"/>
                 <a:cs typeface="Calibri" pitchFamily="34" charset="-120"/>
               </a:rPr>
-              <a:t>Model PantanganText mengklasifikasi teks komposisi di perangkat, lewat Core ML. Labelnya tidak tampil di layar.</a:t>
+              <a:t>Model PantanganText mengklasifikasi teks komposisi lewat Core ML. Labelnya tampil di layar hasil, misalnya kacang 92%.</a:t>
             </a:r>
             <a:endParaRPr lang="en-US" sz="1400" dirty="0"/>
           </a:p>
@@ -6041,7 +6141,7 @@
         <p:spPr>
           <a:xfrm>
             <a:off x="6309360" y="1097280"/>
-            <a:ext cx="2761488" cy="4160520"/>
+            <a:ext cx="2761488" cy="3931920"/>
           </a:xfrm>
           <a:prstGeom prst="roundRect">
             <a:avLst>
@@ -6180,16 +6280,16 @@
         <p:spPr>
           <a:xfrm>
             <a:off x="6510528" y="3108960"/>
-            <a:ext cx="2359152" cy="1874520"/>
-          </a:xfrm>
-          <a:prstGeom prst="rect">
-            <a:avLst/>
-          </a:prstGeom>
-          <a:noFill/>
-          <a:ln/>
-        </p:spPr>
-        <p:txBody>
-          <a:bodyPr wrap="square" lIns="0" tIns="0" rIns="0" bIns="0" rtlCol="0" anchor="ctr"/>
+            <a:ext cx="2359152" cy="1737360"/>
+          </a:xfrm>
+          <a:prstGeom prst="rect">
+            <a:avLst/>
+          </a:prstGeom>
+          <a:noFill/>
+          <a:ln/>
+        </p:spPr>
+        <p:txBody>
+          <a:bodyPr wrap="square" lIns="0" tIns="0" rIns="0" bIns="0" rtlCol="0" anchor="t"/>
           <a:lstStyle/>
           <a:p>
             <a:pPr indent="0" marL="0">
@@ -6204,7 +6304,7 @@
                 <a:ea typeface="Calibri" pitchFamily="34" charset="-122"/>
                 <a:cs typeface="Calibri" pitchFamily="34" charset="-120"/>
               </a:rPr>
-              <a:t>System Language Model, bawaan Apple Intelligence, menyusun kalimat. Hanya jalan kalau fiturnya menyala.</a:t>
+              <a:t>System Language Model bawaan Apple Intelligence menyusun kalimat aman atau tidak aman.</a:t>
             </a:r>
             <a:endParaRPr lang="en-US" sz="1400" dirty="0"/>
           </a:p>
@@ -6219,7 +6319,7 @@
         <p:spPr>
           <a:xfrm>
             <a:off x="9235440" y="1097280"/>
-            <a:ext cx="2761488" cy="4160520"/>
+            <a:ext cx="2761488" cy="3931920"/>
           </a:xfrm>
           <a:prstGeom prst="roundRect">
             <a:avLst>
@@ -6304,7 +6404,7 @@
                 <a:ea typeface="Calibri" pitchFamily="34" charset="-122"/>
                 <a:cs typeface="Calibri" pitchFamily="34" charset="-120"/>
               </a:rPr>
-              <a:t>Side-app</a:t>
+              <a:t>Side-app  ·  model di server</a:t>
             </a:r>
             <a:endParaRPr lang="en-US" sz="1200" dirty="0"/>
           </a:p>
@@ -6343,7 +6443,7 @@
                 <a:ea typeface="Georgia" pitchFamily="34" charset="-122"/>
                 <a:cs typeface="Georgia" pitchFamily="34" charset="-120"/>
               </a:rPr>
-              <a:t>Model di server</a:t>
+              <a:t>API Dicoding</a:t>
             </a:r>
             <a:endParaRPr lang="en-US" sz="2200" dirty="0"/>
           </a:p>
@@ -6358,16 +6458,16 @@
         <p:spPr>
           <a:xfrm>
             <a:off x="9436608" y="3108960"/>
-            <a:ext cx="2359152" cy="1874520"/>
-          </a:xfrm>
-          <a:prstGeom prst="rect">
-            <a:avLst/>
-          </a:prstGeom>
-          <a:noFill/>
-          <a:ln/>
-        </p:spPr>
-        <p:txBody>
-          <a:bodyPr wrap="square" lIns="0" tIns="0" rIns="0" bIns="0" rtlCol="0" anchor="ctr"/>
+            <a:ext cx="2359152" cy="1737360"/>
+          </a:xfrm>
+          <a:prstGeom prst="rect">
+            <a:avLst/>
+          </a:prstGeom>
+          <a:noFill/>
+          <a:ln/>
+        </p:spPr>
+        <p:txBody>
+          <a:bodyPr wrap="square" lIns="0" tIns="0" rIns="0" bIns="0" rtlCol="0" anchor="t"/>
           <a:lstStyle/>
           <a:p>
             <a:pPr indent="0" marL="0">
@@ -6382,7 +6482,7 @@
                 <a:ea typeface="Calibri" pitchFamily="34" charset="-122"/>
                 <a:cs typeface="Calibri" pitchFamily="34" charset="-120"/>
               </a:rPr>
-              <a:t>Kalau model Apple tidak tersedia, side-app menyusun kalimat yang sama. Kalau gagal, kalimat tetap keluar dari daftar kata.</a:t>
+              <a:t>Kalau model Apple tidak tersedia, gpt-oss-20b menyusun kalimat yang sama. Kalau internet mati, kalimat tetap keluar dan ada tombol Coba lagi.</a:t>
             </a:r>
             <a:endParaRPr lang="en-US" sz="1400" dirty="0"/>
           </a:p>

</xml_diff>

<commit_message>
Ganti kalimat 'aman' jadi laporan isi komposisi, rapikan kata-kata deck
</commit_message>
<xml_diff>
--- a/presentasi/PantangMakan.pptx
+++ b/presentasi/PantangMakan.pptx
@@ -602,7 +602,7 @@
           <a:p>
             <a:r>
               <a:rPr lang="en-US" dirty="0"/>
-              <a:t>Jangan mengarang angka. Evaluasi 10 foto belum dijalankan. Lesson learned yang boleh disebut: Foundation Models gagal di Simulator iOS 26, jalan di Simulator iOS 27.</a:t>
+              <a:t>Jangan mengarang angka. Evaluasi 10 foto belum dijalankan. Lesson learned: model bahasa kadang menambah kata sendiri, jadi kalimatnya dicek dulu.</a:t>
             </a:r>
             <a:endParaRPr lang="en-US" dirty="0"/>
           </a:p>
@@ -866,7 +866,7 @@
           <a:p>
             <a:r>
               <a:rPr lang="en-US" dirty="0"/>
-              <a:t>Satu kalimat penutup: kemasan yang salah kami masukkan ke data latih Create ML, lalu latih ulang. Sebut contoh gagal dari slide Validasi kalau sudah ada. Tidak ada slide penutup.</a:t>
+              <a:t>Satu kalimat penutup: nama bahan dari kemasan yang salah kami tambahkan ke daftar kata, lalu dicoba lagi. Sebut contoh gagal dari slide Validasi. Tidak ada slide penutup.</a:t>
             </a:r>
             <a:endParaRPr lang="en-US" dirty="0"/>
           </a:p>
@@ -1042,7 +1042,7 @@
           <a:p>
             <a:r>
               <a:rPr lang="en-US" dirty="0"/>
-              <a:t>Jangan isi pekerjaan atau peran kalau belum disepakati. Nanny dan sutrisno ada di Grup 6, jangan disebut sebagai anggota.</a:t>
+              <a:t>Jangan isi pekerjaan atau peran kalau belum disepakati.</a:t>
             </a:r>
             <a:endParaRPr lang="en-US" dirty="0"/>
           </a:p>
@@ -1130,7 +1130,7 @@
           <a:p>
             <a:r>
               <a:rPr lang="en-US" dirty="0"/>
-              <a:t>User sudah tahu pantangannya. Huruf di kemasan terlalu kecil, jadi bahan yang harus dihindari terlewat. Masalah ini dari user, bukan dari riset yang dikarang.</a:t>
+              <a:t>Mulai dari cerita satu orang sungguhan sebelum fitur. Sebut nama dan pantangannya, jangan dikarang.</a:t>
             </a:r>
             <a:endParaRPr lang="en-US" dirty="0"/>
           </a:p>
@@ -1394,7 +1394,7 @@
           <a:p>
             <a:r>
               <a:rPr lang="en-US" dirty="0"/>
-              <a:t>Urutan di app: foto, Vision membaca teks, Create ML memberi label (tampil di HASIL AI), Foundation Models menyusun kalimat; API Dicoding hanya kalau model Apple tidak ada. Warna kartu tetap dari daftar kata sesuai pantangan user. User pilih garam, kemasan tidak memuat garam: Aman, bisa kamu makan, tidak mengandung garam. Ada arachis dan user pilih kacang: Tidak aman, mengandung kacang. System Language Model hanya menyusun kalimat itu.</a:t>
+              <a:t>Urutan di app: foto, Vision membaca teks, Create ML memberi label yang tampil di HASIL AI, lalu Foundation Models menyusun kalimat. API Dicoding dipakai kalau model Apple tidak ada. Kalimat dari model dicek dulu; kalau tidak lolos, app memakai kalimat dari daftar kata. Contoh: pilih kacang, ada arachis di komposisi: Ada kacang di komposisi ini.</a:t>
             </a:r>
             <a:endParaRPr lang="en-US" dirty="0"/>
           </a:p>
@@ -2074,7 +2074,7 @@
                 <a:ea typeface="Calibri" pitchFamily="34" charset="-122"/>
                 <a:cs typeface="Calibri" pitchFamily="34" charset="-120"/>
               </a:rPr>
-              <a:t>Foto daftar komposisi. Satu kalimat: aman, atau tidak aman.</a:t>
+              <a:t>Foto komposisinya, langsung tahu ada pantanganmu atau tidak.</a:t>
             </a:r>
             <a:endParaRPr lang="en-US" sz="1800" dirty="0"/>
           </a:p>
@@ -2461,17 +2461,6 @@
             <a:pPr indent="0" marL="0">
               <a:buNone/>
             </a:pPr>
-            <a:r>
-              <a:rPr lang="en-US" sz="1400" dirty="0">
-                <a:solidFill>
-                  <a:srgbClr val="B85A3C"/>
-                </a:solidFill>
-                <a:latin typeface="Calibri" pitchFamily="34" charset="0"/>
-                <a:ea typeface="Calibri" pitchFamily="34" charset="-122"/>
-                <a:cs typeface="Calibri" pitchFamily="34" charset="-120"/>
-              </a:rPr>
-              <a:t>Isi: jumlah foto kemasan sungguhan</a:t>
-            </a:r>
             <a:endParaRPr lang="en-US" sz="1400" dirty="0"/>
           </a:p>
         </p:txBody>
@@ -2600,17 +2589,6 @@
             <a:pPr indent="0" marL="0">
               <a:buNone/>
             </a:pPr>
-            <a:r>
-              <a:rPr lang="en-US" sz="1400" dirty="0">
-                <a:solidFill>
-                  <a:srgbClr val="B85A3C"/>
-                </a:solidFill>
-                <a:latin typeface="Calibri" pitchFamily="34" charset="0"/>
-                <a:ea typeface="Calibri" pitchFamily="34" charset="-122"/>
-                <a:cs typeface="Calibri" pitchFamily="34" charset="-120"/>
-              </a:rPr>
-              <a:t>Isi: berapa yang kalimatnya benar</a:t>
-            </a:r>
             <a:endParaRPr lang="en-US" sz="1400" dirty="0"/>
           </a:p>
         </p:txBody>
@@ -2739,17 +2717,6 @@
             <a:pPr indent="0" marL="0">
               <a:buNone/>
             </a:pPr>
-            <a:r>
-              <a:rPr lang="en-US" sz="1400" dirty="0">
-                <a:solidFill>
-                  <a:srgbClr val="B85A3C"/>
-                </a:solidFill>
-                <a:latin typeface="Calibri" pitchFamily="34" charset="0"/>
-                <a:ea typeface="Calibri" pitchFamily="34" charset="-122"/>
-                <a:cs typeface="Calibri" pitchFamily="34" charset="-120"/>
-              </a:rPr>
-              <a:t>Isi: satu kemasan yang salah dan sebabnya</a:t>
-            </a:r>
             <a:endParaRPr lang="en-US" sz="1400" dirty="0"/>
           </a:p>
         </p:txBody>
@@ -2833,14 +2800,14 @@
           <a:ln/>
         </p:spPr>
         <p:txBody>
-          <a:bodyPr wrap="square" lIns="0" tIns="0" rIns="0" bIns="0" rtlCol="0" anchor="ctr"/>
+          <a:bodyPr wrap="square" lIns="0" tIns="0" rIns="0" bIns="0" rtlCol="0" anchor="t"/>
           <a:lstStyle/>
           <a:p>
             <a:pPr indent="0" marL="0">
               <a:buNone/>
             </a:pPr>
             <a:r>
-              <a:rPr lang="en-US" sz="2600" dirty="0">
+              <a:rPr lang="en-US" sz="2200" dirty="0">
                 <a:solidFill>
                   <a:srgbClr val="1C1917"/>
                 </a:solidFill>
@@ -2848,9 +2815,9 @@
                 <a:ea typeface="Georgia" pitchFamily="34" charset="-122"/>
                 <a:cs typeface="Georgia" pitchFamily="34" charset="-120"/>
               </a:rPr>
-              <a:t>Foundation Models selalu gagal di Simulator iOS 26. Di Simulator iOS 27, kalimatnya keluar.</a:t>
-            </a:r>
-            <a:endParaRPr lang="en-US" sz="2600" dirty="0"/>
+              <a:t>Model bahasa kadang menambah kata sendiri, misalnya “Fakta:” di depan kalimat. Karena itu kalimatnya dicek dulu, dan kalau tidak lolos, app memakai kalimat dari daftar kata.</a:t>
+            </a:r>
+            <a:endParaRPr lang="en-US" sz="2200" dirty="0"/>
           </a:p>
         </p:txBody>
       </p:sp>
@@ -3188,7 +3155,7 @@
                 <a:ea typeface="Georgia" pitchFamily="34" charset="-122"/>
                 <a:cs typeface="Georgia" pitchFamily="34" charset="-120"/>
               </a:rPr>
-              <a:t>Tambah data latih dari kemasan sungguhan.</a:t>
+              <a:t>Lengkapi daftar nama bahan.</a:t>
             </a:r>
             <a:endParaRPr lang="en-US" sz="3600" dirty="0"/>
           </a:p>
@@ -3227,7 +3194,7 @@
                 <a:ea typeface="Calibri" pitchFamily="34" charset="-122"/>
                 <a:cs typeface="Calibri" pitchFamily="34" charset="-120"/>
               </a:rPr>
-              <a:t>Teks komposisi yang salah di Validasi Produk dimasukkan ke data latih</a:t>
+              <a:t>Nama bahan dari kemasan yang salah dibaca di Validasi Produk</a:t>
             </a:r>
             <a:endParaRPr lang="en-US" sz="2200" dirty="0"/>
           </a:p>
@@ -3244,7 +3211,7 @@
                 <a:ea typeface="Calibri" pitchFamily="34" charset="-122"/>
                 <a:cs typeface="Calibri" pitchFamily="34" charset="-120"/>
               </a:rPr>
-              <a:t>Create ML PantanganText, lalu model dilatih ulang dan dicoba lagi.</a:t>
+              <a:t>ditambahkan ke daftar kata, lalu kemasan yang sama dicoba lagi.</a:t>
             </a:r>
             <a:endParaRPr lang="en-US" sz="2200" dirty="0"/>
           </a:p>
@@ -4765,45 +4732,6 @@
         </p:nvSpPr>
         <p:spPr>
           <a:xfrm>
-            <a:off x="502920" y="5532120"/>
-            <a:ext cx="10972800" cy="292608"/>
-          </a:xfrm>
-          <a:prstGeom prst="rect">
-            <a:avLst/>
-          </a:prstGeom>
-          <a:noFill/>
-          <a:ln/>
-        </p:spPr>
-        <p:txBody>
-          <a:bodyPr wrap="square" lIns="0" tIns="0" rIns="0" bIns="0" rtlCol="0" anchor="ctr"/>
-          <a:lstStyle/>
-          <a:p>
-            <a:pPr indent="0" marL="0">
-              <a:buNone/>
-            </a:pPr>
-            <a:r>
-              <a:rPr lang="en-US" sz="1400" dirty="0">
-                <a:solidFill>
-                  <a:srgbClr val="6B6560"/>
-                </a:solidFill>
-                <a:latin typeface="Calibri" pitchFamily="34" charset="0"/>
-                <a:ea typeface="Calibri" pitchFamily="34" charset="-122"/>
-                <a:cs typeface="Calibri" pitchFamily="34" charset="-120"/>
-              </a:rPr>
-              <a:t>Foto tim belum ada. Pekerjaan dan peran diisi setelah disepakati.</a:t>
-            </a:r>
-            <a:endParaRPr lang="en-US" sz="1400" dirty="0"/>
-          </a:p>
-        </p:txBody>
-      </p:sp>
-      <p:sp>
-        <p:nvSpPr>
-          <p:cNvPr id="5" name="Text 2"/>
-          <p:cNvSpPr/>
-          <p:nvPr/>
-        </p:nvSpPr>
-        <p:spPr>
-          <a:xfrm>
             <a:off x="502920" y="6510528"/>
             <a:ext cx="7315200" cy="219456"/>
           </a:xfrm>
@@ -5130,7 +5058,7 @@
                 <a:ea typeface="Calibri" pitchFamily="34" charset="-122"/>
                 <a:cs typeface="Calibri" pitchFamily="34" charset="-120"/>
               </a:rPr>
-              <a:t>Orang yang sudah tahu pantangan makannya, karena alergi atau sengaja dihindari.</a:t>
+              <a:t>Orang yang punya pantangan makan, karena alergi atau pilihan sendiri.</a:t>
             </a:r>
             <a:endParaRPr lang="en-US" sz="1800" dirty="0"/>
           </a:p>
@@ -5330,7 +5258,7 @@
                 <a:ea typeface="Calibri" pitchFamily="34" charset="-122"/>
                 <a:cs typeface="Calibri" pitchFamily="34" charset="-120"/>
               </a:rPr>
-              <a:t>Dari pengguna nyata yang punya pantangan. Ia harus membalik bungkus dan membaca komposisi satu per satu.</a:t>
+              <a:t>Dari pengguna yang punya pantangan: tiap belanja, ia membalik bungkus dan membaca huruf kecil satu per satu.</a:t>
             </a:r>
             <a:endParaRPr lang="en-US" sz="1800" dirty="0"/>
           </a:p>
@@ -5430,7 +5358,7 @@
                 <a:ea typeface="Calibri" pitchFamily="34" charset="-122"/>
                 <a:cs typeface="Calibri" pitchFamily="34" charset="-120"/>
               </a:rPr>
-              <a:t>Pilih pantangan sekali, foto komposisi, lalu baca satu kalimat: aman atau tidak aman.</a:t>
+              <a:t>Pilih pantangan sekali, foto komposisinya, lalu baca satu kalimat: ada pantanganmu atau tidak.</a:t>
             </a:r>
             <a:endParaRPr lang="en-US" sz="1800" dirty="0"/>
           </a:p>
@@ -5530,7 +5458,7 @@
                 <a:ea typeface="Calibri" pitchFamily="34" charset="-122"/>
                 <a:cs typeface="Calibri" pitchFamily="34" charset="-120"/>
               </a:rPr>
-              <a:t>Nama bahan asing ikut dikenali. Arachis hypogaea terbaca sebagai kacang, jadi user tidak perlu hafal nama Latin atau Inggris.</a:t>
+              <a:t>Nama bahan asing ikut dikenali. Arachis hypogaea terbaca sebagai kacang, jadi pengguna tidak perlu hafal nama Latin atau Inggrisnya.</a:t>
             </a:r>
             <a:endParaRPr lang="en-US" sz="1800" dirty="0"/>
           </a:p>
@@ -6126,7 +6054,7 @@
                 <a:ea typeface="Calibri" pitchFamily="34" charset="-122"/>
                 <a:cs typeface="Calibri" pitchFamily="34" charset="-120"/>
               </a:rPr>
-              <a:t>Model PantanganText mengklasifikasi teks komposisi lewat Core ML. Labelnya tampil di layar hasil, misalnya kacang 92%.</a:t>
+              <a:t>Model buatan kami menebak jenis pantangan dari teks komposisi. Hasilnya tampil di layar, misalnya kacang 92%.</a:t>
             </a:r>
             <a:endParaRPr lang="en-US" sz="1400" dirty="0"/>
           </a:p>
@@ -6304,7 +6232,7 @@
                 <a:ea typeface="Calibri" pitchFamily="34" charset="-122"/>
                 <a:cs typeface="Calibri" pitchFamily="34" charset="-120"/>
               </a:rPr>
-              <a:t>System Language Model bawaan Apple Intelligence menyusun kalimat aman atau tidak aman.</a:t>
+              <a:t>Model bahasa bawaan Apple Intelligence menyusun kalimat hasilnya, misalnya “Ada kacang di komposisi ini.”</a:t>
             </a:r>
             <a:endParaRPr lang="en-US" sz="1400" dirty="0"/>
           </a:p>
@@ -6482,7 +6410,7 @@
                 <a:ea typeface="Calibri" pitchFamily="34" charset="-122"/>
                 <a:cs typeface="Calibri" pitchFamily="34" charset="-120"/>
               </a:rPr>
-              <a:t>Kalau model Apple tidak tersedia, gpt-oss-20b menyusun kalimat yang sama. Kalau internet mati, kalimat tetap keluar dan ada tombol Coba lagi.</a:t>
+              <a:t>Kalau model Apple tidak tersedia, model di server Dicoding yang menyusun kalimatnya. Kalau internet mati, kalimat tetap keluar dan ada tombol Coba lagi.</a:t>
             </a:r>
             <a:endParaRPr lang="en-US" sz="1400" dirty="0"/>
           </a:p>
@@ -6521,7 +6449,7 @@
                 <a:ea typeface="Calibri" pitchFamily="34" charset="-122"/>
                 <a:cs typeface="Calibri" pitchFamily="34" charset="-120"/>
               </a:rPr>
-              <a:t>Keputusan kartu: daftar kata, sesuai pantangan yang user pilih.</a:t>
+              <a:t>Grup 5  ·  PantangMakan  ·  Jalur Tim</a:t>
             </a:r>
             <a:endParaRPr lang="en-US" sz="1100" dirty="0"/>
           </a:p>
@@ -6823,7 +6751,7 @@
                 <a:ea typeface="Calibri" pitchFamily="34" charset="-122"/>
                 <a:cs typeface="Calibri" pitchFamily="34" charset="-120"/>
               </a:rPr>
-              <a:t>Tidak aman, mengandung kacang dan pemanis.</a:t>
+              <a:t>Ada kacang dan pemanis.</a:t>
             </a:r>
             <a:endParaRPr lang="en-US" sz="1200" dirty="0"/>
           </a:p>
@@ -6831,7 +6759,7 @@
       </p:sp>
       <p:pic>
         <p:nvPicPr>
-          <p:cNvPr id="6" name="Image 1" descr="Foto kedua, app tetap terbuka">    </p:cNvPr>
+          <p:cNvPr id="6" name="Image 1" descr="Foto lagi tanpa menutup app">    </p:cNvPr>
           <p:cNvPicPr>
             <a:picLocks noChangeAspect="1"/>
           </p:cNvPicPr>
@@ -6885,7 +6813,7 @@
                 <a:ea typeface="Calibri" pitchFamily="34" charset="-122"/>
                 <a:cs typeface="Calibri" pitchFamily="34" charset="-120"/>
               </a:rPr>
-              <a:t>Foto kedua, app tetap terbuka</a:t>
+              <a:t>Foto lagi tanpa menutup app</a:t>
             </a:r>
             <a:endParaRPr lang="en-US" sz="1300" dirty="0"/>
           </a:p>
@@ -6924,7 +6852,7 @@
                 <a:ea typeface="Calibri" pitchFamily="34" charset="-122"/>
                 <a:cs typeface="Calibri" pitchFamily="34" charset="-120"/>
               </a:rPr>
-              <a:t>Aman, bisa kamu makan, tidak mengandung garam.</a:t>
+              <a:t>Tidak ditemukan garam.</a:t>
             </a:r>
             <a:endParaRPr lang="en-US" sz="1200" dirty="0"/>
           </a:p>
@@ -7025,7 +6953,7 @@
                 <a:ea typeface="Calibri" pitchFamily="34" charset="-122"/>
                 <a:cs typeface="Calibri" pitchFamily="34" charset="-120"/>
               </a:rPr>
-              <a:t>Ditolak. Gambar ini bukan daftar komposisi.</a:t>
+              <a:t>Ditolak, bukan daftar komposisi.</a:t>
             </a:r>
             <a:endParaRPr lang="en-US" sz="1200" dirty="0"/>
           </a:p>

</xml_diff>

<commit_message>
Tambah README, sinkronkan naskah tim dan BRIEF dengan app terbaru
</commit_message>
<xml_diff>
--- a/presentasi/PantangMakan.pptx
+++ b/presentasi/PantangMakan.pptx
@@ -1130,7 +1130,7 @@
           <a:p>
             <a:r>
               <a:rPr lang="en-US" dirty="0"/>
-              <a:t>Mulai dari cerita satu orang sungguhan sebelum fitur. Sebut nama dan pantangannya, jangan dikarang.</a:t>
+              <a:t>Mulai dari cerita satu pengguna sungguhan sebelum fitur. Sebut nama dan pantangannya, jangan dikarang.</a:t>
             </a:r>
             <a:endParaRPr lang="en-US" dirty="0"/>
           </a:p>
@@ -1218,7 +1218,7 @@
           <a:p>
             <a:r>
               <a:rPr lang="en-US" dirty="0"/>
-              <a:t>Buka dengan cerita satu orang sebelum fitur (syarat D4 Skilled). Sebut nama dan pantangan orang sungguhan yang kalian kenal, jangan dikarang. Contoh alur: dia di minimarket, membalik bungkus selai, huruf komposisinya kecil. Lalu: pilih pantangan sekali, foto, baca satu kalimat. Dampak lain: arachis hypogaea dikenali sebagai kacang.</a:t>
+              <a:t>Buka dengan cerita satu pengguna sebelum fitur (syarat D4 Skilled). Sebut nama dan pantangan pengguna sungguhan yang kalian kenal, jangan dikarang. Lalu: pilih pantangan sekali, foto, baca satu kalimat. Dampak lain: arachis hypogaea dikenali sebagai kacang.</a:t>
             </a:r>
             <a:endParaRPr lang="en-US" dirty="0"/>
           </a:p>
@@ -1570,7 +1570,7 @@
           <a:p>
             <a:r>
               <a:rPr lang="en-US" dirty="0"/>
-              <a:t>Di iPhone: pilih kacang dan pemanis, foto komposisi yang memuat kacang dan gula. Lalu Foto ulang pada teh, pantangan garam: kartu hijau. Terakhir foto depan kemasan: Ditolak. Izin kamera ditolak juga bisa ditunjukkan: pita kiri dan Buka Pengaturan.</a:t>
+              <a:t>Di iPhone: pilih kacang dan pemanis, foto komposisi yang memuat kacang dan gula. Lalu tekan Ubah, pilih garam, dan foto komposisi teh: kartu hijau. Terakhir foto depan kemasan: Ditolak. Izin kamera ditolak juga bisa ditunjukkan: pita kiri dan Buka Pengaturan.</a:t>
             </a:r>
             <a:endParaRPr lang="en-US" dirty="0"/>
           </a:p>
@@ -5058,7 +5058,7 @@
                 <a:ea typeface="Calibri" pitchFamily="34" charset="-122"/>
                 <a:cs typeface="Calibri" pitchFamily="34" charset="-120"/>
               </a:rPr>
-              <a:t>Orang yang punya pantangan makan, karena alergi atau pilihan sendiri.</a:t>
+              <a:t>Pengguna yang punya pantangan makan, karena alergi atau pilihan sendiri.</a:t>
             </a:r>
             <a:endParaRPr lang="en-US" sz="1800" dirty="0"/>
           </a:p>

</xml_diff>

<commit_message>
Validasi: 10 foto label Open Food Facts, 8 benar; isi slide Validasi dan Rencana
</commit_message>
<xml_diff>
--- a/presentasi/PantangMakan.pptx
+++ b/presentasi/PantangMakan.pptx
@@ -602,7 +602,7 @@
           <a:p>
             <a:r>
               <a:rPr lang="en-US" dirty="0"/>
-              <a:t>Jangan mengarang angka. Evaluasi 10 foto belum dijalankan. Lesson learned: model bahasa kadang menambah kata sendiri, jadi kalimatnya dicek dulu.</a:t>
+              <a:t>10 foto label sungguhan, 8 benar. Dua yang salah karena kalimat dapat mengandung ikut terbaca.</a:t>
             </a:r>
             <a:endParaRPr lang="en-US" dirty="0"/>
           </a:p>
@@ -690,7 +690,7 @@
           <a:p>
             <a:r>
               <a:rPr lang="en-US" dirty="0"/>
-              <a:t>Kalau 10 foto sudah dicoba sebelum naik, ganti angka di slide ini. Jangan isi angka yang belum dihitung.</a:t>
+              <a:t>Sumber foto: Open Food Facts, 10 produk Indonesia (Teh Pucuk, Ultra Milk, Oat M*lk, Indomie, Oreo, Energen, Superco, Choki Choki, Del Monte BBQ, Roma Kelapa). Detail di validasi/HASIL.md. Gagal kedua: Oat M*lk, kacang terbaca dari catatan peralatan produksi.</a:t>
             </a:r>
             <a:endParaRPr lang="en-US" dirty="0"/>
           </a:p>
@@ -866,7 +866,7 @@
           <a:p>
             <a:r>
               <a:rPr lang="en-US" dirty="0"/>
-              <a:t>Satu kalimat penutup: nama bahan dari kemasan yang salah kami tambahkan ke daftar kata, lalu dicoba lagi. Sebut contoh gagal dari slide Validasi. Tidak ada slide penutup.</a:t>
+              <a:t>Satu kalimat penutup: kalimat dapat mengandung kami pisahkan jadi peringatan, lalu dua kemasan yang gagal dicoba lagi. Tidak ada slide penutup.</a:t>
             </a:r>
             <a:endParaRPr lang="en-US" dirty="0"/>
           </a:p>
@@ -2431,7 +2431,7 @@
                 <a:ea typeface="Georgia" pitchFamily="34" charset="-122"/>
                 <a:cs typeface="Georgia" pitchFamily="34" charset="-120"/>
               </a:rPr>
-              <a:t>—</a:t>
+              <a:t>10 foto</a:t>
             </a:r>
             <a:endParaRPr lang="en-US" sz="3600" dirty="0"/>
           </a:p>
@@ -2445,23 +2445,34 @@
         </p:nvSpPr>
         <p:spPr>
           <a:xfrm>
-            <a:off x="758952" y="2606040"/>
-            <a:ext cx="3108960" cy="320040"/>
-          </a:xfrm>
-          <a:prstGeom prst="rect">
-            <a:avLst/>
-          </a:prstGeom>
-          <a:noFill/>
-          <a:ln/>
-        </p:spPr>
-        <p:txBody>
-          <a:bodyPr wrap="square" lIns="0" tIns="0" rIns="0" bIns="0" rtlCol="0" anchor="ctr"/>
+            <a:off x="758952" y="2514600"/>
+            <a:ext cx="3108960" cy="594360"/>
+          </a:xfrm>
+          <a:prstGeom prst="rect">
+            <a:avLst/>
+          </a:prstGeom>
+          <a:noFill/>
+          <a:ln/>
+        </p:spPr>
+        <p:txBody>
+          <a:bodyPr wrap="square" lIns="0" tIns="0" rIns="0" bIns="0" rtlCol="0" anchor="t"/>
           <a:lstStyle/>
           <a:p>
             <a:pPr indent="0" marL="0">
               <a:buNone/>
             </a:pPr>
-            <a:endParaRPr lang="en-US" sz="1400" dirty="0"/>
+            <a:r>
+              <a:rPr lang="en-US" sz="1300" dirty="0">
+                <a:solidFill>
+                  <a:srgbClr val="6B6560"/>
+                </a:solidFill>
+                <a:latin typeface="Calibri" pitchFamily="34" charset="0"/>
+                <a:ea typeface="Calibri" pitchFamily="34" charset="-122"/>
+                <a:cs typeface="Calibri" pitchFamily="34" charset="-120"/>
+              </a:rPr>
+              <a:t>Label komposisi produk Indonesia, enam pantangan dipilih</a:t>
+            </a:r>
+            <a:endParaRPr lang="en-US" sz="1300" dirty="0"/>
           </a:p>
         </p:txBody>
       </p:sp>
@@ -2559,7 +2570,7 @@
                 <a:ea typeface="Georgia" pitchFamily="34" charset="-122"/>
                 <a:cs typeface="Georgia" pitchFamily="34" charset="-120"/>
               </a:rPr>
-              <a:t>—</a:t>
+              <a:t>8 dari 10</a:t>
             </a:r>
             <a:endParaRPr lang="en-US" sz="3600" dirty="0"/>
           </a:p>
@@ -2573,23 +2584,34 @@
         </p:nvSpPr>
         <p:spPr>
           <a:xfrm>
-            <a:off x="4599432" y="2606040"/>
-            <a:ext cx="3108960" cy="320040"/>
-          </a:xfrm>
-          <a:prstGeom prst="rect">
-            <a:avLst/>
-          </a:prstGeom>
-          <a:noFill/>
-          <a:ln/>
-        </p:spPr>
-        <p:txBody>
-          <a:bodyPr wrap="square" lIns="0" tIns="0" rIns="0" bIns="0" rtlCol="0" anchor="ctr"/>
+            <a:off x="4599432" y="2514600"/>
+            <a:ext cx="3108960" cy="594360"/>
+          </a:xfrm>
+          <a:prstGeom prst="rect">
+            <a:avLst/>
+          </a:prstGeom>
+          <a:noFill/>
+          <a:ln/>
+        </p:spPr>
+        <p:txBody>
+          <a:bodyPr wrap="square" lIns="0" tIns="0" rIns="0" bIns="0" rtlCol="0" anchor="t"/>
           <a:lstStyle/>
           <a:p>
             <a:pPr indent="0" marL="0">
               <a:buNone/>
             </a:pPr>
-            <a:endParaRPr lang="en-US" sz="1400" dirty="0"/>
+            <a:r>
+              <a:rPr lang="en-US" sz="1300" dirty="0">
+                <a:solidFill>
+                  <a:srgbClr val="6B6560"/>
+                </a:solidFill>
+                <a:latin typeface="Calibri" pitchFamily="34" charset="0"/>
+                <a:ea typeface="Calibri" pitchFamily="34" charset="-122"/>
+                <a:cs typeface="Calibri" pitchFamily="34" charset="-120"/>
+              </a:rPr>
+              <a:t>Pantangan yang disebut sama dengan isi label</a:t>
+            </a:r>
+            <a:endParaRPr lang="en-US" sz="1300" dirty="0"/>
           </a:p>
         </p:txBody>
       </p:sp>
@@ -2687,7 +2709,7 @@
                 <a:ea typeface="Georgia" pitchFamily="34" charset="-122"/>
                 <a:cs typeface="Georgia" pitchFamily="34" charset="-120"/>
               </a:rPr>
-              <a:t>—</a:t>
+              <a:t>Superco</a:t>
             </a:r>
             <a:endParaRPr lang="en-US" sz="3600" dirty="0"/>
           </a:p>
@@ -2701,23 +2723,34 @@
         </p:nvSpPr>
         <p:spPr>
           <a:xfrm>
-            <a:off x="8439912" y="2606040"/>
-            <a:ext cx="3108960" cy="320040"/>
-          </a:xfrm>
-          <a:prstGeom prst="rect">
-            <a:avLst/>
-          </a:prstGeom>
-          <a:noFill/>
-          <a:ln/>
-        </p:spPr>
-        <p:txBody>
-          <a:bodyPr wrap="square" lIns="0" tIns="0" rIns="0" bIns="0" rtlCol="0" anchor="ctr"/>
+            <a:off x="8439912" y="2514600"/>
+            <a:ext cx="3108960" cy="594360"/>
+          </a:xfrm>
+          <a:prstGeom prst="rect">
+            <a:avLst/>
+          </a:prstGeom>
+          <a:noFill/>
+          <a:ln/>
+        </p:spPr>
+        <p:txBody>
+          <a:bodyPr wrap="square" lIns="0" tIns="0" rIns="0" bIns="0" rtlCol="0" anchor="t"/>
           <a:lstStyle/>
           <a:p>
             <a:pPr indent="0" marL="0">
               <a:buNone/>
             </a:pPr>
-            <a:endParaRPr lang="en-US" sz="1400" dirty="0"/>
+            <a:r>
+              <a:rPr lang="en-US" sz="1300" dirty="0">
+                <a:solidFill>
+                  <a:srgbClr val="6B6560"/>
+                </a:solidFill>
+                <a:latin typeface="Calibri" pitchFamily="34" charset="0"/>
+                <a:ea typeface="Calibri" pitchFamily="34" charset="-122"/>
+                <a:cs typeface="Calibri" pitchFamily="34" charset="-120"/>
+              </a:rPr>
+              <a:t>“Dapat mengandung telur dan kacang” dihitung sebagai bahan</a:t>
+            </a:r>
+            <a:endParaRPr lang="en-US" sz="1300" dirty="0"/>
           </a:p>
         </p:txBody>
       </p:sp>
@@ -2791,7 +2824,7 @@
         <p:spPr>
           <a:xfrm>
             <a:off x="777240" y="4206240"/>
-            <a:ext cx="10515600" cy="1097280"/>
+            <a:ext cx="6949440" cy="1371600"/>
           </a:xfrm>
           <a:prstGeom prst="rect">
             <a:avLst/>
@@ -2807,7 +2840,7 @@
               <a:buNone/>
             </a:pPr>
             <a:r>
-              <a:rPr lang="en-US" sz="2200" dirty="0">
+              <a:rPr lang="en-US" sz="2000" dirty="0">
                 <a:solidFill>
                   <a:srgbClr val="1C1917"/>
                 </a:solidFill>
@@ -2815,15 +2848,77 @@
                 <a:ea typeface="Georgia" pitchFamily="34" charset="-122"/>
                 <a:cs typeface="Georgia" pitchFamily="34" charset="-120"/>
               </a:rPr>
-              <a:t>Model bahasa kadang menambah kata sendiri, misalnya “Fakta:” di depan kalimat. Karena itu kalimatnya dicek dulu, dan kalau tidak lolos, app memakai kalimat dari daftar kata.</a:t>
-            </a:r>
-            <a:endParaRPr lang="en-US" sz="2200" dirty="0"/>
-          </a:p>
-        </p:txBody>
-      </p:sp>
-      <p:sp>
-        <p:nvSpPr>
-          <p:cNvPr id="18" name="Text 16"/>
+              <a:t>Kedua kegagalan punya sebab yang sama: kalimat peringatan di bawah komposisi, seperti “dapat mengandung” atau “diproses dengan peralatan yang juga memproses kacang”, ikut terbaca sebagai bahan.</a:t>
+            </a:r>
+            <a:endParaRPr lang="en-US" sz="2000" dirty="0"/>
+          </a:p>
+        </p:txBody>
+      </p:sp>
+      <p:pic>
+        <p:nvPicPr>
+          <p:cNvPr id="18" name="Image 0" descr="Label komposisi Superco dengan kalimat Dapat mengandung telur, kedelai dan kacang">    </p:cNvPr>
+          <p:cNvPicPr>
+            <a:picLocks noChangeAspect="1"/>
+          </p:cNvPicPr>
+          <p:nvPr/>
+        </p:nvPicPr>
+        <p:blipFill>
+          <a:blip r:embed="rId1"/>
+          <a:srcRect l="0" r="0" t="0" b="0"/>
+          <a:stretch/>
+        </p:blipFill>
+        <p:spPr>
+          <a:xfrm>
+            <a:off x="8092440" y="3749040"/>
+            <a:ext cx="2743200" cy="1783080"/>
+          </a:xfrm>
+          <a:prstGeom prst="rect">
+            <a:avLst/>
+          </a:prstGeom>
+        </p:spPr>
+      </p:pic>
+      <p:sp>
+        <p:nvSpPr>
+          <p:cNvPr id="19" name="Text 16"/>
+          <p:cNvSpPr/>
+          <p:nvPr/>
+        </p:nvSpPr>
+        <p:spPr>
+          <a:xfrm>
+            <a:off x="8092440" y="5559552"/>
+            <a:ext cx="2743200" cy="182880"/>
+          </a:xfrm>
+          <a:prstGeom prst="rect">
+            <a:avLst/>
+          </a:prstGeom>
+          <a:noFill/>
+          <a:ln/>
+        </p:spPr>
+        <p:txBody>
+          <a:bodyPr wrap="square" lIns="0" tIns="0" rIns="0" bIns="0" rtlCol="0" anchor="ctr"/>
+          <a:lstStyle/>
+          <a:p>
+            <a:pPr algn="r" indent="0" marL="0">
+              <a:buNone/>
+            </a:pPr>
+            <a:r>
+              <a:rPr lang="en-US" sz="900" dirty="0">
+                <a:solidFill>
+                  <a:srgbClr val="6B6560"/>
+                </a:solidFill>
+                <a:latin typeface="Calibri" pitchFamily="34" charset="0"/>
+                <a:ea typeface="Calibri" pitchFamily="34" charset="-122"/>
+                <a:cs typeface="Calibri" pitchFamily="34" charset="-120"/>
+              </a:rPr>
+              <a:t>Foto: Open Food Facts</a:t>
+            </a:r>
+            <a:endParaRPr lang="en-US" sz="900" dirty="0"/>
+          </a:p>
+        </p:txBody>
+      </p:sp>
+      <p:sp>
+        <p:nvSpPr>
+          <p:cNvPr id="20" name="Text 17"/>
           <p:cNvSpPr/>
           <p:nvPr/>
         </p:nvSpPr>
@@ -3155,7 +3250,7 @@
                 <a:ea typeface="Georgia" pitchFamily="34" charset="-122"/>
                 <a:cs typeface="Georgia" pitchFamily="34" charset="-120"/>
               </a:rPr>
-              <a:t>Lengkapi daftar nama bahan.</a:t>
+              <a:t>Pisahkan kalimat “dapat mengandung”.</a:t>
             </a:r>
             <a:endParaRPr lang="en-US" sz="3600" dirty="0"/>
           </a:p>
@@ -3194,7 +3289,7 @@
                 <a:ea typeface="Calibri" pitchFamily="34" charset="-122"/>
                 <a:cs typeface="Calibri" pitchFamily="34" charset="-120"/>
               </a:rPr>
-              <a:t>Nama bahan dari kemasan yang salah dibaca di Validasi Produk</a:t>
+              <a:t>Bahan di daftar komposisi tetap jadi kartu merah. Kalimat “dapat mengandung”</a:t>
             </a:r>
             <a:endParaRPr lang="en-US" sz="2200" dirty="0"/>
           </a:p>
@@ -3211,7 +3306,7 @@
                 <a:ea typeface="Calibri" pitchFamily="34" charset="-122"/>
                 <a:cs typeface="Calibri" pitchFamily="34" charset="-120"/>
               </a:rPr>
-              <a:t>ditambahkan ke daftar kata, lalu kemasan yang sama dicoba lagi.</a:t>
+              <a:t>jadi peringatan terpisah, lalu Superco dan Oat M*lk dicoba lagi.</a:t>
             </a:r>
             <a:endParaRPr lang="en-US" sz="2200" dirty="0"/>
           </a:p>

</xml_diff>

<commit_message>
Deck dirombak (visual, validasi 8→10, rencana uji kamera), README/BRIEF/naskah sesuai alur baru
</commit_message>
<xml_diff>
--- a/presentasi/PantangMakan.pptx
+++ b/presentasi/PantangMakan.pptx
@@ -514,7 +514,7 @@
           <a:p>
             <a:r>
               <a:rPr lang="en-US" dirty="0"/>
-              <a:t>Sampul. Sebut nama app, jalur tim, dan lima nama Grup 5. Langsung ke masalah. Jangan perkenalan panjang.</a:t>
+              <a:t>Sebut nama app, jalur tim, dan lima nama Grup 5. Langsung ke cerita pengguna.</a:t>
             </a:r>
             <a:endParaRPr lang="en-US" dirty="0"/>
           </a:p>
@@ -602,7 +602,7 @@
           <a:p>
             <a:r>
               <a:rPr lang="en-US" dirty="0"/>
-              <a:t>10 foto label sungguhan, 8 benar. Dua yang salah karena kalimat dapat mengandung ikut terbaca.</a:t>
+              <a:t>10 foto dari Open Food Facts, tidak ikut data latih. Detail di validasi/HASIL.md.</a:t>
             </a:r>
             <a:endParaRPr lang="en-US" dirty="0"/>
           </a:p>
@@ -690,7 +690,7 @@
           <a:p>
             <a:r>
               <a:rPr lang="en-US" dirty="0"/>
-              <a:t>Sumber foto: Open Food Facts, 10 produk Indonesia (Teh Pucuk, Ultra Milk, Oat M*lk, Indomie, Oreo, Energen, Superco, Choki Choki, Del Monte BBQ, Roma Kelapa). Detail di validasi/HASIL.md. Gagal kedua: Oat M*lk, kacang terbaca dari catatan peralatan produksi.</a:t>
+              <a:t>Gagal kedua di versi lama: Oat M*lk, kacang terbaca dari catatan peralatan produksi. Batasnya: hanya 10 foto, dan bukan dari kamera app.</a:t>
             </a:r>
             <a:endParaRPr lang="en-US" dirty="0"/>
           </a:p>
@@ -778,7 +778,7 @@
           <a:p>
             <a:r>
               <a:rPr lang="en-US" dirty="0"/>
-              <a:t>Satu langkah berikutnya saja. Jangan bahas bisnis atau pasar.</a:t>
+              <a:t>Satu langkah saja. Jangan bahas bisnis atau pasar.</a:t>
             </a:r>
             <a:endParaRPr lang="en-US" dirty="0"/>
           </a:p>
@@ -866,7 +866,7 @@
           <a:p>
             <a:r>
               <a:rPr lang="en-US" dirty="0"/>
-              <a:t>Satu kalimat penutup: kalimat dapat mengandung kami pisahkan jadi peringatan, lalu dua kemasan yang gagal dicoba lagi. Tidak ada slide penutup.</a:t>
+              <a:t>Penutup satu kalimat: berikutnya kami uji 30 kemasan dari kamera iPhone sendiri, lalu kalimat yang salah masuk ke data latih. Tidak ada slide penutup.</a:t>
             </a:r>
             <a:endParaRPr lang="en-US" dirty="0"/>
           </a:p>
@@ -954,7 +954,7 @@
           <a:p>
             <a:r>
               <a:rPr lang="en-US" dirty="0"/>
-              <a:t>Bagian ini tidak dinilai. Sebut nama saja. Pekerjaan dan peran masih kosong, jangan mengarang.</a:t>
+              <a:t>Bagian ini tidak dinilai. Sebut nama saja.</a:t>
             </a:r>
             <a:endParaRPr lang="en-US" dirty="0"/>
           </a:p>
@@ -1042,7 +1042,7 @@
           <a:p>
             <a:r>
               <a:rPr lang="en-US" dirty="0"/>
-              <a:t>Jangan isi pekerjaan atau peran kalau belum disepakati.</a:t>
+              <a:t>Isi pekerjaan dan peran sesuai kesepakatan grup, lalu tempel foto tim di kotak kanan.</a:t>
             </a:r>
             <a:endParaRPr lang="en-US" dirty="0"/>
           </a:p>
@@ -1218,7 +1218,7 @@
           <a:p>
             <a:r>
               <a:rPr lang="en-US" dirty="0"/>
-              <a:t>Buka dengan cerita satu pengguna sebelum fitur (syarat D4 Skilled). Sebut nama dan pantangan pengguna sungguhan yang kalian kenal, jangan dikarang. Lalu: pilih pantangan sekali, foto, baca satu kalimat. Dampak lain: arachis hypogaea dikenali sebagai kacang.</a:t>
+              <a:t>Dampak lain: pengguna bisa membedakan bahan dan kemungkinan sisa produksi. Nama Latin seperti arachis hypogaea dikenali sebagai kacang.</a:t>
             </a:r>
             <a:endParaRPr lang="en-US" dirty="0"/>
           </a:p>
@@ -1306,7 +1306,7 @@
           <a:p>
             <a:r>
               <a:rPr lang="en-US" dirty="0"/>
-              <a:t>Sebut kelompoknya: dua diajarkan (Create ML, Foundation Models) dan dua side-app (baca teks dari foto, API). Jangan bilang semuanya on-device. Di layar hasil, tunjuk bagian HASIL AI.</a:t>
+              <a:t>Dua fitur diajarkan (Create ML, Foundation Models) dan satu dari side-app (baca teks dari foto). Semuanya jalan di perangkat.</a:t>
             </a:r>
             <a:endParaRPr lang="en-US" dirty="0"/>
           </a:p>
@@ -1394,7 +1394,7 @@
           <a:p>
             <a:r>
               <a:rPr lang="en-US" dirty="0"/>
-              <a:t>Urutan di app: foto, Vision membaca teks, Create ML memberi label yang tampil di HASIL AI, lalu Foundation Models menyusun kalimat. API Dicoding dipakai kalau model Apple tidak ada. Kalimat dari model dicek dulu; kalau tidak lolos, app memakai kalimat dari daftar kata. Contoh: pilih kacang, ada arachis di komposisi: Ada kacang di komposisi ini.</a:t>
+              <a:t>Urutan: foto, Vision membaca teks, Create ML memilah kalimat, daftar kata mencocokkan pantangan di kalimat bahan, Foundation Models menjelaskan. Tunjuk bagian HASIL AI saat demo.</a:t>
             </a:r>
             <a:endParaRPr lang="en-US" dirty="0"/>
           </a:p>
@@ -1482,7 +1482,7 @@
           <a:p>
             <a:r>
               <a:rPr lang="en-US" dirty="0"/>
-              <a:t>Saat bagian ini, pindah ke iPhone. Urutan: happy path merah, foto ulang jadi hijau, lalu foto yang bukan komposisi ditolak. Jangan tutup app di antara foto pertama dan kedua.</a:t>
+              <a:t>Pindah ke iPhone. Urutan: kacang dan pemanis jadi merah; Ubah ke garam, foto teh jadi hijau; foto wafer dengan dapat mengandung; foto depan kemasan ditolak.</a:t>
             </a:r>
             <a:endParaRPr lang="en-US" dirty="0"/>
           </a:p>
@@ -1570,7 +1570,7 @@
           <a:p>
             <a:r>
               <a:rPr lang="en-US" dirty="0"/>
-              <a:t>Di iPhone: pilih kacang dan pemanis, foto komposisi yang memuat kacang dan gula. Lalu tekan Ubah, pilih garam, dan foto komposisi teh: kartu hijau. Terakhir foto depan kemasan: Ditolak. Izin kamera ditolak juga bisa ditunjukkan: pita kiri dan Buka Pengaturan.</a:t>
+              <a:t>Cadangan unhappy path: izin kamera ditolak, muncul pesan dan tombol Buka Pengaturan.</a:t>
             </a:r>
             <a:endParaRPr lang="en-US" dirty="0"/>
           </a:p>
@@ -1972,7 +1972,7 @@
         <p:spPr>
           <a:xfrm>
             <a:off x="777240" y="1554480"/>
-            <a:ext cx="9144000" cy="320040"/>
+            <a:ext cx="6400800" cy="320040"/>
           </a:xfrm>
           <a:prstGeom prst="rect">
             <a:avLst/>
@@ -2011,7 +2011,7 @@
         <p:spPr>
           <a:xfrm>
             <a:off x="777240" y="1965960"/>
-            <a:ext cx="10058400" cy="960120"/>
+            <a:ext cx="6400800" cy="960120"/>
           </a:xfrm>
           <a:prstGeom prst="rect">
             <a:avLst/>
@@ -2050,23 +2050,23 @@
         <p:spPr>
           <a:xfrm>
             <a:off x="777240" y="3063240"/>
-            <a:ext cx="9144000" cy="365760"/>
-          </a:xfrm>
-          <a:prstGeom prst="rect">
-            <a:avLst/>
-          </a:prstGeom>
-          <a:noFill/>
-          <a:ln/>
-        </p:spPr>
-        <p:txBody>
-          <a:bodyPr wrap="square" lIns="0" tIns="0" rIns="0" bIns="0" rtlCol="0" anchor="ctr"/>
+            <a:ext cx="5943600" cy="731520"/>
+          </a:xfrm>
+          <a:prstGeom prst="rect">
+            <a:avLst/>
+          </a:prstGeom>
+          <a:noFill/>
+          <a:ln/>
+        </p:spPr>
+        <p:txBody>
+          <a:bodyPr wrap="square" lIns="0" tIns="0" rIns="0" bIns="0" rtlCol="0" anchor="t"/>
           <a:lstStyle/>
           <a:p>
             <a:pPr indent="0" marL="0">
               <a:buNone/>
             </a:pPr>
             <a:r>
-              <a:rPr lang="en-US" sz="1800" dirty="0">
+              <a:rPr lang="en-US" sz="2000" dirty="0">
                 <a:solidFill>
                   <a:srgbClr val="6B6560"/>
                 </a:solidFill>
@@ -2076,7 +2076,7 @@
               </a:rPr>
               <a:t>Foto komposisinya, langsung tahu ada pantanganmu atau tidak.</a:t>
             </a:r>
-            <a:endParaRPr lang="en-US" sz="1800" dirty="0"/>
+            <a:endParaRPr lang="en-US" sz="2000" dirty="0"/>
           </a:p>
         </p:txBody>
       </p:sp>
@@ -2088,24 +2088,27 @@
         </p:nvSpPr>
         <p:spPr>
           <a:xfrm>
-            <a:off x="777240" y="4114800"/>
-            <a:ext cx="10058400" cy="731520"/>
-          </a:xfrm>
-          <a:prstGeom prst="rect">
-            <a:avLst/>
-          </a:prstGeom>
-          <a:noFill/>
-          <a:ln/>
-        </p:spPr>
-        <p:txBody>
-          <a:bodyPr wrap="square" lIns="0" tIns="0" rIns="0" bIns="0" rtlCol="0" anchor="ctr"/>
+            <a:off x="777240" y="4160520"/>
+            <a:ext cx="5486400" cy="1737360"/>
+          </a:xfrm>
+          <a:prstGeom prst="rect">
+            <a:avLst/>
+          </a:prstGeom>
+          <a:noFill/>
+          <a:ln/>
+        </p:spPr>
+        <p:txBody>
+          <a:bodyPr wrap="square" lIns="0" tIns="0" rIns="0" bIns="0" rtlCol="0" anchor="t"/>
           <a:lstStyle/>
           <a:p>
             <a:pPr indent="0" marL="0">
-              <a:buNone/>
-            </a:pPr>
-            <a:r>
-              <a:rPr lang="en-US" sz="1600" dirty="0">
+              <a:spcAft>
+                <a:spcPts val="300"/>
+              </a:spcAft>
+              <a:buNone/>
+            </a:pPr>
+            <a:r>
+              <a:rPr lang="en-US" sz="1500" dirty="0">
                 <a:solidFill>
                   <a:srgbClr val="1C1917"/>
                 </a:solidFill>
@@ -2113,16 +2116,19 @@
                 <a:ea typeface="Calibri" pitchFamily="34" charset="-122"/>
                 <a:cs typeface="Calibri" pitchFamily="34" charset="-120"/>
               </a:rPr>
-              <a:t>Muhammad Fajar Wira Azdi    ·    Ahmad Syafiq Kamil    ·    Dendy Ramdhan Fauzy</a:t>
-            </a:r>
-            <a:endParaRPr lang="en-US" sz="1600" dirty="0"/>
+              <a:t>Muhammad Fajar Wira Azdi</a:t>
+            </a:r>
+            <a:endParaRPr lang="en-US" sz="1500" dirty="0"/>
           </a:p>
           <a:p>
             <a:pPr indent="0" marL="0">
-              <a:buNone/>
-            </a:pPr>
-            <a:r>
-              <a:rPr lang="en-US" sz="1600" dirty="0">
+              <a:spcAft>
+                <a:spcPts val="300"/>
+              </a:spcAft>
+              <a:buNone/>
+            </a:pPr>
+            <a:r>
+              <a:rPr lang="en-US" sz="1500" dirty="0">
                 <a:solidFill>
                   <a:srgbClr val="1C1917"/>
                 </a:solidFill>
@@ -2130,11 +2136,119 @@
                 <a:ea typeface="Calibri" pitchFamily="34" charset="-122"/>
                 <a:cs typeface="Calibri" pitchFamily="34" charset="-120"/>
               </a:rPr>
-              <a:t>Mohamad Arrizal    ·    Zuber Khatib</a:t>
-            </a:r>
-            <a:endParaRPr lang="en-US" sz="1600" dirty="0"/>
-          </a:p>
-        </p:txBody>
+              <a:t>Ahmad Syafiq Kamil</a:t>
+            </a:r>
+            <a:endParaRPr lang="en-US" sz="1500" dirty="0"/>
+          </a:p>
+          <a:p>
+            <a:pPr indent="0" marL="0">
+              <a:spcAft>
+                <a:spcPts val="300"/>
+              </a:spcAft>
+              <a:buNone/>
+            </a:pPr>
+            <a:r>
+              <a:rPr lang="en-US" sz="1500" dirty="0">
+                <a:solidFill>
+                  <a:srgbClr val="1C1917"/>
+                </a:solidFill>
+                <a:latin typeface="Calibri" pitchFamily="34" charset="0"/>
+                <a:ea typeface="Calibri" pitchFamily="34" charset="-122"/>
+                <a:cs typeface="Calibri" pitchFamily="34" charset="-120"/>
+              </a:rPr>
+              <a:t>Dendy Ramdhan Fauzy</a:t>
+            </a:r>
+            <a:endParaRPr lang="en-US" sz="1500" dirty="0"/>
+          </a:p>
+          <a:p>
+            <a:pPr indent="0" marL="0">
+              <a:spcAft>
+                <a:spcPts val="300"/>
+              </a:spcAft>
+              <a:buNone/>
+            </a:pPr>
+            <a:r>
+              <a:rPr lang="en-US" sz="1500" dirty="0">
+                <a:solidFill>
+                  <a:srgbClr val="1C1917"/>
+                </a:solidFill>
+                <a:latin typeface="Calibri" pitchFamily="34" charset="0"/>
+                <a:ea typeface="Calibri" pitchFamily="34" charset="-122"/>
+                <a:cs typeface="Calibri" pitchFamily="34" charset="-120"/>
+              </a:rPr>
+              <a:t>Mohamad Arrizal</a:t>
+            </a:r>
+            <a:endParaRPr lang="en-US" sz="1500" dirty="0"/>
+          </a:p>
+          <a:p>
+            <a:pPr indent="0" marL="0">
+              <a:spcAft>
+                <a:spcPts val="300"/>
+              </a:spcAft>
+              <a:buNone/>
+            </a:pPr>
+            <a:r>
+              <a:rPr lang="en-US" sz="1500" dirty="0">
+                <a:solidFill>
+                  <a:srgbClr val="1C1917"/>
+                </a:solidFill>
+                <a:latin typeface="Calibri" pitchFamily="34" charset="0"/>
+                <a:ea typeface="Calibri" pitchFamily="34" charset="-122"/>
+                <a:cs typeface="Calibri" pitchFamily="34" charset="-120"/>
+              </a:rPr>
+              <a:t>Zuber Khatib</a:t>
+            </a:r>
+            <a:endParaRPr lang="en-US" sz="1500" dirty="0"/>
+          </a:p>
+        </p:txBody>
+      </p:sp>
+      <p:pic>
+        <p:nvPicPr>
+          <p:cNvPr id="7" name="Image 0" descr="Layar hasil PantangMakan: Ada kacang dan pemanis di komposisi ini">    </p:cNvPr>
+          <p:cNvPicPr>
+            <a:picLocks noChangeAspect="1"/>
+          </p:cNvPicPr>
+          <p:nvPr/>
+        </p:nvPicPr>
+        <p:blipFill>
+          <a:blip r:embed="rId1"/>
+          <a:stretch>
+            <a:fillRect/>
+          </a:stretch>
+        </p:blipFill>
+        <p:spPr>
+          <a:xfrm>
+            <a:off x="8321040" y="502920"/>
+            <a:ext cx="2695074" cy="5852160"/>
+          </a:xfrm>
+          <a:prstGeom prst="rect">
+            <a:avLst/>
+          </a:prstGeom>
+        </p:spPr>
+      </p:pic>
+      <p:sp>
+        <p:nvSpPr>
+          <p:cNvPr id="8" name="Shape 5"/>
+          <p:cNvSpPr/>
+          <p:nvPr/>
+        </p:nvSpPr>
+        <p:spPr>
+          <a:xfrm>
+            <a:off x="8321040" y="502920"/>
+            <a:ext cx="2695074" cy="5852160"/>
+          </a:xfrm>
+          <a:prstGeom prst="roundRect">
+            <a:avLst>
+              <a:gd name="adj" fmla="val 6107"/>
+            </a:avLst>
+          </a:prstGeom>
+          <a:ln w="12700">
+            <a:solidFill>
+              <a:srgbClr val="E4DDD4"/>
+            </a:solidFill>
+            <a:prstDash val="solid"/>
+          </a:ln>
+        </p:spPr>
       </p:sp>
     </p:spTree>
   </p:cSld>
@@ -2196,8 +2310,8 @@
         </p:nvSpPr>
         <p:spPr>
           <a:xfrm>
-            <a:off x="777240" y="1965960"/>
-            <a:ext cx="3657600" cy="822960"/>
+            <a:off x="777240" y="1828800"/>
+            <a:ext cx="2743200" cy="822960"/>
           </a:xfrm>
           <a:prstGeom prst="rect">
             <a:avLst/>
@@ -2235,24 +2349,24 @@
         </p:nvSpPr>
         <p:spPr>
           <a:xfrm>
-            <a:off x="777240" y="2880360"/>
-            <a:ext cx="10058400" cy="1005840"/>
-          </a:xfrm>
-          <a:prstGeom prst="rect">
-            <a:avLst/>
-          </a:prstGeom>
-          <a:noFill/>
-          <a:ln/>
-        </p:spPr>
-        <p:txBody>
-          <a:bodyPr wrap="square" lIns="0" tIns="0" rIns="0" bIns="0" rtlCol="0" anchor="ctr"/>
+            <a:off x="777240" y="2743200"/>
+            <a:ext cx="6035040" cy="1097280"/>
+          </a:xfrm>
+          <a:prstGeom prst="rect">
+            <a:avLst/>
+          </a:prstGeom>
+          <a:noFill/>
+          <a:ln/>
+        </p:spPr>
+        <p:txBody>
+          <a:bodyPr wrap="square" lIns="0" tIns="0" rIns="0" bIns="0" rtlCol="0" anchor="t"/>
           <a:lstStyle/>
           <a:p>
             <a:pPr indent="0" marL="0">
               <a:buNone/>
             </a:pPr>
             <a:r>
-              <a:rPr lang="en-US" sz="4000" dirty="0">
+              <a:rPr lang="en-US" sz="3800" dirty="0">
                 <a:solidFill>
                   <a:srgbClr val="1C1917"/>
                 </a:solidFill>
@@ -2262,7 +2376,202 @@
               </a:rPr>
               <a:t>Validasi Produk</a:t>
             </a:r>
-            <a:endParaRPr lang="en-US" sz="4000" dirty="0"/>
+            <a:endParaRPr lang="en-US" sz="3800" dirty="0"/>
+          </a:p>
+        </p:txBody>
+      </p:sp>
+      <p:sp>
+        <p:nvSpPr>
+          <p:cNvPr id="5" name="Text 3"/>
+          <p:cNvSpPr/>
+          <p:nvPr/>
+        </p:nvSpPr>
+        <p:spPr>
+          <a:xfrm>
+            <a:off x="777240" y="3977640"/>
+            <a:ext cx="5669280" cy="914400"/>
+          </a:xfrm>
+          <a:prstGeom prst="rect">
+            <a:avLst/>
+          </a:prstGeom>
+          <a:noFill/>
+          <a:ln/>
+        </p:spPr>
+        <p:txBody>
+          <a:bodyPr wrap="square" lIns="0" tIns="0" rIns="0" bIns="0" rtlCol="0" anchor="t"/>
+          <a:lstStyle/>
+          <a:p>
+            <a:pPr indent="0" marL="0">
+              <a:buNone/>
+            </a:pPr>
+            <a:r>
+              <a:rPr lang="en-US" sz="1800" dirty="0">
+                <a:solidFill>
+                  <a:srgbClr val="6B6560"/>
+                </a:solidFill>
+                <a:latin typeface="Calibri" pitchFamily="34" charset="0"/>
+                <a:ea typeface="Calibri" pitchFamily="34" charset="-122"/>
+                <a:cs typeface="Calibri" pitchFamily="34" charset="-120"/>
+              </a:rPr>
+              <a:t>10 label sungguhan: 8 benar sebelum Create ML, 10 benar sesudahnya.</a:t>
+            </a:r>
+            <a:endParaRPr lang="en-US" sz="1800" dirty="0"/>
+          </a:p>
+        </p:txBody>
+      </p:sp>
+      <p:sp>
+        <p:nvSpPr>
+          <p:cNvPr id="6" name="Text 4"/>
+          <p:cNvSpPr/>
+          <p:nvPr/>
+        </p:nvSpPr>
+        <p:spPr>
+          <a:xfrm>
+            <a:off x="7223760" y="2194560"/>
+            <a:ext cx="1463040" cy="1645920"/>
+          </a:xfrm>
+          <a:prstGeom prst="rect">
+            <a:avLst/>
+          </a:prstGeom>
+          <a:noFill/>
+          <a:ln/>
+        </p:spPr>
+        <p:txBody>
+          <a:bodyPr wrap="square" lIns="0" tIns="0" rIns="0" bIns="0" rtlCol="0" anchor="ctr"/>
+          <a:lstStyle/>
+          <a:p>
+            <a:pPr algn="ctr" indent="0" marL="0">
+              <a:buNone/>
+            </a:pPr>
+            <a:r>
+              <a:rPr lang="en-US" sz="11000" dirty="0">
+                <a:solidFill>
+                  <a:srgbClr val="6B6560"/>
+                </a:solidFill>
+                <a:latin typeface="Georgia" pitchFamily="34" charset="0"/>
+                <a:ea typeface="Georgia" pitchFamily="34" charset="-122"/>
+                <a:cs typeface="Georgia" pitchFamily="34" charset="-120"/>
+              </a:rPr>
+              <a:t>8</a:t>
+            </a:r>
+            <a:endParaRPr lang="en-US" sz="11000" dirty="0"/>
+          </a:p>
+        </p:txBody>
+      </p:sp>
+      <p:sp>
+        <p:nvSpPr>
+          <p:cNvPr id="7" name="Text 5"/>
+          <p:cNvSpPr/>
+          <p:nvPr/>
+        </p:nvSpPr>
+        <p:spPr>
+          <a:xfrm>
+            <a:off x="8686800" y="2514600"/>
+            <a:ext cx="914400" cy="914400"/>
+          </a:xfrm>
+          <a:prstGeom prst="rect">
+            <a:avLst/>
+          </a:prstGeom>
+          <a:noFill/>
+          <a:ln/>
+        </p:spPr>
+        <p:txBody>
+          <a:bodyPr wrap="square" lIns="0" tIns="0" rIns="0" bIns="0" rtlCol="0" anchor="ctr"/>
+          <a:lstStyle/>
+          <a:p>
+            <a:pPr algn="ctr" indent="0" marL="0">
+              <a:buNone/>
+            </a:pPr>
+            <a:r>
+              <a:rPr lang="en-US" sz="4400" dirty="0">
+                <a:solidFill>
+                  <a:srgbClr val="B85A3C"/>
+                </a:solidFill>
+                <a:latin typeface="Calibri" pitchFamily="34" charset="0"/>
+                <a:ea typeface="Calibri" pitchFamily="34" charset="-122"/>
+                <a:cs typeface="Calibri" pitchFamily="34" charset="-120"/>
+              </a:rPr>
+              <a:t>→</a:t>
+            </a:r>
+            <a:endParaRPr lang="en-US" sz="4400" dirty="0"/>
+          </a:p>
+        </p:txBody>
+      </p:sp>
+      <p:sp>
+        <p:nvSpPr>
+          <p:cNvPr id="8" name="Text 6"/>
+          <p:cNvSpPr/>
+          <p:nvPr/>
+        </p:nvSpPr>
+        <p:spPr>
+          <a:xfrm>
+            <a:off x="9601200" y="2194560"/>
+            <a:ext cx="2194560" cy="1645920"/>
+          </a:xfrm>
+          <a:prstGeom prst="rect">
+            <a:avLst/>
+          </a:prstGeom>
+          <a:noFill/>
+          <a:ln/>
+        </p:spPr>
+        <p:txBody>
+          <a:bodyPr wrap="square" lIns="0" tIns="0" rIns="0" bIns="0" rtlCol="0" anchor="ctr"/>
+          <a:lstStyle/>
+          <a:p>
+            <a:pPr algn="ctr" indent="0" marL="0">
+              <a:buNone/>
+            </a:pPr>
+            <a:r>
+              <a:rPr lang="en-US" sz="11000" dirty="0">
+                <a:solidFill>
+                  <a:srgbClr val="1E7345"/>
+                </a:solidFill>
+                <a:latin typeface="Georgia" pitchFamily="34" charset="0"/>
+                <a:ea typeface="Georgia" pitchFamily="34" charset="-122"/>
+                <a:cs typeface="Georgia" pitchFamily="34" charset="-120"/>
+              </a:rPr>
+              <a:t>10</a:t>
+            </a:r>
+            <a:endParaRPr lang="en-US" sz="11000" dirty="0"/>
+          </a:p>
+        </p:txBody>
+      </p:sp>
+      <p:sp>
+        <p:nvSpPr>
+          <p:cNvPr id="9" name="Text 7"/>
+          <p:cNvSpPr/>
+          <p:nvPr/>
+        </p:nvSpPr>
+        <p:spPr>
+          <a:xfrm>
+            <a:off x="7223760" y="3886200"/>
+            <a:ext cx="4572000" cy="365760"/>
+          </a:xfrm>
+          <a:prstGeom prst="rect">
+            <a:avLst/>
+          </a:prstGeom>
+          <a:noFill/>
+          <a:ln/>
+        </p:spPr>
+        <p:txBody>
+          <a:bodyPr wrap="square" lIns="0" tIns="0" rIns="0" bIns="0" rtlCol="0" anchor="ctr"/>
+          <a:lstStyle/>
+          <a:p>
+            <a:pPr algn="ctr" indent="0" marL="0">
+              <a:buNone/>
+            </a:pPr>
+            <a:r>
+              <a:rPr lang="en-US" sz="1600" dirty="0">
+                <a:solidFill>
+                  <a:srgbClr val="6B6560"/>
+                </a:solidFill>
+                <a:latin typeface="Calibri" pitchFamily="34" charset="0"/>
+                <a:ea typeface="Calibri" pitchFamily="34" charset="-122"/>
+                <a:cs typeface="Calibri" pitchFamily="34" charset="-120"/>
+              </a:rPr>
+              <a:t>dari 10 label benar</a:t>
+            </a:r>
+            <a:endParaRPr lang="en-US" sz="1600" dirty="0"/>
           </a:p>
         </p:txBody>
       </p:sp>
@@ -2306,8 +2615,8 @@
         </p:nvSpPr>
         <p:spPr>
           <a:xfrm>
-            <a:off x="502920" y="292608"/>
-            <a:ext cx="11155680" cy="530352"/>
+            <a:off x="502920" y="320040"/>
+            <a:ext cx="11155680" cy="548640"/>
           </a:xfrm>
           <a:prstGeom prst="rect">
             <a:avLst/>
@@ -2345,18 +2654,23 @@
         </p:nvSpPr>
         <p:spPr>
           <a:xfrm>
-            <a:off x="502920" y="1143000"/>
-            <a:ext cx="3611880" cy="2148840"/>
+            <a:off x="502920" y="1097280"/>
+            <a:ext cx="3611880" cy="2103120"/>
           </a:xfrm>
           <a:prstGeom prst="roundRect">
             <a:avLst>
-              <a:gd name="adj" fmla="val 5106"/>
+              <a:gd name="adj" fmla="val 5217"/>
             </a:avLst>
           </a:prstGeom>
           <a:solidFill>
             <a:srgbClr val="FFFCF8"/>
           </a:solidFill>
-          <a:ln/>
+          <a:ln w="9525">
+            <a:solidFill>
+              <a:srgbClr val="E4DDD4"/>
+            </a:solidFill>
+            <a:prstDash val="solid"/>
+          </a:ln>
         </p:spPr>
       </p:sp>
       <p:sp>
@@ -2367,8 +2681,8 @@
         </p:nvSpPr>
         <p:spPr>
           <a:xfrm>
-            <a:off x="758952" y="1325880"/>
-            <a:ext cx="3108960" cy="292608"/>
+            <a:off x="758952" y="1280160"/>
+            <a:ext cx="3108960" cy="274320"/>
           </a:xfrm>
           <a:prstGeom prst="rect">
             <a:avLst/>
@@ -2384,7 +2698,7 @@
               <a:buNone/>
             </a:pPr>
             <a:r>
-              <a:rPr lang="en-US" sz="1400" dirty="0">
+              <a:rPr lang="en-US" sz="1200" b="1" spc="100" kern="0" dirty="0">
                 <a:solidFill>
                   <a:srgbClr val="6B6560"/>
                 </a:solidFill>
@@ -2392,9 +2706,9 @@
                 <a:ea typeface="Calibri" pitchFamily="34" charset="-122"/>
                 <a:cs typeface="Calibri" pitchFamily="34" charset="-120"/>
               </a:rPr>
-              <a:t>Input yang dicoba</a:t>
-            </a:r>
-            <a:endParaRPr lang="en-US" sz="1400" dirty="0"/>
+              <a:t>INPUT YANG DICOBA</a:t>
+            </a:r>
+            <a:endParaRPr lang="en-US" sz="1200" dirty="0"/>
           </a:p>
         </p:txBody>
       </p:sp>
@@ -2406,8 +2720,8 @@
         </p:nvSpPr>
         <p:spPr>
           <a:xfrm>
-            <a:off x="758952" y="1737360"/>
-            <a:ext cx="3108960" cy="731520"/>
+            <a:off x="758952" y="1627632"/>
+            <a:ext cx="3108960" cy="685800"/>
           </a:xfrm>
           <a:prstGeom prst="rect">
             <a:avLst/>
@@ -2423,7 +2737,7 @@
               <a:buNone/>
             </a:pPr>
             <a:r>
-              <a:rPr lang="en-US" sz="3600" dirty="0">
+              <a:rPr lang="en-US" sz="3400" dirty="0">
                 <a:solidFill>
                   <a:srgbClr val="1C1917"/>
                 </a:solidFill>
@@ -2431,9 +2745,9 @@
                 <a:ea typeface="Georgia" pitchFamily="34" charset="-122"/>
                 <a:cs typeface="Georgia" pitchFamily="34" charset="-120"/>
               </a:rPr>
-              <a:t>10 foto</a:t>
-            </a:r>
-            <a:endParaRPr lang="en-US" sz="3600" dirty="0"/>
+              <a:t>10 label</a:t>
+            </a:r>
+            <a:endParaRPr lang="en-US" sz="3400" dirty="0"/>
           </a:p>
         </p:txBody>
       </p:sp>
@@ -2445,8 +2759,8 @@
         </p:nvSpPr>
         <p:spPr>
           <a:xfrm>
-            <a:off x="758952" y="2514600"/>
-            <a:ext cx="3108960" cy="594360"/>
+            <a:off x="758952" y="2377440"/>
+            <a:ext cx="3154680" cy="685800"/>
           </a:xfrm>
           <a:prstGeom prst="rect">
             <a:avLst/>
@@ -2470,7 +2784,7 @@
                 <a:ea typeface="Calibri" pitchFamily="34" charset="-122"/>
                 <a:cs typeface="Calibri" pitchFamily="34" charset="-120"/>
               </a:rPr>
-              <a:t>Label komposisi produk Indonesia, enam pantangan dipilih</a:t>
+              <a:t>Produk Indonesia dari Open Food Facts, tidak ikut data latih</a:t>
             </a:r>
             <a:endParaRPr lang="en-US" sz="1300" dirty="0"/>
           </a:p>
@@ -2484,18 +2798,23 @@
         </p:nvSpPr>
         <p:spPr>
           <a:xfrm>
-            <a:off x="4343400" y="1143000"/>
-            <a:ext cx="3611880" cy="2148840"/>
+            <a:off x="4297680" y="1097280"/>
+            <a:ext cx="3611880" cy="2103120"/>
           </a:xfrm>
           <a:prstGeom prst="roundRect">
             <a:avLst>
-              <a:gd name="adj" fmla="val 5106"/>
+              <a:gd name="adj" fmla="val 5217"/>
             </a:avLst>
           </a:prstGeom>
           <a:solidFill>
             <a:srgbClr val="FFFCF8"/>
           </a:solidFill>
-          <a:ln/>
+          <a:ln w="9525">
+            <a:solidFill>
+              <a:srgbClr val="E4DDD4"/>
+            </a:solidFill>
+            <a:prstDash val="solid"/>
+          </a:ln>
         </p:spPr>
       </p:sp>
       <p:sp>
@@ -2506,8 +2825,8 @@
         </p:nvSpPr>
         <p:spPr>
           <a:xfrm>
-            <a:off x="4599432" y="1325880"/>
-            <a:ext cx="3108960" cy="292608"/>
+            <a:off x="4553712" y="1280160"/>
+            <a:ext cx="3108960" cy="274320"/>
           </a:xfrm>
           <a:prstGeom prst="rect">
             <a:avLst/>
@@ -2523,7 +2842,7 @@
               <a:buNone/>
             </a:pPr>
             <a:r>
-              <a:rPr lang="en-US" sz="1400" dirty="0">
+              <a:rPr lang="en-US" sz="1200" b="1" spc="100" kern="0" dirty="0">
                 <a:solidFill>
                   <a:srgbClr val="6B6560"/>
                 </a:solidFill>
@@ -2531,9 +2850,9 @@
                 <a:ea typeface="Calibri" pitchFamily="34" charset="-122"/>
                 <a:cs typeface="Calibri" pitchFamily="34" charset="-120"/>
               </a:rPr>
-              <a:t>Berhasil</a:t>
-            </a:r>
-            <a:endParaRPr lang="en-US" sz="1400" dirty="0"/>
+              <a:t>BERHASIL</a:t>
+            </a:r>
+            <a:endParaRPr lang="en-US" sz="1200" dirty="0"/>
           </a:p>
         </p:txBody>
       </p:sp>
@@ -2545,8 +2864,8 @@
         </p:nvSpPr>
         <p:spPr>
           <a:xfrm>
-            <a:off x="4599432" y="1737360"/>
-            <a:ext cx="3108960" cy="731520"/>
+            <a:off x="4553712" y="1627632"/>
+            <a:ext cx="3108960" cy="685800"/>
           </a:xfrm>
           <a:prstGeom prst="rect">
             <a:avLst/>
@@ -2562,17 +2881,17 @@
               <a:buNone/>
             </a:pPr>
             <a:r>
-              <a:rPr lang="en-US" sz="3600" dirty="0">
-                <a:solidFill>
-                  <a:srgbClr val="1C1917"/>
+              <a:rPr lang="en-US" sz="3400" dirty="0">
+                <a:solidFill>
+                  <a:srgbClr val="1E7345"/>
                 </a:solidFill>
                 <a:latin typeface="Georgia" pitchFamily="34" charset="0"/>
                 <a:ea typeface="Georgia" pitchFamily="34" charset="-122"/>
                 <a:cs typeface="Georgia" pitchFamily="34" charset="-120"/>
               </a:rPr>
-              <a:t>8 dari 10</a:t>
-            </a:r>
-            <a:endParaRPr lang="en-US" sz="3600" dirty="0"/>
+              <a:t>10 dari 10</a:t>
+            </a:r>
+            <a:endParaRPr lang="en-US" sz="3400" dirty="0"/>
           </a:p>
         </p:txBody>
       </p:sp>
@@ -2584,8 +2903,8 @@
         </p:nvSpPr>
         <p:spPr>
           <a:xfrm>
-            <a:off x="4599432" y="2514600"/>
-            <a:ext cx="3108960" cy="594360"/>
+            <a:off x="4553712" y="2377440"/>
+            <a:ext cx="3154680" cy="685800"/>
           </a:xfrm>
           <a:prstGeom prst="rect">
             <a:avLst/>
@@ -2609,7 +2928,7 @@
                 <a:ea typeface="Calibri" pitchFamily="34" charset="-122"/>
                 <a:cs typeface="Calibri" pitchFamily="34" charset="-120"/>
               </a:rPr>
-              <a:t>Pantangan yang disebut sama dengan isi label</a:t>
+              <a:t>Sebelum Create ML: 8 dari 10</a:t>
             </a:r>
             <a:endParaRPr lang="en-US" sz="1300" dirty="0"/>
           </a:p>
@@ -2623,18 +2942,23 @@
         </p:nvSpPr>
         <p:spPr>
           <a:xfrm>
-            <a:off x="8183880" y="1143000"/>
-            <a:ext cx="3611880" cy="2148840"/>
+            <a:off x="8092440" y="1097280"/>
+            <a:ext cx="3611880" cy="2103120"/>
           </a:xfrm>
           <a:prstGeom prst="roundRect">
             <a:avLst>
-              <a:gd name="adj" fmla="val 5106"/>
+              <a:gd name="adj" fmla="val 5217"/>
             </a:avLst>
           </a:prstGeom>
           <a:solidFill>
             <a:srgbClr val="FFFCF8"/>
           </a:solidFill>
-          <a:ln/>
+          <a:ln w="9525">
+            <a:solidFill>
+              <a:srgbClr val="E4DDD4"/>
+            </a:solidFill>
+            <a:prstDash val="solid"/>
+          </a:ln>
         </p:spPr>
       </p:sp>
       <p:sp>
@@ -2645,8 +2969,8 @@
         </p:nvSpPr>
         <p:spPr>
           <a:xfrm>
-            <a:off x="8439912" y="1325880"/>
-            <a:ext cx="3108960" cy="292608"/>
+            <a:off x="8348472" y="1280160"/>
+            <a:ext cx="3108960" cy="274320"/>
           </a:xfrm>
           <a:prstGeom prst="rect">
             <a:avLst/>
@@ -2662,7 +2986,7 @@
               <a:buNone/>
             </a:pPr>
             <a:r>
-              <a:rPr lang="en-US" sz="1400" dirty="0">
+              <a:rPr lang="en-US" sz="1200" b="1" spc="100" kern="0" dirty="0">
                 <a:solidFill>
                   <a:srgbClr val="6B6560"/>
                 </a:solidFill>
@@ -2670,9 +2994,9 @@
                 <a:ea typeface="Calibri" pitchFamily="34" charset="-122"/>
                 <a:cs typeface="Calibri" pitchFamily="34" charset="-120"/>
               </a:rPr>
-              <a:t>Contoh yang gagal</a:t>
-            </a:r>
-            <a:endParaRPr lang="en-US" sz="1400" dirty="0"/>
+              <a:t>CONTOH YANG GAGAL</a:t>
+            </a:r>
+            <a:endParaRPr lang="en-US" sz="1200" dirty="0"/>
           </a:p>
         </p:txBody>
       </p:sp>
@@ -2684,8 +3008,8 @@
         </p:nvSpPr>
         <p:spPr>
           <a:xfrm>
-            <a:off x="8439912" y="1737360"/>
-            <a:ext cx="3108960" cy="731520"/>
+            <a:off x="8348472" y="1627632"/>
+            <a:ext cx="3108960" cy="685800"/>
           </a:xfrm>
           <a:prstGeom prst="rect">
             <a:avLst/>
@@ -2701,7 +3025,7 @@
               <a:buNone/>
             </a:pPr>
             <a:r>
-              <a:rPr lang="en-US" sz="3600" dirty="0">
+              <a:rPr lang="en-US" sz="3400" dirty="0">
                 <a:solidFill>
                   <a:srgbClr val="1C1917"/>
                 </a:solidFill>
@@ -2711,7 +3035,7 @@
               </a:rPr>
               <a:t>Superco</a:t>
             </a:r>
-            <a:endParaRPr lang="en-US" sz="3600" dirty="0"/>
+            <a:endParaRPr lang="en-US" sz="3400" dirty="0"/>
           </a:p>
         </p:txBody>
       </p:sp>
@@ -2723,8 +3047,8 @@
         </p:nvSpPr>
         <p:spPr>
           <a:xfrm>
-            <a:off x="8439912" y="2514600"/>
-            <a:ext cx="3108960" cy="594360"/>
+            <a:off x="8348472" y="2377440"/>
+            <a:ext cx="3154680" cy="685800"/>
           </a:xfrm>
           <a:prstGeom prst="rect">
             <a:avLst/>
@@ -2748,7 +3072,7 @@
                 <a:ea typeface="Calibri" pitchFamily="34" charset="-122"/>
                 <a:cs typeface="Calibri" pitchFamily="34" charset="-120"/>
               </a:rPr>
-              <a:t>“Dapat mengandung telur dan kacang” dihitung sebagai bahan</a:t>
+              <a:t>Versi lama menghitung “dapat mengandung telur dan kacang” sebagai bahan</a:t>
             </a:r>
             <a:endParaRPr lang="en-US" sz="1300" dirty="0"/>
           </a:p>
@@ -2762,18 +3086,23 @@
         </p:nvSpPr>
         <p:spPr>
           <a:xfrm>
-            <a:off x="502920" y="3566160"/>
-            <a:ext cx="11155680" cy="2148840"/>
+            <a:off x="502920" y="3429000"/>
+            <a:ext cx="11201400" cy="2697480"/>
           </a:xfrm>
           <a:prstGeom prst="roundRect">
             <a:avLst>
-              <a:gd name="adj" fmla="val 5106"/>
+              <a:gd name="adj" fmla="val 4068"/>
             </a:avLst>
           </a:prstGeom>
           <a:solidFill>
             <a:srgbClr val="FFFCF8"/>
           </a:solidFill>
-          <a:ln/>
+          <a:ln w="9525">
+            <a:solidFill>
+              <a:srgbClr val="E4DDD4"/>
+            </a:solidFill>
+            <a:prstDash val="solid"/>
+          </a:ln>
         </p:spPr>
       </p:sp>
       <p:sp>
@@ -2784,8 +3113,8 @@
         </p:nvSpPr>
         <p:spPr>
           <a:xfrm>
-            <a:off x="777240" y="3794760"/>
-            <a:ext cx="10058400" cy="292608"/>
+            <a:off x="777240" y="3639312"/>
+            <a:ext cx="5486400" cy="274320"/>
           </a:xfrm>
           <a:prstGeom prst="rect">
             <a:avLst/>
@@ -2801,7 +3130,7 @@
               <a:buNone/>
             </a:pPr>
             <a:r>
-              <a:rPr lang="en-US" sz="1400" dirty="0">
+              <a:rPr lang="en-US" sz="1200" b="1" spc="100" kern="0" dirty="0">
                 <a:solidFill>
                   <a:srgbClr val="B85A3C"/>
                 </a:solidFill>
@@ -2809,9 +3138,9 @@
                 <a:ea typeface="Calibri" pitchFamily="34" charset="-122"/>
                 <a:cs typeface="Calibri" pitchFamily="34" charset="-120"/>
               </a:rPr>
-              <a:t>Lesson learned</a:t>
-            </a:r>
-            <a:endParaRPr lang="en-US" sz="1400" dirty="0"/>
+              <a:t>LESSON LEARNED</a:t>
+            </a:r>
+            <a:endParaRPr lang="en-US" sz="1200" dirty="0"/>
           </a:p>
         </p:txBody>
       </p:sp>
@@ -2823,8 +3152,8 @@
         </p:nvSpPr>
         <p:spPr>
           <a:xfrm>
-            <a:off x="777240" y="4206240"/>
-            <a:ext cx="6949440" cy="1371600"/>
+            <a:off x="777240" y="3977640"/>
+            <a:ext cx="6766560" cy="1920240"/>
           </a:xfrm>
           <a:prstGeom prst="rect">
             <a:avLst/>
@@ -2840,7 +3169,7 @@
               <a:buNone/>
             </a:pPr>
             <a:r>
-              <a:rPr lang="en-US" sz="2000" dirty="0">
+              <a:rPr lang="en-US" sz="1900" dirty="0">
                 <a:solidFill>
                   <a:srgbClr val="1C1917"/>
                 </a:solidFill>
@@ -2848,15 +3177,15 @@
                 <a:ea typeface="Georgia" pitchFamily="34" charset="-122"/>
                 <a:cs typeface="Georgia" pitchFamily="34" charset="-120"/>
               </a:rPr>
-              <a:t>Kedua kegagalan punya sebab yang sama: kalimat peringatan di bawah komposisi, seperti “dapat mengandung” atau “diproses dengan peralatan yang juga memproses kacang”, ikut terbaca sebagai bahan.</a:t>
-            </a:r>
-            <a:endParaRPr lang="en-US" sz="2000" dirty="0"/>
+              <a:t>Label kemasan mencampur bahan dengan peringatan. Mencocokkan kata saja tidak cukup: kalimatnya perlu dipilah dulu. Model kami benar 90,4% di 230 kalimat uji.</a:t>
+            </a:r>
+            <a:endParaRPr lang="en-US" sz="1900" dirty="0"/>
           </a:p>
         </p:txBody>
       </p:sp>
       <p:pic>
         <p:nvPicPr>
-          <p:cNvPr id="18" name="Image 0" descr="Label komposisi Superco dengan kalimat Dapat mengandung telur, kedelai dan kacang">    </p:cNvPr>
+          <p:cNvPr id="18" name="Image 0" descr="Label Superco dengan kalimat dapat mengandung">    </p:cNvPr>
           <p:cNvPicPr>
             <a:picLocks noChangeAspect="1"/>
           </p:cNvPicPr>
@@ -2864,13 +3193,14 @@
         </p:nvPicPr>
         <p:blipFill>
           <a:blip r:embed="rId1"/>
-          <a:srcRect l="0" r="0" t="0" b="0"/>
-          <a:stretch/>
+          <a:stretch>
+            <a:fillRect/>
+          </a:stretch>
         </p:blipFill>
         <p:spPr>
           <a:xfrm>
-            <a:off x="8092440" y="3749040"/>
-            <a:ext cx="2743200" cy="1783080"/>
+            <a:off x="7863840" y="3639312"/>
+            <a:ext cx="3566160" cy="2312624"/>
           </a:xfrm>
           <a:prstGeom prst="rect">
             <a:avLst/>
@@ -2885,8 +3215,8 @@
         </p:nvSpPr>
         <p:spPr>
           <a:xfrm>
-            <a:off x="8092440" y="5559552"/>
-            <a:ext cx="2743200" cy="182880"/>
+            <a:off x="7863840" y="5943600"/>
+            <a:ext cx="3566160" cy="182880"/>
           </a:xfrm>
           <a:prstGeom prst="rect">
             <a:avLst/>
@@ -2924,8 +3254,8 @@
         </p:nvSpPr>
         <p:spPr>
           <a:xfrm>
-            <a:off x="502920" y="6510528"/>
-            <a:ext cx="7315200" cy="219456"/>
+            <a:off x="502920" y="6446520"/>
+            <a:ext cx="7315200" cy="228600"/>
           </a:xfrm>
           <a:prstGeom prst="rect">
             <a:avLst/>
@@ -3015,8 +3345,8 @@
         </p:nvSpPr>
         <p:spPr>
           <a:xfrm>
-            <a:off x="777240" y="1965960"/>
-            <a:ext cx="3657600" cy="822960"/>
+            <a:off x="777240" y="1828800"/>
+            <a:ext cx="2743200" cy="822960"/>
           </a:xfrm>
           <a:prstGeom prst="rect">
             <a:avLst/>
@@ -3054,24 +3384,24 @@
         </p:nvSpPr>
         <p:spPr>
           <a:xfrm>
-            <a:off x="777240" y="2880360"/>
-            <a:ext cx="10058400" cy="1005840"/>
-          </a:xfrm>
-          <a:prstGeom prst="rect">
-            <a:avLst/>
-          </a:prstGeom>
-          <a:noFill/>
-          <a:ln/>
-        </p:spPr>
-        <p:txBody>
-          <a:bodyPr wrap="square" lIns="0" tIns="0" rIns="0" bIns="0" rtlCol="0" anchor="ctr"/>
+            <a:off x="777240" y="2743200"/>
+            <a:ext cx="6035040" cy="1097280"/>
+          </a:xfrm>
+          <a:prstGeom prst="rect">
+            <a:avLst/>
+          </a:prstGeom>
+          <a:noFill/>
+          <a:ln/>
+        </p:spPr>
+        <p:txBody>
+          <a:bodyPr wrap="square" lIns="0" tIns="0" rIns="0" bIns="0" rtlCol="0" anchor="t"/>
           <a:lstStyle/>
           <a:p>
             <a:pPr indent="0" marL="0">
               <a:buNone/>
             </a:pPr>
             <a:r>
-              <a:rPr lang="en-US" sz="4000" dirty="0">
+              <a:rPr lang="en-US" sz="3800" dirty="0">
                 <a:solidFill>
                   <a:srgbClr val="1C1917"/>
                 </a:solidFill>
@@ -3081,7 +3411,46 @@
               </a:rPr>
               <a:t>Rencana Pengembangan</a:t>
             </a:r>
-            <a:endParaRPr lang="en-US" sz="4000" dirty="0"/>
+            <a:endParaRPr lang="en-US" sz="3800" dirty="0"/>
+          </a:p>
+        </p:txBody>
+      </p:sp>
+      <p:sp>
+        <p:nvSpPr>
+          <p:cNvPr id="5" name="Text 3"/>
+          <p:cNvSpPr/>
+          <p:nvPr/>
+        </p:nvSpPr>
+        <p:spPr>
+          <a:xfrm>
+            <a:off x="777240" y="3977640"/>
+            <a:ext cx="5669280" cy="914400"/>
+          </a:xfrm>
+          <a:prstGeom prst="rect">
+            <a:avLst/>
+          </a:prstGeom>
+          <a:noFill/>
+          <a:ln/>
+        </p:spPr>
+        <p:txBody>
+          <a:bodyPr wrap="square" lIns="0" tIns="0" rIns="0" bIns="0" rtlCol="0" anchor="t"/>
+          <a:lstStyle/>
+          <a:p>
+            <a:pPr indent="0" marL="0">
+              <a:buNone/>
+            </a:pPr>
+            <a:r>
+              <a:rPr lang="en-US" sz="1800" dirty="0">
+                <a:solidFill>
+                  <a:srgbClr val="6B6560"/>
+                </a:solidFill>
+                <a:latin typeface="Calibri" pitchFamily="34" charset="0"/>
+                <a:ea typeface="Calibri" pitchFamily="34" charset="-122"/>
+                <a:cs typeface="Calibri" pitchFamily="34" charset="-120"/>
+              </a:rPr>
+              <a:t>Satu langkah berikutnya.</a:t>
+            </a:r>
+            <a:endParaRPr lang="en-US" sz="1800" dirty="0"/>
           </a:p>
         </p:txBody>
       </p:sp>
@@ -3125,8 +3494,8 @@
         </p:nvSpPr>
         <p:spPr>
           <a:xfrm>
-            <a:off x="502920" y="292608"/>
-            <a:ext cx="11155680" cy="530352"/>
+            <a:off x="502920" y="320040"/>
+            <a:ext cx="11155680" cy="548640"/>
           </a:xfrm>
           <a:prstGeom prst="rect">
             <a:avLst/>
@@ -3164,18 +3533,23 @@
         </p:nvSpPr>
         <p:spPr>
           <a:xfrm>
-            <a:off x="502920" y="1325880"/>
-            <a:ext cx="11155680" cy="3291840"/>
+            <a:off x="502920" y="1143000"/>
+            <a:ext cx="6949440" cy="3566160"/>
           </a:xfrm>
           <a:prstGeom prst="roundRect">
             <a:avLst>
-              <a:gd name="adj" fmla="val 3333"/>
+              <a:gd name="adj" fmla="val 3077"/>
             </a:avLst>
           </a:prstGeom>
           <a:solidFill>
             <a:srgbClr val="FFFCF8"/>
           </a:solidFill>
-          <a:ln/>
+          <a:ln w="9525">
+            <a:solidFill>
+              <a:srgbClr val="E4DDD4"/>
+            </a:solidFill>
+            <a:prstDash val="solid"/>
+          </a:ln>
         </p:spPr>
       </p:sp>
       <p:sp>
@@ -3186,8 +3560,8 @@
         </p:nvSpPr>
         <p:spPr>
           <a:xfrm>
-            <a:off x="868680" y="1691640"/>
-            <a:ext cx="10058400" cy="320040"/>
+            <a:off x="868680" y="1463040"/>
+            <a:ext cx="5486400" cy="274320"/>
           </a:xfrm>
           <a:prstGeom prst="rect">
             <a:avLst/>
@@ -3203,7 +3577,7 @@
               <a:buNone/>
             </a:pPr>
             <a:r>
-              <a:rPr lang="en-US" sz="1400" dirty="0">
+              <a:rPr lang="en-US" sz="1200" b="1" spc="100" kern="0" dirty="0">
                 <a:solidFill>
                   <a:srgbClr val="B85A3C"/>
                 </a:solidFill>
@@ -3211,9 +3585,9 @@
                 <a:ea typeface="Calibri" pitchFamily="34" charset="-122"/>
                 <a:cs typeface="Calibri" pitchFamily="34" charset="-120"/>
               </a:rPr>
-              <a:t>Langkah berikutnya</a:t>
-            </a:r>
-            <a:endParaRPr lang="en-US" sz="1400" dirty="0"/>
+              <a:t>LANGKAH BERIKUTNYA</a:t>
+            </a:r>
+            <a:endParaRPr lang="en-US" sz="1200" dirty="0"/>
           </a:p>
         </p:txBody>
       </p:sp>
@@ -3225,24 +3599,24 @@
         </p:nvSpPr>
         <p:spPr>
           <a:xfrm>
-            <a:off x="868680" y="2194560"/>
-            <a:ext cx="10058400" cy="640080"/>
-          </a:xfrm>
-          <a:prstGeom prst="rect">
-            <a:avLst/>
-          </a:prstGeom>
-          <a:noFill/>
-          <a:ln/>
-        </p:spPr>
-        <p:txBody>
-          <a:bodyPr wrap="square" lIns="0" tIns="0" rIns="0" bIns="0" rtlCol="0" anchor="ctr"/>
+            <a:off x="868680" y="1828800"/>
+            <a:ext cx="6309360" cy="1188720"/>
+          </a:xfrm>
+          <a:prstGeom prst="rect">
+            <a:avLst/>
+          </a:prstGeom>
+          <a:noFill/>
+          <a:ln/>
+        </p:spPr>
+        <p:txBody>
+          <a:bodyPr wrap="square" lIns="0" tIns="0" rIns="0" bIns="0" rtlCol="0" anchor="t"/>
           <a:lstStyle/>
           <a:p>
             <a:pPr indent="0" marL="0">
               <a:buNone/>
             </a:pPr>
             <a:r>
-              <a:rPr lang="en-US" sz="3600" dirty="0">
+              <a:rPr lang="en-US" sz="3200" dirty="0">
                 <a:solidFill>
                   <a:srgbClr val="1C1917"/>
                 </a:solidFill>
@@ -3250,9 +3624,9 @@
                 <a:ea typeface="Georgia" pitchFamily="34" charset="-122"/>
                 <a:cs typeface="Georgia" pitchFamily="34" charset="-120"/>
               </a:rPr>
-              <a:t>Pisahkan kalimat “dapat mengandung”.</a:t>
-            </a:r>
-            <a:endParaRPr lang="en-US" sz="3600" dirty="0"/>
+              <a:t>Uji 30 kemasan dari kamera iPhone.</a:t>
+            </a:r>
+            <a:endParaRPr lang="en-US" sz="3200" dirty="0"/>
           </a:p>
         </p:txBody>
       </p:sp>
@@ -3264,24 +3638,24 @@
         </p:nvSpPr>
         <p:spPr>
           <a:xfrm>
-            <a:off x="868680" y="3063240"/>
-            <a:ext cx="10058400" cy="1188720"/>
-          </a:xfrm>
-          <a:prstGeom prst="rect">
-            <a:avLst/>
-          </a:prstGeom>
-          <a:noFill/>
-          <a:ln/>
-        </p:spPr>
-        <p:txBody>
-          <a:bodyPr wrap="square" lIns="0" tIns="0" rIns="0" bIns="0" rtlCol="0" anchor="ctr"/>
+            <a:off x="868680" y="3154680"/>
+            <a:ext cx="6309360" cy="1828800"/>
+          </a:xfrm>
+          <a:prstGeom prst="rect">
+            <a:avLst/>
+          </a:prstGeom>
+          <a:noFill/>
+          <a:ln/>
+        </p:spPr>
+        <p:txBody>
+          <a:bodyPr wrap="square" lIns="0" tIns="0" rIns="0" bIns="0" rtlCol="0" anchor="t"/>
           <a:lstStyle/>
           <a:p>
             <a:pPr indent="0" marL="0">
               <a:buNone/>
             </a:pPr>
             <a:r>
-              <a:rPr lang="en-US" sz="2200" dirty="0">
+              <a:rPr lang="en-US" sz="1700" dirty="0">
                 <a:solidFill>
                   <a:srgbClr val="1C1917"/>
                 </a:solidFill>
@@ -3289,16 +3663,65 @@
                 <a:ea typeface="Calibri" pitchFamily="34" charset="-122"/>
                 <a:cs typeface="Calibri" pitchFamily="34" charset="-120"/>
               </a:rPr>
-              <a:t>Bahan di daftar komposisi tetap jadi kartu merah. Kalimat “dapat mengandung”</a:t>
-            </a:r>
-            <a:endParaRPr lang="en-US" sz="2200" dirty="0"/>
-          </a:p>
+              <a:t>Validasi kali ini memakai foto dari Open Food Facts. Berikutnya kami foto sendiri di minimarket, termasuk huruf yang lengkung atau mengkilap, lalu kalimat yang salah dipilah ditambahkan ke data latih Create ML.</a:t>
+            </a:r>
+            <a:endParaRPr lang="en-US" sz="1700" dirty="0"/>
+          </a:p>
+        </p:txBody>
+      </p:sp>
+      <p:sp>
+        <p:nvSpPr>
+          <p:cNvPr id="7" name="Shape 5"/>
+          <p:cNvSpPr/>
+          <p:nvPr/>
+        </p:nvSpPr>
+        <p:spPr>
+          <a:xfrm>
+            <a:off x="7726680" y="1143000"/>
+            <a:ext cx="3977640" cy="3566160"/>
+          </a:xfrm>
+          <a:prstGeom prst="roundRect">
+            <a:avLst>
+              <a:gd name="adj" fmla="val 3077"/>
+            </a:avLst>
+          </a:prstGeom>
+          <a:solidFill>
+            <a:srgbClr val="FDF0CC"/>
+          </a:solidFill>
+          <a:ln w="9525">
+            <a:solidFill>
+              <a:srgbClr val="E4DDD4"/>
+            </a:solidFill>
+            <a:prstDash val="solid"/>
+          </a:ln>
+        </p:spPr>
+      </p:sp>
+      <p:sp>
+        <p:nvSpPr>
+          <p:cNvPr id="8" name="Text 6"/>
+          <p:cNvSpPr/>
+          <p:nvPr/>
+        </p:nvSpPr>
+        <p:spPr>
+          <a:xfrm>
+            <a:off x="8001000" y="1463040"/>
+            <a:ext cx="3474720" cy="274320"/>
+          </a:xfrm>
+          <a:prstGeom prst="rect">
+            <a:avLst/>
+          </a:prstGeom>
+          <a:noFill/>
+          <a:ln/>
+        </p:spPr>
+        <p:txBody>
+          <a:bodyPr wrap="square" lIns="0" tIns="0" rIns="0" bIns="0" rtlCol="0" anchor="ctr"/>
+          <a:lstStyle/>
           <a:p>
             <a:pPr indent="0" marL="0">
               <a:buNone/>
             </a:pPr>
             <a:r>
-              <a:rPr lang="en-US" sz="2200" dirty="0">
+              <a:rPr lang="en-US" sz="1200" b="1" spc="100" kern="0" dirty="0">
                 <a:solidFill>
                   <a:srgbClr val="1C1917"/>
                 </a:solidFill>
@@ -3306,22 +3729,61 @@
                 <a:ea typeface="Calibri" pitchFamily="34" charset="-122"/>
                 <a:cs typeface="Calibri" pitchFamily="34" charset="-120"/>
               </a:rPr>
-              <a:t>jadi peringatan terpisah, lalu Superco dan Oat M*lk dicoba lagi.</a:t>
-            </a:r>
-            <a:endParaRPr lang="en-US" sz="2200" dirty="0"/>
-          </a:p>
-        </p:txBody>
-      </p:sp>
-      <p:sp>
-        <p:nvSpPr>
-          <p:cNvPr id="7" name="Text 5"/>
-          <p:cNvSpPr/>
-          <p:nvPr/>
-        </p:nvSpPr>
-        <p:spPr>
-          <a:xfrm>
-            <a:off x="502920" y="6510528"/>
-            <a:ext cx="7315200" cy="219456"/>
+              <a:t>KENAPA INI</a:t>
+            </a:r>
+            <a:endParaRPr lang="en-US" sz="1200" dirty="0"/>
+          </a:p>
+        </p:txBody>
+      </p:sp>
+      <p:sp>
+        <p:nvSpPr>
+          <p:cNvPr id="9" name="Text 7"/>
+          <p:cNvSpPr/>
+          <p:nvPr/>
+        </p:nvSpPr>
+        <p:spPr>
+          <a:xfrm>
+            <a:off x="8001000" y="1828800"/>
+            <a:ext cx="3474720" cy="3200400"/>
+          </a:xfrm>
+          <a:prstGeom prst="rect">
+            <a:avLst/>
+          </a:prstGeom>
+          <a:noFill/>
+          <a:ln/>
+        </p:spPr>
+        <p:txBody>
+          <a:bodyPr wrap="square" lIns="0" tIns="0" rIns="0" bIns="0" rtlCol="0" anchor="t"/>
+          <a:lstStyle/>
+          <a:p>
+            <a:pPr indent="0" marL="0">
+              <a:buNone/>
+            </a:pPr>
+            <a:r>
+              <a:rPr lang="en-US" sz="1600" dirty="0">
+                <a:solidFill>
+                  <a:srgbClr val="1C1917"/>
+                </a:solidFill>
+                <a:latin typeface="Calibri" pitchFamily="34" charset="0"/>
+                <a:ea typeface="Calibri" pitchFamily="34" charset="-122"/>
+                <a:cs typeface="Calibri" pitchFamily="34" charset="-120"/>
+              </a:rPr>
+              <a:t>Data latih dan uji sekarang berasal dari 230 foto Open Food Facts. Kamera iPhone di rak toko memberi sudut, cahaya, dan pantulan yang belum pernah dilihat model.</a:t>
+            </a:r>
+            <a:endParaRPr lang="en-US" sz="1600" dirty="0"/>
+          </a:p>
+        </p:txBody>
+      </p:sp>
+      <p:sp>
+        <p:nvSpPr>
+          <p:cNvPr id="10" name="Text 8"/>
+          <p:cNvSpPr/>
+          <p:nvPr/>
+        </p:nvSpPr>
+        <p:spPr>
+          <a:xfrm>
+            <a:off x="502920" y="6446520"/>
+            <a:ext cx="7315200" cy="228600"/>
           </a:xfrm>
           <a:prstGeom prst="rect">
             <a:avLst/>
@@ -3411,8 +3873,8 @@
         </p:nvSpPr>
         <p:spPr>
           <a:xfrm>
-            <a:off x="777240" y="1965960"/>
-            <a:ext cx="3657600" cy="822960"/>
+            <a:off x="777240" y="1828800"/>
+            <a:ext cx="2743200" cy="822960"/>
           </a:xfrm>
           <a:prstGeom prst="rect">
             <a:avLst/>
@@ -3450,24 +3912,24 @@
         </p:nvSpPr>
         <p:spPr>
           <a:xfrm>
-            <a:off x="777240" y="2880360"/>
-            <a:ext cx="10058400" cy="1005840"/>
-          </a:xfrm>
-          <a:prstGeom prst="rect">
-            <a:avLst/>
-          </a:prstGeom>
-          <a:noFill/>
-          <a:ln/>
-        </p:spPr>
-        <p:txBody>
-          <a:bodyPr wrap="square" lIns="0" tIns="0" rIns="0" bIns="0" rtlCol="0" anchor="ctr"/>
+            <a:off x="777240" y="2743200"/>
+            <a:ext cx="6035040" cy="1097280"/>
+          </a:xfrm>
+          <a:prstGeom prst="rect">
+            <a:avLst/>
+          </a:prstGeom>
+          <a:noFill/>
+          <a:ln/>
+        </p:spPr>
+        <p:txBody>
+          <a:bodyPr wrap="square" lIns="0" tIns="0" rIns="0" bIns="0" rtlCol="0" anchor="t"/>
           <a:lstStyle/>
           <a:p>
             <a:pPr indent="0" marL="0">
               <a:buNone/>
             </a:pPr>
             <a:r>
-              <a:rPr lang="en-US" sz="4000" dirty="0">
+              <a:rPr lang="en-US" sz="3800" dirty="0">
                 <a:solidFill>
                   <a:srgbClr val="1C1917"/>
                 </a:solidFill>
@@ -3477,7 +3939,46 @@
               </a:rPr>
               <a:t>Tim Kami</a:t>
             </a:r>
-            <a:endParaRPr lang="en-US" sz="4000" dirty="0"/>
+            <a:endParaRPr lang="en-US" sz="3800" dirty="0"/>
+          </a:p>
+        </p:txBody>
+      </p:sp>
+      <p:sp>
+        <p:nvSpPr>
+          <p:cNvPr id="5" name="Text 3"/>
+          <p:cNvSpPr/>
+          <p:nvPr/>
+        </p:nvSpPr>
+        <p:spPr>
+          <a:xfrm>
+            <a:off x="777240" y="3977640"/>
+            <a:ext cx="5669280" cy="914400"/>
+          </a:xfrm>
+          <a:prstGeom prst="rect">
+            <a:avLst/>
+          </a:prstGeom>
+          <a:noFill/>
+          <a:ln/>
+        </p:spPr>
+        <p:txBody>
+          <a:bodyPr wrap="square" lIns="0" tIns="0" rIns="0" bIns="0" rtlCol="0" anchor="t"/>
+          <a:lstStyle/>
+          <a:p>
+            <a:pPr indent="0" marL="0">
+              <a:buNone/>
+            </a:pPr>
+            <a:r>
+              <a:rPr lang="en-US" sz="1800" dirty="0">
+                <a:solidFill>
+                  <a:srgbClr val="6B6560"/>
+                </a:solidFill>
+                <a:latin typeface="Calibri" pitchFamily="34" charset="0"/>
+                <a:ea typeface="Calibri" pitchFamily="34" charset="-122"/>
+                <a:cs typeface="Calibri" pitchFamily="34" charset="-120"/>
+              </a:rPr>
+              <a:t>Lima anggota, satu app.</a:t>
+            </a:r>
+            <a:endParaRPr lang="en-US" sz="1800" dirty="0"/>
           </a:p>
         </p:txBody>
       </p:sp>
@@ -3521,8 +4022,8 @@
         </p:nvSpPr>
         <p:spPr>
           <a:xfrm>
-            <a:off x="502920" y="292608"/>
-            <a:ext cx="11155680" cy="530352"/>
+            <a:off x="502920" y="320040"/>
+            <a:ext cx="11155680" cy="548640"/>
           </a:xfrm>
           <a:prstGeom prst="rect">
             <a:avLst/>
@@ -3567,17 +4068,17 @@
           </p:nvPr>
         </p:nvGraphicFramePr>
         <p:xfrm>
-          <a:off x="502920" y="1097280"/>
-          <a:ext cx="11155680" cy="4206240"/>
+          <a:off x="502920" y="1143000"/>
+          <a:ext cx="7680960" cy="4206240"/>
         </p:xfrm>
         <a:graphic>
           <a:graphicData uri="http://schemas.openxmlformats.org/drawingml/2006/table">
             <a:tbl>
               <a:tblPr/>
               <a:tblGrid>
-                <a:gridCol w="4754880"/>
-                <a:gridCol w="3200400"/>
-                <a:gridCol w="3200400"/>
+                <a:gridCol w="3291840"/>
+                <a:gridCol w="2194560"/>
+                <a:gridCol w="2194560"/>
               </a:tblGrid>
               <a:tr h="701040">
                 <a:tc>
@@ -3585,7 +4086,7 @@
                     <a:bodyPr/>
                     <a:lstStyle/>
                     <a:p>
-                      <a:pPr algn="l" indent="0" marL="0">
+                      <a:pPr indent="0" marL="0">
                         <a:buNone/>
                       </a:pPr>
                       <a:r>
@@ -3644,7 +4145,7 @@
                       <a:tailEnd type="none" w="med" len="med"/>
                     </a:lnB>
                     <a:solidFill>
-                      <a:srgbClr val="1C1917"/>
+                      <a:srgbClr val="2B2B28"/>
                     </a:solidFill>
                   </a:tcPr>
                 </a:tc>
@@ -3653,7 +4154,7 @@
                     <a:bodyPr/>
                     <a:lstStyle/>
                     <a:p>
-                      <a:pPr algn="l" indent="0" marL="0">
+                      <a:pPr indent="0" marL="0">
                         <a:buNone/>
                       </a:pPr>
                       <a:r>
@@ -3712,7 +4213,7 @@
                       <a:tailEnd type="none" w="med" len="med"/>
                     </a:lnB>
                     <a:solidFill>
-                      <a:srgbClr val="1C1917"/>
+                      <a:srgbClr val="2B2B28"/>
                     </a:solidFill>
                   </a:tcPr>
                 </a:tc>
@@ -3721,7 +4222,7 @@
                     <a:bodyPr/>
                     <a:lstStyle/>
                     <a:p>
-                      <a:pPr algn="l" indent="0" marL="0">
+                      <a:pPr indent="0" marL="0">
                         <a:buNone/>
                       </a:pPr>
                       <a:r>
@@ -3780,7 +4281,7 @@
                       <a:tailEnd type="none" w="med" len="med"/>
                     </a:lnB>
                     <a:solidFill>
-                      <a:srgbClr val="1C1917"/>
+                      <a:srgbClr val="2B2B28"/>
                     </a:solidFill>
                   </a:tcPr>
                 </a:tc>
@@ -3791,7 +4292,7 @@
                     <a:bodyPr/>
                     <a:lstStyle/>
                     <a:p>
-                      <a:pPr algn="l" indent="0" marL="0">
+                      <a:pPr indent="0" marL="0">
                         <a:buNone/>
                       </a:pPr>
                       <a:r>
@@ -3859,20 +4360,9 @@
                     <a:bodyPr/>
                     <a:lstStyle/>
                     <a:p>
-                      <a:pPr algn="l" indent="0" marL="0">
+                      <a:pPr indent="0" marL="0">
                         <a:buNone/>
                       </a:pPr>
-                      <a:r>
-                        <a:rPr lang="en-US" sz="1500" dirty="0">
-                          <a:solidFill>
-                            <a:srgbClr val="6B6560"/>
-                          </a:solidFill>
-                          <a:latin typeface="Calibri" pitchFamily="34" charset="0"/>
-                          <a:ea typeface="Calibri" pitchFamily="34" charset="-122"/>
-                          <a:cs typeface="Calibri" pitchFamily="34" charset="-120"/>
-                        </a:rPr>
-                        <a:t>—</a:t>
-                      </a:r>
                       <a:endParaRPr lang="en-US" sz="1500" dirty="0">
                         <a:latin typeface="Calibri" charset="0"/>
                         <a:ea typeface="Calibri" charset="0"/>
@@ -3927,20 +4417,9 @@
                     <a:bodyPr/>
                     <a:lstStyle/>
                     <a:p>
-                      <a:pPr algn="l" indent="0" marL="0">
+                      <a:pPr indent="0" marL="0">
                         <a:buNone/>
                       </a:pPr>
-                      <a:r>
-                        <a:rPr lang="en-US" sz="1500" dirty="0">
-                          <a:solidFill>
-                            <a:srgbClr val="6B6560"/>
-                          </a:solidFill>
-                          <a:latin typeface="Calibri" pitchFamily="34" charset="0"/>
-                          <a:ea typeface="Calibri" pitchFamily="34" charset="-122"/>
-                          <a:cs typeface="Calibri" pitchFamily="34" charset="-120"/>
-                        </a:rPr>
-                        <a:t>—</a:t>
-                      </a:r>
                       <a:endParaRPr lang="en-US" sz="1500" dirty="0">
                         <a:latin typeface="Calibri" charset="0"/>
                         <a:ea typeface="Calibri" charset="0"/>
@@ -3997,7 +4476,7 @@
                     <a:bodyPr/>
                     <a:lstStyle/>
                     <a:p>
-                      <a:pPr algn="l" indent="0" marL="0">
+                      <a:pPr indent="0" marL="0">
                         <a:buNone/>
                       </a:pPr>
                       <a:r>
@@ -4065,20 +4544,9 @@
                     <a:bodyPr/>
                     <a:lstStyle/>
                     <a:p>
-                      <a:pPr algn="l" indent="0" marL="0">
+                      <a:pPr indent="0" marL="0">
                         <a:buNone/>
                       </a:pPr>
-                      <a:r>
-                        <a:rPr lang="en-US" sz="1500" dirty="0">
-                          <a:solidFill>
-                            <a:srgbClr val="6B6560"/>
-                          </a:solidFill>
-                          <a:latin typeface="Calibri" pitchFamily="34" charset="0"/>
-                          <a:ea typeface="Calibri" pitchFamily="34" charset="-122"/>
-                          <a:cs typeface="Calibri" pitchFamily="34" charset="-120"/>
-                        </a:rPr>
-                        <a:t>—</a:t>
-                      </a:r>
                       <a:endParaRPr lang="en-US" sz="1500" dirty="0">
                         <a:latin typeface="Calibri" charset="0"/>
                         <a:ea typeface="Calibri" charset="0"/>
@@ -4133,20 +4601,9 @@
                     <a:bodyPr/>
                     <a:lstStyle/>
                     <a:p>
-                      <a:pPr algn="l" indent="0" marL="0">
+                      <a:pPr indent="0" marL="0">
                         <a:buNone/>
                       </a:pPr>
-                      <a:r>
-                        <a:rPr lang="en-US" sz="1500" dirty="0">
-                          <a:solidFill>
-                            <a:srgbClr val="6B6560"/>
-                          </a:solidFill>
-                          <a:latin typeface="Calibri" pitchFamily="34" charset="0"/>
-                          <a:ea typeface="Calibri" pitchFamily="34" charset="-122"/>
-                          <a:cs typeface="Calibri" pitchFamily="34" charset="-120"/>
-                        </a:rPr>
-                        <a:t>—</a:t>
-                      </a:r>
                       <a:endParaRPr lang="en-US" sz="1500" dirty="0">
                         <a:latin typeface="Calibri" charset="0"/>
                         <a:ea typeface="Calibri" charset="0"/>
@@ -4203,7 +4660,7 @@
                     <a:bodyPr/>
                     <a:lstStyle/>
                     <a:p>
-                      <a:pPr algn="l" indent="0" marL="0">
+                      <a:pPr indent="0" marL="0">
                         <a:buNone/>
                       </a:pPr>
                       <a:r>
@@ -4271,20 +4728,9 @@
                     <a:bodyPr/>
                     <a:lstStyle/>
                     <a:p>
-                      <a:pPr algn="l" indent="0" marL="0">
+                      <a:pPr indent="0" marL="0">
                         <a:buNone/>
                       </a:pPr>
-                      <a:r>
-                        <a:rPr lang="en-US" sz="1500" dirty="0">
-                          <a:solidFill>
-                            <a:srgbClr val="6B6560"/>
-                          </a:solidFill>
-                          <a:latin typeface="Calibri" pitchFamily="34" charset="0"/>
-                          <a:ea typeface="Calibri" pitchFamily="34" charset="-122"/>
-                          <a:cs typeface="Calibri" pitchFamily="34" charset="-120"/>
-                        </a:rPr>
-                        <a:t>—</a:t>
-                      </a:r>
                       <a:endParaRPr lang="en-US" sz="1500" dirty="0">
                         <a:latin typeface="Calibri" charset="0"/>
                         <a:ea typeface="Calibri" charset="0"/>
@@ -4339,20 +4785,9 @@
                     <a:bodyPr/>
                     <a:lstStyle/>
                     <a:p>
-                      <a:pPr algn="l" indent="0" marL="0">
+                      <a:pPr indent="0" marL="0">
                         <a:buNone/>
                       </a:pPr>
-                      <a:r>
-                        <a:rPr lang="en-US" sz="1500" dirty="0">
-                          <a:solidFill>
-                            <a:srgbClr val="6B6560"/>
-                          </a:solidFill>
-                          <a:latin typeface="Calibri" pitchFamily="34" charset="0"/>
-                          <a:ea typeface="Calibri" pitchFamily="34" charset="-122"/>
-                          <a:cs typeface="Calibri" pitchFamily="34" charset="-120"/>
-                        </a:rPr>
-                        <a:t>—</a:t>
-                      </a:r>
                       <a:endParaRPr lang="en-US" sz="1500" dirty="0">
                         <a:latin typeface="Calibri" charset="0"/>
                         <a:ea typeface="Calibri" charset="0"/>
@@ -4409,7 +4844,7 @@
                     <a:bodyPr/>
                     <a:lstStyle/>
                     <a:p>
-                      <a:pPr algn="l" indent="0" marL="0">
+                      <a:pPr indent="0" marL="0">
                         <a:buNone/>
                       </a:pPr>
                       <a:r>
@@ -4477,20 +4912,9 @@
                     <a:bodyPr/>
                     <a:lstStyle/>
                     <a:p>
-                      <a:pPr algn="l" indent="0" marL="0">
+                      <a:pPr indent="0" marL="0">
                         <a:buNone/>
                       </a:pPr>
-                      <a:r>
-                        <a:rPr lang="en-US" sz="1500" dirty="0">
-                          <a:solidFill>
-                            <a:srgbClr val="6B6560"/>
-                          </a:solidFill>
-                          <a:latin typeface="Calibri" pitchFamily="34" charset="0"/>
-                          <a:ea typeface="Calibri" pitchFamily="34" charset="-122"/>
-                          <a:cs typeface="Calibri" pitchFamily="34" charset="-120"/>
-                        </a:rPr>
-                        <a:t>—</a:t>
-                      </a:r>
                       <a:endParaRPr lang="en-US" sz="1500" dirty="0">
                         <a:latin typeface="Calibri" charset="0"/>
                         <a:ea typeface="Calibri" charset="0"/>
@@ -4545,20 +4969,9 @@
                     <a:bodyPr/>
                     <a:lstStyle/>
                     <a:p>
-                      <a:pPr algn="l" indent="0" marL="0">
+                      <a:pPr indent="0" marL="0">
                         <a:buNone/>
                       </a:pPr>
-                      <a:r>
-                        <a:rPr lang="en-US" sz="1500" dirty="0">
-                          <a:solidFill>
-                            <a:srgbClr val="6B6560"/>
-                          </a:solidFill>
-                          <a:latin typeface="Calibri" pitchFamily="34" charset="0"/>
-                          <a:ea typeface="Calibri" pitchFamily="34" charset="-122"/>
-                          <a:cs typeface="Calibri" pitchFamily="34" charset="-120"/>
-                        </a:rPr>
-                        <a:t>—</a:t>
-                      </a:r>
                       <a:endParaRPr lang="en-US" sz="1500" dirty="0">
                         <a:latin typeface="Calibri" charset="0"/>
                         <a:ea typeface="Calibri" charset="0"/>
@@ -4615,7 +5028,7 @@
                     <a:bodyPr/>
                     <a:lstStyle/>
                     <a:p>
-                      <a:pPr algn="l" indent="0" marL="0">
+                      <a:pPr indent="0" marL="0">
                         <a:buNone/>
                       </a:pPr>
                       <a:r>
@@ -4683,20 +5096,9 @@
                     <a:bodyPr/>
                     <a:lstStyle/>
                     <a:p>
-                      <a:pPr algn="l" indent="0" marL="0">
+                      <a:pPr indent="0" marL="0">
                         <a:buNone/>
                       </a:pPr>
-                      <a:r>
-                        <a:rPr lang="en-US" sz="1500" dirty="0">
-                          <a:solidFill>
-                            <a:srgbClr val="6B6560"/>
-                          </a:solidFill>
-                          <a:latin typeface="Calibri" pitchFamily="34" charset="0"/>
-                          <a:ea typeface="Calibri" pitchFamily="34" charset="-122"/>
-                          <a:cs typeface="Calibri" pitchFamily="34" charset="-120"/>
-                        </a:rPr>
-                        <a:t>—</a:t>
-                      </a:r>
                       <a:endParaRPr lang="en-US" sz="1500" dirty="0">
                         <a:latin typeface="Calibri" charset="0"/>
                         <a:ea typeface="Calibri" charset="0"/>
@@ -4751,20 +5153,9 @@
                     <a:bodyPr/>
                     <a:lstStyle/>
                     <a:p>
-                      <a:pPr algn="l" indent="0" marL="0">
+                      <a:pPr indent="0" marL="0">
                         <a:buNone/>
                       </a:pPr>
-                      <a:r>
-                        <a:rPr lang="en-US" sz="1500" dirty="0">
-                          <a:solidFill>
-                            <a:srgbClr val="6B6560"/>
-                          </a:solidFill>
-                          <a:latin typeface="Calibri" pitchFamily="34" charset="0"/>
-                          <a:ea typeface="Calibri" pitchFamily="34" charset="-122"/>
-                          <a:cs typeface="Calibri" pitchFamily="34" charset="-120"/>
-                        </a:rPr>
-                        <a:t>—</a:t>
-                      </a:r>
                       <a:endParaRPr lang="en-US" sz="1500" dirty="0">
                         <a:latin typeface="Calibri" charset="0"/>
                         <a:ea typeface="Calibri" charset="0"/>
@@ -4821,14 +5212,80 @@
       </p:graphicFrame>
       <p:sp>
         <p:nvSpPr>
-          <p:cNvPr id="4" name="Text 1"/>
-          <p:cNvSpPr/>
-          <p:nvPr/>
-        </p:nvSpPr>
-        <p:spPr>
-          <a:xfrm>
-            <a:off x="502920" y="6510528"/>
-            <a:ext cx="7315200" cy="219456"/>
+          <p:cNvPr id="4" name="Shape 1"/>
+          <p:cNvSpPr/>
+          <p:nvPr/>
+        </p:nvSpPr>
+        <p:spPr>
+          <a:xfrm>
+            <a:off x="8503920" y="1143000"/>
+            <a:ext cx="3200400" cy="4206240"/>
+          </a:xfrm>
+          <a:prstGeom prst="roundRect">
+            <a:avLst>
+              <a:gd name="adj" fmla="val 3429"/>
+            </a:avLst>
+          </a:prstGeom>
+          <a:solidFill>
+            <a:srgbClr val="FFFCF8"/>
+          </a:solidFill>
+          <a:ln w="9525">
+            <a:solidFill>
+              <a:srgbClr val="E4DDD4"/>
+            </a:solidFill>
+            <a:prstDash val="solid"/>
+          </a:ln>
+        </p:spPr>
+      </p:sp>
+      <p:sp>
+        <p:nvSpPr>
+          <p:cNvPr id="5" name="Text 2"/>
+          <p:cNvSpPr/>
+          <p:nvPr/>
+        </p:nvSpPr>
+        <p:spPr>
+          <a:xfrm>
+            <a:off x="8503920" y="3017520"/>
+            <a:ext cx="3200400" cy="365760"/>
+          </a:xfrm>
+          <a:prstGeom prst="rect">
+            <a:avLst/>
+          </a:prstGeom>
+          <a:noFill/>
+          <a:ln/>
+        </p:spPr>
+        <p:txBody>
+          <a:bodyPr wrap="square" lIns="0" tIns="0" rIns="0" bIns="0" rtlCol="0" anchor="ctr"/>
+          <a:lstStyle/>
+          <a:p>
+            <a:pPr algn="ctr" indent="0" marL="0">
+              <a:buNone/>
+            </a:pPr>
+            <a:r>
+              <a:rPr lang="en-US" sz="1400" dirty="0">
+                <a:solidFill>
+                  <a:srgbClr val="6B6560"/>
+                </a:solidFill>
+                <a:latin typeface="Calibri" pitchFamily="34" charset="0"/>
+                <a:ea typeface="Calibri" pitchFamily="34" charset="-122"/>
+                <a:cs typeface="Calibri" pitchFamily="34" charset="-120"/>
+              </a:rPr>
+              <a:t>Foto tim</a:t>
+            </a:r>
+            <a:endParaRPr lang="en-US" sz="1400" dirty="0"/>
+          </a:p>
+        </p:txBody>
+      </p:sp>
+      <p:sp>
+        <p:nvSpPr>
+          <p:cNvPr id="6" name="Text 3"/>
+          <p:cNvSpPr/>
+          <p:nvPr/>
+        </p:nvSpPr>
+        <p:spPr>
+          <a:xfrm>
+            <a:off x="502920" y="6446520"/>
+            <a:ext cx="7315200" cy="228600"/>
           </a:xfrm>
           <a:prstGeom prst="rect">
             <a:avLst/>
@@ -4918,8 +5375,8 @@
         </p:nvSpPr>
         <p:spPr>
           <a:xfrm>
-            <a:off x="777240" y="1965960"/>
-            <a:ext cx="3657600" cy="822960"/>
+            <a:off x="777240" y="1828800"/>
+            <a:ext cx="2743200" cy="822960"/>
           </a:xfrm>
           <a:prstGeom prst="rect">
             <a:avLst/>
@@ -4957,24 +5414,24 @@
         </p:nvSpPr>
         <p:spPr>
           <a:xfrm>
-            <a:off x="777240" y="2880360"/>
-            <a:ext cx="10058400" cy="1005840"/>
-          </a:xfrm>
-          <a:prstGeom prst="rect">
-            <a:avLst/>
-          </a:prstGeom>
-          <a:noFill/>
-          <a:ln/>
-        </p:spPr>
-        <p:txBody>
-          <a:bodyPr wrap="square" lIns="0" tIns="0" rIns="0" bIns="0" rtlCol="0" anchor="ctr"/>
+            <a:off x="777240" y="2743200"/>
+            <a:ext cx="6035040" cy="1097280"/>
+          </a:xfrm>
+          <a:prstGeom prst="rect">
+            <a:avLst/>
+          </a:prstGeom>
+          <a:noFill/>
+          <a:ln/>
+        </p:spPr>
+        <p:txBody>
+          <a:bodyPr wrap="square" lIns="0" tIns="0" rIns="0" bIns="0" rtlCol="0" anchor="t"/>
           <a:lstStyle/>
           <a:p>
             <a:pPr indent="0" marL="0">
               <a:buNone/>
             </a:pPr>
             <a:r>
-              <a:rPr lang="en-US" sz="4000" dirty="0">
+              <a:rPr lang="en-US" sz="3800" dirty="0">
                 <a:solidFill>
                   <a:srgbClr val="1C1917"/>
                 </a:solidFill>
@@ -4984,7 +5441,109 @@
               </a:rPr>
               <a:t>Masalah yang Kami Selesaikan</a:t>
             </a:r>
-            <a:endParaRPr lang="en-US" sz="4000" dirty="0"/>
+            <a:endParaRPr lang="en-US" sz="3800" dirty="0"/>
+          </a:p>
+        </p:txBody>
+      </p:sp>
+      <p:sp>
+        <p:nvSpPr>
+          <p:cNvPr id="5" name="Text 3"/>
+          <p:cNvSpPr/>
+          <p:nvPr/>
+        </p:nvSpPr>
+        <p:spPr>
+          <a:xfrm>
+            <a:off x="777240" y="3977640"/>
+            <a:ext cx="5669280" cy="914400"/>
+          </a:xfrm>
+          <a:prstGeom prst="rect">
+            <a:avLst/>
+          </a:prstGeom>
+          <a:noFill/>
+          <a:ln/>
+        </p:spPr>
+        <p:txBody>
+          <a:bodyPr wrap="square" lIns="0" tIns="0" rIns="0" bIns="0" rtlCol="0" anchor="t"/>
+          <a:lstStyle/>
+          <a:p>
+            <a:pPr indent="0" marL="0">
+              <a:buNone/>
+            </a:pPr>
+            <a:r>
+              <a:rPr lang="en-US" sz="1800" dirty="0">
+                <a:solidFill>
+                  <a:srgbClr val="6B6560"/>
+                </a:solidFill>
+                <a:latin typeface="Calibri" pitchFamily="34" charset="0"/>
+                <a:ea typeface="Calibri" pitchFamily="34" charset="-122"/>
+                <a:cs typeface="Calibri" pitchFamily="34" charset="-120"/>
+              </a:rPr>
+              <a:t>Huruf komposisi terlalu kecil, dan label mencampur bahan dengan peringatan.</a:t>
+            </a:r>
+            <a:endParaRPr lang="en-US" sz="1800" dirty="0"/>
+          </a:p>
+        </p:txBody>
+      </p:sp>
+      <p:pic>
+        <p:nvPicPr>
+          <p:cNvPr id="6" name="Image 0" descr="Foto label komposisi Superco">    </p:cNvPr>
+          <p:cNvPicPr>
+            <a:picLocks noChangeAspect="1"/>
+          </p:cNvPicPr>
+          <p:nvPr/>
+        </p:nvPicPr>
+        <p:blipFill>
+          <a:blip r:embed="rId1"/>
+          <a:stretch>
+            <a:fillRect/>
+          </a:stretch>
+        </p:blipFill>
+        <p:spPr>
+          <a:xfrm>
+            <a:off x="6949440" y="1737360"/>
+            <a:ext cx="4754880" cy="3083498"/>
+          </a:xfrm>
+          <a:prstGeom prst="rect">
+            <a:avLst/>
+          </a:prstGeom>
+        </p:spPr>
+      </p:pic>
+      <p:sp>
+        <p:nvSpPr>
+          <p:cNvPr id="7" name="Text 4"/>
+          <p:cNvSpPr/>
+          <p:nvPr/>
+        </p:nvSpPr>
+        <p:spPr>
+          <a:xfrm>
+            <a:off x="6949440" y="4864608"/>
+            <a:ext cx="4754880" cy="228600"/>
+          </a:xfrm>
+          <a:prstGeom prst="rect">
+            <a:avLst/>
+          </a:prstGeom>
+          <a:noFill/>
+          <a:ln/>
+        </p:spPr>
+        <p:txBody>
+          <a:bodyPr wrap="square" lIns="0" tIns="0" rIns="0" bIns="0" rtlCol="0" anchor="ctr"/>
+          <a:lstStyle/>
+          <a:p>
+            <a:pPr algn="r" indent="0" marL="0">
+              <a:buNone/>
+            </a:pPr>
+            <a:r>
+              <a:rPr lang="en-US" sz="1000" dirty="0">
+                <a:solidFill>
+                  <a:srgbClr val="6B6560"/>
+                </a:solidFill>
+                <a:latin typeface="Calibri" pitchFamily="34" charset="0"/>
+                <a:ea typeface="Calibri" pitchFamily="34" charset="-122"/>
+                <a:cs typeface="Calibri" pitchFamily="34" charset="-120"/>
+              </a:rPr>
+              <a:t>Label Superco. Foto: Open Food Facts</a:t>
+            </a:r>
+            <a:endParaRPr lang="en-US" sz="1000" dirty="0"/>
           </a:p>
         </p:txBody>
       </p:sp>
@@ -5028,8 +5587,8 @@
         </p:nvSpPr>
         <p:spPr>
           <a:xfrm>
-            <a:off x="502920" y="292608"/>
-            <a:ext cx="11155680" cy="530352"/>
+            <a:off x="502920" y="320040"/>
+            <a:ext cx="11155680" cy="548640"/>
           </a:xfrm>
           <a:prstGeom prst="rect">
             <a:avLst/>
@@ -5061,36 +5620,14 @@
       </p:sp>
       <p:sp>
         <p:nvSpPr>
-          <p:cNvPr id="3" name="Shape 1"/>
-          <p:cNvSpPr/>
-          <p:nvPr/>
-        </p:nvSpPr>
-        <p:spPr>
-          <a:xfrm>
-            <a:off x="502920" y="1051560"/>
-            <a:ext cx="5532120" cy="1481328"/>
-          </a:xfrm>
-          <a:prstGeom prst="roundRect">
-            <a:avLst>
-              <a:gd name="adj" fmla="val 7407"/>
-            </a:avLst>
-          </a:prstGeom>
-          <a:solidFill>
-            <a:srgbClr val="FFFCF8"/>
-          </a:solidFill>
-          <a:ln/>
-        </p:spPr>
-      </p:sp>
-      <p:sp>
-        <p:nvSpPr>
-          <p:cNvPr id="4" name="Text 2"/>
-          <p:cNvSpPr/>
-          <p:nvPr/>
-        </p:nvSpPr>
-        <p:spPr>
-          <a:xfrm>
-            <a:off x="777240" y="1252728"/>
-            <a:ext cx="4983480" cy="292608"/>
+          <p:cNvPr id="3" name="Text 1"/>
+          <p:cNvSpPr/>
+          <p:nvPr/>
+        </p:nvSpPr>
+        <p:spPr>
+          <a:xfrm>
+            <a:off x="502920" y="1097280"/>
+            <a:ext cx="5852160" cy="274320"/>
           </a:xfrm>
           <a:prstGeom prst="rect">
             <a:avLst/>
@@ -5106,7 +5643,7 @@
               <a:buNone/>
             </a:pPr>
             <a:r>
-              <a:rPr lang="en-US" sz="1300" dirty="0">
+              <a:rPr lang="en-US" sz="1200" b="1" spc="100" kern="0" dirty="0">
                 <a:solidFill>
                   <a:srgbClr val="B85A3C"/>
                 </a:solidFill>
@@ -5114,22 +5651,22 @@
                 <a:ea typeface="Calibri" pitchFamily="34" charset="-122"/>
                 <a:cs typeface="Calibri" pitchFamily="34" charset="-120"/>
               </a:rPr>
-              <a:t>Pengguna</a:t>
-            </a:r>
-            <a:endParaRPr lang="en-US" sz="1300" dirty="0"/>
-          </a:p>
-        </p:txBody>
-      </p:sp>
-      <p:sp>
-        <p:nvSpPr>
-          <p:cNvPr id="5" name="Text 3"/>
-          <p:cNvSpPr/>
-          <p:nvPr/>
-        </p:nvSpPr>
-        <p:spPr>
-          <a:xfrm>
-            <a:off x="777240" y="1600200"/>
-            <a:ext cx="4983480" cy="777240"/>
+              <a:t>PENGGUNA</a:t>
+            </a:r>
+            <a:endParaRPr lang="en-US" sz="1200" dirty="0"/>
+          </a:p>
+        </p:txBody>
+      </p:sp>
+      <p:sp>
+        <p:nvSpPr>
+          <p:cNvPr id="4" name="Text 2"/>
+          <p:cNvSpPr/>
+          <p:nvPr/>
+        </p:nvSpPr>
+        <p:spPr>
+          <a:xfrm>
+            <a:off x="502920" y="1389888"/>
+            <a:ext cx="6035040" cy="731520"/>
           </a:xfrm>
           <a:prstGeom prst="rect">
             <a:avLst/>
@@ -5145,7 +5682,7 @@
               <a:buNone/>
             </a:pPr>
             <a:r>
-              <a:rPr lang="en-US" sz="1800" dirty="0">
+              <a:rPr lang="en-US" sz="1700" dirty="0">
                 <a:solidFill>
                   <a:srgbClr val="1C1917"/>
                 </a:solidFill>
@@ -5155,42 +5692,20 @@
               </a:rPr>
               <a:t>Pengguna yang punya pantangan makan, karena alergi atau pilihan sendiri.</a:t>
             </a:r>
-            <a:endParaRPr lang="en-US" sz="1800" dirty="0"/>
-          </a:p>
-        </p:txBody>
-      </p:sp>
-      <p:sp>
-        <p:nvSpPr>
-          <p:cNvPr id="6" name="Shape 4"/>
-          <p:cNvSpPr/>
-          <p:nvPr/>
-        </p:nvSpPr>
-        <p:spPr>
-          <a:xfrm>
-            <a:off x="6309360" y="1051560"/>
-            <a:ext cx="5532120" cy="1481328"/>
-          </a:xfrm>
-          <a:prstGeom prst="roundRect">
-            <a:avLst>
-              <a:gd name="adj" fmla="val 7407"/>
-            </a:avLst>
-          </a:prstGeom>
-          <a:solidFill>
-            <a:srgbClr val="FFFCF8"/>
-          </a:solidFill>
-          <a:ln/>
-        </p:spPr>
-      </p:sp>
-      <p:sp>
-        <p:nvSpPr>
-          <p:cNvPr id="7" name="Text 5"/>
-          <p:cNvSpPr/>
-          <p:nvPr/>
-        </p:nvSpPr>
-        <p:spPr>
-          <a:xfrm>
-            <a:off x="6583680" y="1252728"/>
-            <a:ext cx="4983480" cy="292608"/>
+            <a:endParaRPr lang="en-US" sz="1700" dirty="0"/>
+          </a:p>
+        </p:txBody>
+      </p:sp>
+      <p:sp>
+        <p:nvSpPr>
+          <p:cNvPr id="5" name="Text 3"/>
+          <p:cNvSpPr/>
+          <p:nvPr/>
+        </p:nvSpPr>
+        <p:spPr>
+          <a:xfrm>
+            <a:off x="502920" y="2176272"/>
+            <a:ext cx="5852160" cy="274320"/>
           </a:xfrm>
           <a:prstGeom prst="rect">
             <a:avLst/>
@@ -5206,7 +5721,7 @@
               <a:buNone/>
             </a:pPr>
             <a:r>
-              <a:rPr lang="en-US" sz="1300" dirty="0">
+              <a:rPr lang="en-US" sz="1200" b="1" spc="100" kern="0" dirty="0">
                 <a:solidFill>
                   <a:srgbClr val="B85A3C"/>
                 </a:solidFill>
@@ -5214,22 +5729,22 @@
                 <a:ea typeface="Calibri" pitchFamily="34" charset="-122"/>
                 <a:cs typeface="Calibri" pitchFamily="34" charset="-120"/>
               </a:rPr>
-              <a:t>Masalah</a:t>
-            </a:r>
-            <a:endParaRPr lang="en-US" sz="1300" dirty="0"/>
-          </a:p>
-        </p:txBody>
-      </p:sp>
-      <p:sp>
-        <p:nvSpPr>
-          <p:cNvPr id="8" name="Text 6"/>
-          <p:cNvSpPr/>
-          <p:nvPr/>
-        </p:nvSpPr>
-        <p:spPr>
-          <a:xfrm>
-            <a:off x="6583680" y="1600200"/>
-            <a:ext cx="4983480" cy="777240"/>
+              <a:t>MASALAH</a:t>
+            </a:r>
+            <a:endParaRPr lang="en-US" sz="1200" dirty="0"/>
+          </a:p>
+        </p:txBody>
+      </p:sp>
+      <p:sp>
+        <p:nvSpPr>
+          <p:cNvPr id="6" name="Text 4"/>
+          <p:cNvSpPr/>
+          <p:nvPr/>
+        </p:nvSpPr>
+        <p:spPr>
+          <a:xfrm>
+            <a:off x="502920" y="2468880"/>
+            <a:ext cx="6035040" cy="731520"/>
           </a:xfrm>
           <a:prstGeom prst="rect">
             <a:avLst/>
@@ -5245,7 +5760,7 @@
               <a:buNone/>
             </a:pPr>
             <a:r>
-              <a:rPr lang="en-US" sz="1800" dirty="0">
+              <a:rPr lang="en-US" sz="1700" dirty="0">
                 <a:solidFill>
                   <a:srgbClr val="1C1917"/>
                 </a:solidFill>
@@ -5253,44 +5768,22 @@
                 <a:ea typeface="Calibri" pitchFamily="34" charset="-122"/>
                 <a:cs typeface="Calibri" pitchFamily="34" charset="-120"/>
               </a:rPr>
-              <a:t>Huruf daftar komposisi di kemasan terlalu kecil, jadi bahan pantangan terlewat.</a:t>
-            </a:r>
-            <a:endParaRPr lang="en-US" sz="1800" dirty="0"/>
-          </a:p>
-        </p:txBody>
-      </p:sp>
-      <p:sp>
-        <p:nvSpPr>
-          <p:cNvPr id="9" name="Shape 7"/>
-          <p:cNvSpPr/>
-          <p:nvPr/>
-        </p:nvSpPr>
-        <p:spPr>
-          <a:xfrm>
-            <a:off x="502920" y="2715768"/>
-            <a:ext cx="5532120" cy="1481328"/>
-          </a:xfrm>
-          <a:prstGeom prst="roundRect">
-            <a:avLst>
-              <a:gd name="adj" fmla="val 7407"/>
-            </a:avLst>
-          </a:prstGeom>
-          <a:solidFill>
-            <a:srgbClr val="FFFCF8"/>
-          </a:solidFill>
-          <a:ln/>
-        </p:spPr>
-      </p:sp>
-      <p:sp>
-        <p:nvSpPr>
-          <p:cNvPr id="10" name="Text 8"/>
-          <p:cNvSpPr/>
-          <p:nvPr/>
-        </p:nvSpPr>
-        <p:spPr>
-          <a:xfrm>
-            <a:off x="777240" y="2916936"/>
-            <a:ext cx="4983480" cy="292608"/>
+              <a:t>Huruf daftar komposisi terlalu kecil, jadi bahan pantangan terlewat.</a:t>
+            </a:r>
+            <a:endParaRPr lang="en-US" sz="1700" dirty="0"/>
+          </a:p>
+        </p:txBody>
+      </p:sp>
+      <p:sp>
+        <p:nvSpPr>
+          <p:cNvPr id="7" name="Text 5"/>
+          <p:cNvSpPr/>
+          <p:nvPr/>
+        </p:nvSpPr>
+        <p:spPr>
+          <a:xfrm>
+            <a:off x="502920" y="3255264"/>
+            <a:ext cx="5852160" cy="274320"/>
           </a:xfrm>
           <a:prstGeom prst="rect">
             <a:avLst/>
@@ -5306,7 +5799,7 @@
               <a:buNone/>
             </a:pPr>
             <a:r>
-              <a:rPr lang="en-US" sz="1300" dirty="0">
+              <a:rPr lang="en-US" sz="1200" b="1" spc="100" kern="0" dirty="0">
                 <a:solidFill>
                   <a:srgbClr val="B85A3C"/>
                 </a:solidFill>
@@ -5314,22 +5807,22 @@
                 <a:ea typeface="Calibri" pitchFamily="34" charset="-122"/>
                 <a:cs typeface="Calibri" pitchFamily="34" charset="-120"/>
               </a:rPr>
-              <a:t>Asal masalah</a:t>
-            </a:r>
-            <a:endParaRPr lang="en-US" sz="1300" dirty="0"/>
-          </a:p>
-        </p:txBody>
-      </p:sp>
-      <p:sp>
-        <p:nvSpPr>
-          <p:cNvPr id="11" name="Text 9"/>
-          <p:cNvSpPr/>
-          <p:nvPr/>
-        </p:nvSpPr>
-        <p:spPr>
-          <a:xfrm>
-            <a:off x="777240" y="3264408"/>
-            <a:ext cx="4983480" cy="777240"/>
+              <a:t>ASAL MASALAH</a:t>
+            </a:r>
+            <a:endParaRPr lang="en-US" sz="1200" dirty="0"/>
+          </a:p>
+        </p:txBody>
+      </p:sp>
+      <p:sp>
+        <p:nvSpPr>
+          <p:cNvPr id="8" name="Text 6"/>
+          <p:cNvSpPr/>
+          <p:nvPr/>
+        </p:nvSpPr>
+        <p:spPr>
+          <a:xfrm>
+            <a:off x="502920" y="3547872"/>
+            <a:ext cx="6035040" cy="731520"/>
           </a:xfrm>
           <a:prstGeom prst="rect">
             <a:avLst/>
@@ -5345,7 +5838,7 @@
               <a:buNone/>
             </a:pPr>
             <a:r>
-              <a:rPr lang="en-US" sz="1800" dirty="0">
+              <a:rPr lang="en-US" sz="1700" dirty="0">
                 <a:solidFill>
                   <a:srgbClr val="1C1917"/>
                 </a:solidFill>
@@ -5353,44 +5846,22 @@
                 <a:ea typeface="Calibri" pitchFamily="34" charset="-122"/>
                 <a:cs typeface="Calibri" pitchFamily="34" charset="-120"/>
               </a:rPr>
-              <a:t>Dari pengguna yang punya pantangan: tiap belanja, ia membalik bungkus dan membaca huruf kecil satu per satu.</a:t>
-            </a:r>
-            <a:endParaRPr lang="en-US" sz="1800" dirty="0"/>
-          </a:p>
-        </p:txBody>
-      </p:sp>
-      <p:sp>
-        <p:nvSpPr>
-          <p:cNvPr id="12" name="Shape 10"/>
-          <p:cNvSpPr/>
-          <p:nvPr/>
-        </p:nvSpPr>
-        <p:spPr>
-          <a:xfrm>
-            <a:off x="6309360" y="2715768"/>
-            <a:ext cx="5532120" cy="1481328"/>
-          </a:xfrm>
-          <a:prstGeom prst="roundRect">
-            <a:avLst>
-              <a:gd name="adj" fmla="val 7407"/>
-            </a:avLst>
-          </a:prstGeom>
-          <a:solidFill>
-            <a:srgbClr val="FFFCF8"/>
-          </a:solidFill>
-          <a:ln/>
-        </p:spPr>
-      </p:sp>
-      <p:sp>
-        <p:nvSpPr>
-          <p:cNvPr id="13" name="Text 11"/>
-          <p:cNvSpPr/>
-          <p:nvPr/>
-        </p:nvSpPr>
-        <p:spPr>
-          <a:xfrm>
-            <a:off x="6583680" y="2916936"/>
-            <a:ext cx="4983480" cy="292608"/>
+              <a:t>Dari pengguna yang punya pantangan: tiap belanja ia membalik bungkus dan membaca huruf kecil satu per satu.</a:t>
+            </a:r>
+            <a:endParaRPr lang="en-US" sz="1700" dirty="0"/>
+          </a:p>
+        </p:txBody>
+      </p:sp>
+      <p:sp>
+        <p:nvSpPr>
+          <p:cNvPr id="9" name="Text 7"/>
+          <p:cNvSpPr/>
+          <p:nvPr/>
+        </p:nvSpPr>
+        <p:spPr>
+          <a:xfrm>
+            <a:off x="502920" y="4334256"/>
+            <a:ext cx="5852160" cy="274320"/>
           </a:xfrm>
           <a:prstGeom prst="rect">
             <a:avLst/>
@@ -5406,7 +5877,7 @@
               <a:buNone/>
             </a:pPr>
             <a:r>
-              <a:rPr lang="en-US" sz="1300" dirty="0">
+              <a:rPr lang="en-US" sz="1200" b="1" spc="100" kern="0" dirty="0">
                 <a:solidFill>
                   <a:srgbClr val="B85A3C"/>
                 </a:solidFill>
@@ -5414,22 +5885,22 @@
                 <a:ea typeface="Calibri" pitchFamily="34" charset="-122"/>
                 <a:cs typeface="Calibri" pitchFamily="34" charset="-120"/>
               </a:rPr>
-              <a:t>Cara app menyelesaikannya</a:t>
-            </a:r>
-            <a:endParaRPr lang="en-US" sz="1300" dirty="0"/>
-          </a:p>
-        </p:txBody>
-      </p:sp>
-      <p:sp>
-        <p:nvSpPr>
-          <p:cNvPr id="14" name="Text 12"/>
-          <p:cNvSpPr/>
-          <p:nvPr/>
-        </p:nvSpPr>
-        <p:spPr>
-          <a:xfrm>
-            <a:off x="6583680" y="3264408"/>
-            <a:ext cx="4983480" cy="777240"/>
+              <a:t>CARA APP MENYELESAIKANNYA</a:t>
+            </a:r>
+            <a:endParaRPr lang="en-US" sz="1200" dirty="0"/>
+          </a:p>
+        </p:txBody>
+      </p:sp>
+      <p:sp>
+        <p:nvSpPr>
+          <p:cNvPr id="10" name="Text 8"/>
+          <p:cNvSpPr/>
+          <p:nvPr/>
+        </p:nvSpPr>
+        <p:spPr>
+          <a:xfrm>
+            <a:off x="502920" y="4626864"/>
+            <a:ext cx="6035040" cy="731520"/>
           </a:xfrm>
           <a:prstGeom prst="rect">
             <a:avLst/>
@@ -5445,7 +5916,7 @@
               <a:buNone/>
             </a:pPr>
             <a:r>
-              <a:rPr lang="en-US" sz="1800" dirty="0">
+              <a:rPr lang="en-US" sz="1700" dirty="0">
                 <a:solidFill>
                   <a:srgbClr val="1C1917"/>
                 </a:solidFill>
@@ -5453,44 +5924,49 @@
                 <a:ea typeface="Calibri" pitchFamily="34" charset="-122"/>
                 <a:cs typeface="Calibri" pitchFamily="34" charset="-120"/>
               </a:rPr>
-              <a:t>Pilih pantangan sekali, foto komposisinya, lalu baca satu kalimat: ada pantanganmu atau tidak.</a:t>
-            </a:r>
-            <a:endParaRPr lang="en-US" sz="1800" dirty="0"/>
-          </a:p>
-        </p:txBody>
-      </p:sp>
-      <p:sp>
-        <p:nvSpPr>
-          <p:cNvPr id="15" name="Shape 13"/>
-          <p:cNvSpPr/>
-          <p:nvPr/>
-        </p:nvSpPr>
-        <p:spPr>
-          <a:xfrm>
-            <a:off x="502920" y="4379976"/>
-            <a:ext cx="11338560" cy="1481328"/>
+              <a:t>Pilih pantangan sekali, foto komposisinya, lalu baca satu kalimat.</a:t>
+            </a:r>
+            <a:endParaRPr lang="en-US" sz="1700" dirty="0"/>
+          </a:p>
+        </p:txBody>
+      </p:sp>
+      <p:sp>
+        <p:nvSpPr>
+          <p:cNvPr id="11" name="Shape 9"/>
+          <p:cNvSpPr/>
+          <p:nvPr/>
+        </p:nvSpPr>
+        <p:spPr>
+          <a:xfrm>
+            <a:off x="6903720" y="1097280"/>
+            <a:ext cx="4800600" cy="4160520"/>
           </a:xfrm>
           <a:prstGeom prst="roundRect">
             <a:avLst>
-              <a:gd name="adj" fmla="val 7407"/>
+              <a:gd name="adj" fmla="val 2637"/>
             </a:avLst>
           </a:prstGeom>
           <a:solidFill>
-            <a:srgbClr val="E3F5E8"/>
+            <a:srgbClr val="FDF0CC"/>
           </a:solidFill>
-          <a:ln/>
-        </p:spPr>
-      </p:sp>
-      <p:sp>
-        <p:nvSpPr>
-          <p:cNvPr id="16" name="Text 14"/>
-          <p:cNvSpPr/>
-          <p:nvPr/>
-        </p:nvSpPr>
-        <p:spPr>
-          <a:xfrm>
-            <a:off x="777240" y="4581144"/>
-            <a:ext cx="10789920" cy="292608"/>
+          <a:ln w="9525">
+            <a:solidFill>
+              <a:srgbClr val="E4DDD4"/>
+            </a:solidFill>
+            <a:prstDash val="solid"/>
+          </a:ln>
+        </p:spPr>
+      </p:sp>
+      <p:sp>
+        <p:nvSpPr>
+          <p:cNvPr id="12" name="Text 10"/>
+          <p:cNvSpPr/>
+          <p:nvPr/>
+        </p:nvSpPr>
+        <p:spPr>
+          <a:xfrm>
+            <a:off x="7178040" y="1325880"/>
+            <a:ext cx="4297680" cy="274320"/>
           </a:xfrm>
           <a:prstGeom prst="rect">
             <a:avLst/>
@@ -5506,30 +5982,30 @@
               <a:buNone/>
             </a:pPr>
             <a:r>
-              <a:rPr lang="en-US" sz="1300" dirty="0">
-                <a:solidFill>
-                  <a:srgbClr val="1E7345"/>
+              <a:rPr lang="en-US" sz="1200" b="1" spc="100" kern="0" dirty="0">
+                <a:solidFill>
+                  <a:srgbClr val="1C1917"/>
                 </a:solidFill>
                 <a:latin typeface="Calibri" pitchFamily="34" charset="0"/>
                 <a:ea typeface="Calibri" pitchFamily="34" charset="-122"/>
                 <a:cs typeface="Calibri" pitchFamily="34" charset="-120"/>
               </a:rPr>
-              <a:t>Dampak lain</a:t>
-            </a:r>
-            <a:endParaRPr lang="en-US" sz="1300" dirty="0"/>
-          </a:p>
-        </p:txBody>
-      </p:sp>
-      <p:sp>
-        <p:nvSpPr>
-          <p:cNvPr id="17" name="Text 15"/>
-          <p:cNvSpPr/>
-          <p:nvPr/>
-        </p:nvSpPr>
-        <p:spPr>
-          <a:xfrm>
-            <a:off x="777240" y="4928616"/>
-            <a:ext cx="10789920" cy="777240"/>
+              <a:t>DAMPAK LAIN</a:t>
+            </a:r>
+            <a:endParaRPr lang="en-US" sz="1200" dirty="0"/>
+          </a:p>
+        </p:txBody>
+      </p:sp>
+      <p:sp>
+        <p:nvSpPr>
+          <p:cNvPr id="13" name="Text 11"/>
+          <p:cNvSpPr/>
+          <p:nvPr/>
+        </p:nvSpPr>
+        <p:spPr>
+          <a:xfrm>
+            <a:off x="7178040" y="1691640"/>
+            <a:ext cx="4297680" cy="1097280"/>
           </a:xfrm>
           <a:prstGeom prst="rect">
             <a:avLst/>
@@ -5545,7 +6021,46 @@
               <a:buNone/>
             </a:pPr>
             <a:r>
-              <a:rPr lang="en-US" sz="1800" dirty="0">
+              <a:rPr lang="en-US" sz="2200" dirty="0">
+                <a:solidFill>
+                  <a:srgbClr val="1C1917"/>
+                </a:solidFill>
+                <a:latin typeface="Georgia" pitchFamily="34" charset="0"/>
+                <a:ea typeface="Georgia" pitchFamily="34" charset="-122"/>
+                <a:cs typeface="Georgia" pitchFamily="34" charset="-120"/>
+              </a:rPr>
+              <a:t>“Dapat mengandung” tidak lagi tercampur dengan bahan.</a:t>
+            </a:r>
+            <a:endParaRPr lang="en-US" sz="2200" dirty="0"/>
+          </a:p>
+        </p:txBody>
+      </p:sp>
+      <p:sp>
+        <p:nvSpPr>
+          <p:cNvPr id="14" name="Text 12"/>
+          <p:cNvSpPr/>
+          <p:nvPr/>
+        </p:nvSpPr>
+        <p:spPr>
+          <a:xfrm>
+            <a:off x="7178040" y="2880360"/>
+            <a:ext cx="4297680" cy="1463040"/>
+          </a:xfrm>
+          <a:prstGeom prst="rect">
+            <a:avLst/>
+          </a:prstGeom>
+          <a:noFill/>
+          <a:ln/>
+        </p:spPr>
+        <p:txBody>
+          <a:bodyPr wrap="square" lIns="0" tIns="0" rIns="0" bIns="0" rtlCol="0" anchor="t"/>
+          <a:lstStyle/>
+          <a:p>
+            <a:pPr indent="0" marL="0">
+              <a:buNone/>
+            </a:pPr>
+            <a:r>
+              <a:rPr lang="en-US" sz="1500" dirty="0">
                 <a:solidFill>
                   <a:srgbClr val="1C1917"/>
                 </a:solidFill>
@@ -5553,22 +6068,46 @@
                 <a:ea typeface="Calibri" pitchFamily="34" charset="-122"/>
                 <a:cs typeface="Calibri" pitchFamily="34" charset="-120"/>
               </a:rPr>
-              <a:t>Nama bahan asing ikut dikenali. Arachis hypogaea terbaca sebagai kacang, jadi pengguna tidak perlu hafal nama Latin atau Inggrisnya.</a:t>
-            </a:r>
-            <a:endParaRPr lang="en-US" sz="1800" dirty="0"/>
-          </a:p>
-        </p:txBody>
-      </p:sp>
-      <p:sp>
-        <p:nvSpPr>
-          <p:cNvPr id="18" name="Text 16"/>
-          <p:cNvSpPr/>
-          <p:nvPr/>
-        </p:nvSpPr>
-        <p:spPr>
-          <a:xfrm>
-            <a:off x="502920" y="6510528"/>
-            <a:ext cx="7315200" cy="219456"/>
+              <a:t>Pengguna tahu mana yang memang bahan produk, dan mana yang hanya kemungkinan dari pabrik. Nama Latin atau Inggris, misalnya arachis hypogaea, ikut dikenali.</a:t>
+            </a:r>
+            <a:endParaRPr lang="en-US" sz="1500" dirty="0"/>
+          </a:p>
+        </p:txBody>
+      </p:sp>
+      <p:pic>
+        <p:nvPicPr>
+          <p:cNvPr id="15" name="Image 0" descr="Kartu hijau dengan peringatan dapat mengandung kacang">    </p:cNvPr>
+          <p:cNvPicPr>
+            <a:picLocks noChangeAspect="1"/>
+          </p:cNvPicPr>
+          <p:nvPr/>
+        </p:nvPicPr>
+        <p:blipFill>
+          <a:blip r:embed="rId1"/>
+          <a:stretch>
+            <a:fillRect/>
+          </a:stretch>
+        </p:blipFill>
+        <p:spPr>
+          <a:xfrm>
+            <a:off x="7178040" y="4251960"/>
+            <a:ext cx="2194560" cy="975360"/>
+          </a:xfrm>
+          <a:prstGeom prst="rect">
+            <a:avLst/>
+          </a:prstGeom>
+        </p:spPr>
+      </p:pic>
+      <p:sp>
+        <p:nvSpPr>
+          <p:cNvPr id="16" name="Text 13"/>
+          <p:cNvSpPr/>
+          <p:nvPr/>
+        </p:nvSpPr>
+        <p:spPr>
+          <a:xfrm>
+            <a:off x="502920" y="6446520"/>
+            <a:ext cx="7315200" cy="228600"/>
           </a:xfrm>
           <a:prstGeom prst="rect">
             <a:avLst/>
@@ -5658,8 +6197,8 @@
         </p:nvSpPr>
         <p:spPr>
           <a:xfrm>
-            <a:off x="777240" y="1965960"/>
-            <a:ext cx="3657600" cy="822960"/>
+            <a:off x="777240" y="1828800"/>
+            <a:ext cx="2743200" cy="822960"/>
           </a:xfrm>
           <a:prstGeom prst="rect">
             <a:avLst/>
@@ -5697,24 +6236,24 @@
         </p:nvSpPr>
         <p:spPr>
           <a:xfrm>
-            <a:off x="777240" y="2880360"/>
-            <a:ext cx="10058400" cy="1005840"/>
-          </a:xfrm>
-          <a:prstGeom prst="rect">
-            <a:avLst/>
-          </a:prstGeom>
-          <a:noFill/>
-          <a:ln/>
-        </p:spPr>
-        <p:txBody>
-          <a:bodyPr wrap="square" lIns="0" tIns="0" rIns="0" bIns="0" rtlCol="0" anchor="ctr"/>
+            <a:off x="777240" y="2743200"/>
+            <a:ext cx="6035040" cy="1097280"/>
+          </a:xfrm>
+          <a:prstGeom prst="rect">
+            <a:avLst/>
+          </a:prstGeom>
+          <a:noFill/>
+          <a:ln/>
+        </p:spPr>
+        <p:txBody>
+          <a:bodyPr wrap="square" lIns="0" tIns="0" rIns="0" bIns="0" rtlCol="0" anchor="t"/>
           <a:lstStyle/>
           <a:p>
             <a:pPr indent="0" marL="0">
               <a:buNone/>
             </a:pPr>
             <a:r>
-              <a:rPr lang="en-US" sz="4000" dirty="0">
+              <a:rPr lang="en-US" sz="3800" dirty="0">
                 <a:solidFill>
                   <a:srgbClr val="1C1917"/>
                 </a:solidFill>
@@ -5724,10 +6263,73 @@
               </a:rPr>
               <a:t>Solusi Berbasis AI</a:t>
             </a:r>
-            <a:endParaRPr lang="en-US" sz="4000" dirty="0"/>
-          </a:p>
-        </p:txBody>
-      </p:sp>
+            <a:endParaRPr lang="en-US" sz="3800" dirty="0"/>
+          </a:p>
+        </p:txBody>
+      </p:sp>
+      <p:sp>
+        <p:nvSpPr>
+          <p:cNvPr id="5" name="Text 3"/>
+          <p:cNvSpPr/>
+          <p:nvPr/>
+        </p:nvSpPr>
+        <p:spPr>
+          <a:xfrm>
+            <a:off x="777240" y="3977640"/>
+            <a:ext cx="5669280" cy="914400"/>
+          </a:xfrm>
+          <a:prstGeom prst="rect">
+            <a:avLst/>
+          </a:prstGeom>
+          <a:noFill/>
+          <a:ln/>
+        </p:spPr>
+        <p:txBody>
+          <a:bodyPr wrap="square" lIns="0" tIns="0" rIns="0" bIns="0" rtlCol="0" anchor="t"/>
+          <a:lstStyle/>
+          <a:p>
+            <a:pPr indent="0" marL="0">
+              <a:buNone/>
+            </a:pPr>
+            <a:r>
+              <a:rPr lang="en-US" sz="1800" dirty="0">
+                <a:solidFill>
+                  <a:srgbClr val="6B6560"/>
+                </a:solidFill>
+                <a:latin typeface="Calibri" pitchFamily="34" charset="0"/>
+                <a:ea typeface="Calibri" pitchFamily="34" charset="-122"/>
+                <a:cs typeface="Calibri" pitchFamily="34" charset="-120"/>
+              </a:rPr>
+              <a:t>Tiga fitur AI berurutan dalam satu foto.</a:t>
+            </a:r>
+            <a:endParaRPr lang="en-US" sz="1800" dirty="0"/>
+          </a:p>
+        </p:txBody>
+      </p:sp>
+      <p:pic>
+        <p:nvPicPr>
+          <p:cNvPr id="6" name="Image 0" descr="Bagian hasil AI di layar app">    </p:cNvPr>
+          <p:cNvPicPr>
+            <a:picLocks noChangeAspect="1"/>
+          </p:cNvPicPr>
+          <p:nvPr/>
+        </p:nvPicPr>
+        <p:blipFill>
+          <a:blip r:embed="rId1"/>
+          <a:stretch>
+            <a:fillRect/>
+          </a:stretch>
+        </p:blipFill>
+        <p:spPr>
+          <a:xfrm>
+            <a:off x="7086600" y="1778000"/>
+            <a:ext cx="4572000" cy="3302000"/>
+          </a:xfrm>
+          <a:prstGeom prst="rect">
+            <a:avLst/>
+          </a:prstGeom>
+        </p:spPr>
+      </p:pic>
     </p:spTree>
   </p:cSld>
   <p:clrMapOvr>
@@ -5768,8 +6370,8 @@
         </p:nvSpPr>
         <p:spPr>
           <a:xfrm>
-            <a:off x="502920" y="292608"/>
-            <a:ext cx="11155680" cy="530352"/>
+            <a:off x="502920" y="320040"/>
+            <a:ext cx="11155680" cy="548640"/>
           </a:xfrm>
           <a:prstGeom prst="rect">
             <a:avLst/>
@@ -5807,18 +6409,23 @@
         </p:nvSpPr>
         <p:spPr>
           <a:xfrm>
-            <a:off x="457200" y="1097280"/>
-            <a:ext cx="2761488" cy="3931920"/>
+            <a:off x="502920" y="1143000"/>
+            <a:ext cx="2560320" cy="3840480"/>
           </a:xfrm>
           <a:prstGeom prst="roundRect">
             <a:avLst>
-              <a:gd name="adj" fmla="val 3974"/>
+              <a:gd name="adj" fmla="val 4286"/>
             </a:avLst>
           </a:prstGeom>
           <a:solidFill>
             <a:srgbClr val="FFFCF8"/>
           </a:solidFill>
-          <a:ln/>
+          <a:ln w="9525">
+            <a:solidFill>
+              <a:srgbClr val="E4DDD4"/>
+            </a:solidFill>
+            <a:prstDash val="solid"/>
+          </a:ln>
         </p:spPr>
       </p:sp>
       <p:sp>
@@ -5829,8 +6436,8 @@
         </p:nvSpPr>
         <p:spPr>
           <a:xfrm>
-            <a:off x="658368" y="1280160"/>
-            <a:ext cx="2286000" cy="457200"/>
+            <a:off x="731520" y="1325880"/>
+            <a:ext cx="914400" cy="457200"/>
           </a:xfrm>
           <a:prstGeom prst="rect">
             <a:avLst/>
@@ -5868,8 +6475,8 @@
         </p:nvSpPr>
         <p:spPr>
           <a:xfrm>
-            <a:off x="658368" y="1874520"/>
-            <a:ext cx="2359152" cy="502920"/>
+            <a:off x="731520" y="1828800"/>
+            <a:ext cx="2194560" cy="274320"/>
           </a:xfrm>
           <a:prstGeom prst="rect">
             <a:avLst/>
@@ -5885,7 +6492,7 @@
               <a:buNone/>
             </a:pPr>
             <a:r>
-              <a:rPr lang="en-US" sz="1200" dirty="0">
+              <a:rPr lang="en-US" sz="1100" dirty="0">
                 <a:solidFill>
                   <a:srgbClr val="6B6560"/>
                 </a:solidFill>
@@ -5895,7 +6502,7 @@
               </a:rPr>
               <a:t>Side-app  ·  baca teks dari foto</a:t>
             </a:r>
-            <a:endParaRPr lang="en-US" sz="1200" dirty="0"/>
+            <a:endParaRPr lang="en-US" sz="1100" dirty="0"/>
           </a:p>
         </p:txBody>
       </p:sp>
@@ -5907,24 +6514,24 @@
         </p:nvSpPr>
         <p:spPr>
           <a:xfrm>
-            <a:off x="658368" y="2377440"/>
-            <a:ext cx="2359152" cy="640080"/>
-          </a:xfrm>
-          <a:prstGeom prst="rect">
-            <a:avLst/>
-          </a:prstGeom>
-          <a:noFill/>
-          <a:ln/>
-        </p:spPr>
-        <p:txBody>
-          <a:bodyPr wrap="square" lIns="0" tIns="0" rIns="0" bIns="0" rtlCol="0" anchor="ctr"/>
+            <a:off x="731520" y="2148840"/>
+            <a:ext cx="2240280" cy="731520"/>
+          </a:xfrm>
+          <a:prstGeom prst="rect">
+            <a:avLst/>
+          </a:prstGeom>
+          <a:noFill/>
+          <a:ln/>
+        </p:spPr>
+        <p:txBody>
+          <a:bodyPr wrap="square" lIns="0" tIns="0" rIns="0" bIns="0" rtlCol="0" anchor="t"/>
           <a:lstStyle/>
           <a:p>
             <a:pPr indent="0" marL="0">
               <a:buNone/>
             </a:pPr>
             <a:r>
-              <a:rPr lang="en-US" sz="2200" dirty="0">
+              <a:rPr lang="en-US" sz="1900" dirty="0">
                 <a:solidFill>
                   <a:srgbClr val="1C1917"/>
                 </a:solidFill>
@@ -5934,7 +6541,7 @@
               </a:rPr>
               <a:t>Vision</a:t>
             </a:r>
-            <a:endParaRPr lang="en-US" sz="2200" dirty="0"/>
+            <a:endParaRPr lang="en-US" sz="1900" dirty="0"/>
           </a:p>
         </p:txBody>
       </p:sp>
@@ -5946,8 +6553,8 @@
         </p:nvSpPr>
         <p:spPr>
           <a:xfrm>
-            <a:off x="658368" y="3108960"/>
-            <a:ext cx="2359152" cy="1737360"/>
+            <a:off x="731520" y="2971800"/>
+            <a:ext cx="2148840" cy="2194560"/>
           </a:xfrm>
           <a:prstGeom prst="rect">
             <a:avLst/>
@@ -5963,7 +6570,7 @@
               <a:buNone/>
             </a:pPr>
             <a:r>
-              <a:rPr lang="en-US" sz="1400" dirty="0">
+              <a:rPr lang="en-US" sz="1350" dirty="0">
                 <a:solidFill>
                   <a:srgbClr val="1C1917"/>
                 </a:solidFill>
@@ -5971,44 +6578,88 @@
                 <a:ea typeface="Calibri" pitchFamily="34" charset="-122"/>
                 <a:cs typeface="Calibri" pitchFamily="34" charset="-120"/>
               </a:rPr>
-              <a:t>Membaca huruf di foto, bahasa Indonesia dan Inggris. Hanya teks di bawah judul Komposisi, Ingredients, atau Daftar bahan.</a:t>
-            </a:r>
-            <a:endParaRPr lang="en-US" sz="1400" dirty="0"/>
-          </a:p>
-        </p:txBody>
-      </p:sp>
-      <p:sp>
-        <p:nvSpPr>
-          <p:cNvPr id="8" name="Shape 6"/>
-          <p:cNvSpPr/>
-          <p:nvPr/>
-        </p:nvSpPr>
-        <p:spPr>
-          <a:xfrm>
-            <a:off x="3383280" y="1097280"/>
-            <a:ext cx="2761488" cy="3931920"/>
+              <a:t>Membaca huruf di foto, bahasa Indonesia dan Inggris. Hanya teks di bawah judul Komposisi atau Ingredients.</a:t>
+            </a:r>
+            <a:endParaRPr lang="en-US" sz="1350" dirty="0"/>
+          </a:p>
+        </p:txBody>
+      </p:sp>
+      <p:sp>
+        <p:nvSpPr>
+          <p:cNvPr id="8" name="Text 6"/>
+          <p:cNvSpPr/>
+          <p:nvPr/>
+        </p:nvSpPr>
+        <p:spPr>
+          <a:xfrm>
+            <a:off x="3044952" y="2743200"/>
+            <a:ext cx="228600" cy="365760"/>
+          </a:xfrm>
+          <a:prstGeom prst="rect">
+            <a:avLst/>
+          </a:prstGeom>
+          <a:noFill/>
+          <a:ln/>
+        </p:spPr>
+        <p:txBody>
+          <a:bodyPr wrap="square" lIns="0" tIns="0" rIns="0" bIns="0" rtlCol="0" anchor="ctr"/>
+          <a:lstStyle/>
+          <a:p>
+            <a:pPr algn="ctr" indent="0" marL="0">
+              <a:buNone/>
+            </a:pPr>
+            <a:r>
+              <a:rPr lang="en-US" sz="1800" dirty="0">
+                <a:solidFill>
+                  <a:srgbClr val="B85A3C"/>
+                </a:solidFill>
+                <a:latin typeface="Calibri" pitchFamily="34" charset="0"/>
+                <a:ea typeface="Calibri" pitchFamily="34" charset="-122"/>
+                <a:cs typeface="Calibri" pitchFamily="34" charset="-120"/>
+              </a:rPr>
+              <a:t>→</a:t>
+            </a:r>
+            <a:endParaRPr lang="en-US" sz="1800" dirty="0"/>
+          </a:p>
+        </p:txBody>
+      </p:sp>
+      <p:sp>
+        <p:nvSpPr>
+          <p:cNvPr id="9" name="Shape 7"/>
+          <p:cNvSpPr/>
+          <p:nvPr/>
+        </p:nvSpPr>
+        <p:spPr>
+          <a:xfrm>
+            <a:off x="3246120" y="1143000"/>
+            <a:ext cx="2560320" cy="3840480"/>
           </a:xfrm>
           <a:prstGeom prst="roundRect">
             <a:avLst>
-              <a:gd name="adj" fmla="val 3974"/>
+              <a:gd name="adj" fmla="val 4286"/>
             </a:avLst>
           </a:prstGeom>
           <a:solidFill>
             <a:srgbClr val="FFFCF8"/>
           </a:solidFill>
-          <a:ln/>
-        </p:spPr>
-      </p:sp>
-      <p:sp>
-        <p:nvSpPr>
-          <p:cNvPr id="9" name="Text 7"/>
-          <p:cNvSpPr/>
-          <p:nvPr/>
-        </p:nvSpPr>
-        <p:spPr>
-          <a:xfrm>
-            <a:off x="3584448" y="1280160"/>
-            <a:ext cx="2286000" cy="457200"/>
+          <a:ln w="9525">
+            <a:solidFill>
+              <a:srgbClr val="E4DDD4"/>
+            </a:solidFill>
+            <a:prstDash val="solid"/>
+          </a:ln>
+        </p:spPr>
+      </p:sp>
+      <p:sp>
+        <p:nvSpPr>
+          <p:cNvPr id="10" name="Text 8"/>
+          <p:cNvSpPr/>
+          <p:nvPr/>
+        </p:nvSpPr>
+        <p:spPr>
+          <a:xfrm>
+            <a:off x="3474720" y="1325880"/>
+            <a:ext cx="914400" cy="457200"/>
           </a:xfrm>
           <a:prstGeom prst="rect">
             <a:avLst/>
@@ -6040,14 +6691,14 @@
       </p:sp>
       <p:sp>
         <p:nvSpPr>
-          <p:cNvPr id="10" name="Text 8"/>
-          <p:cNvSpPr/>
-          <p:nvPr/>
-        </p:nvSpPr>
-        <p:spPr>
-          <a:xfrm>
-            <a:off x="3584448" y="1874520"/>
-            <a:ext cx="2359152" cy="502920"/>
+          <p:cNvPr id="11" name="Text 9"/>
+          <p:cNvSpPr/>
+          <p:nvPr/>
+        </p:nvSpPr>
+        <p:spPr>
+          <a:xfrm>
+            <a:off x="3474720" y="1828800"/>
+            <a:ext cx="2194560" cy="274320"/>
           </a:xfrm>
           <a:prstGeom prst="rect">
             <a:avLst/>
@@ -6063,7 +6714,7 @@
               <a:buNone/>
             </a:pPr>
             <a:r>
-              <a:rPr lang="en-US" sz="1200" dirty="0">
+              <a:rPr lang="en-US" sz="1100" dirty="0">
                 <a:solidFill>
                   <a:srgbClr val="6B6560"/>
                 </a:solidFill>
@@ -6073,36 +6724,36 @@
               </a:rPr>
               <a:t>Diajarkan  ·  sesi 1.3</a:t>
             </a:r>
-            <a:endParaRPr lang="en-US" sz="1200" dirty="0"/>
-          </a:p>
-        </p:txBody>
-      </p:sp>
-      <p:sp>
-        <p:nvSpPr>
-          <p:cNvPr id="11" name="Text 9"/>
-          <p:cNvSpPr/>
-          <p:nvPr/>
-        </p:nvSpPr>
-        <p:spPr>
-          <a:xfrm>
-            <a:off x="3584448" y="2377440"/>
-            <a:ext cx="2359152" cy="640080"/>
-          </a:xfrm>
-          <a:prstGeom prst="rect">
-            <a:avLst/>
-          </a:prstGeom>
-          <a:noFill/>
-          <a:ln/>
-        </p:spPr>
-        <p:txBody>
-          <a:bodyPr wrap="square" lIns="0" tIns="0" rIns="0" bIns="0" rtlCol="0" anchor="ctr"/>
+            <a:endParaRPr lang="en-US" sz="1100" dirty="0"/>
+          </a:p>
+        </p:txBody>
+      </p:sp>
+      <p:sp>
+        <p:nvSpPr>
+          <p:cNvPr id="12" name="Text 10"/>
+          <p:cNvSpPr/>
+          <p:nvPr/>
+        </p:nvSpPr>
+        <p:spPr>
+          <a:xfrm>
+            <a:off x="3474720" y="2148840"/>
+            <a:ext cx="2240280" cy="731520"/>
+          </a:xfrm>
+          <a:prstGeom prst="rect">
+            <a:avLst/>
+          </a:prstGeom>
+          <a:noFill/>
+          <a:ln/>
+        </p:spPr>
+        <p:txBody>
+          <a:bodyPr wrap="square" lIns="0" tIns="0" rIns="0" bIns="0" rtlCol="0" anchor="t"/>
           <a:lstStyle/>
           <a:p>
             <a:pPr indent="0" marL="0">
               <a:buNone/>
             </a:pPr>
             <a:r>
-              <a:rPr lang="en-US" sz="2200" dirty="0">
+              <a:rPr lang="en-US" sz="1900" dirty="0">
                 <a:solidFill>
                   <a:srgbClr val="1C1917"/>
                 </a:solidFill>
@@ -6112,20 +6763,20 @@
               </a:rPr>
               <a:t>Create ML</a:t>
             </a:r>
-            <a:endParaRPr lang="en-US" sz="2200" dirty="0"/>
-          </a:p>
-        </p:txBody>
-      </p:sp>
-      <p:sp>
-        <p:nvSpPr>
-          <p:cNvPr id="12" name="Text 10"/>
-          <p:cNvSpPr/>
-          <p:nvPr/>
-        </p:nvSpPr>
-        <p:spPr>
-          <a:xfrm>
-            <a:off x="3584448" y="3108960"/>
-            <a:ext cx="2359152" cy="1737360"/>
+            <a:endParaRPr lang="en-US" sz="1900" dirty="0"/>
+          </a:p>
+        </p:txBody>
+      </p:sp>
+      <p:sp>
+        <p:nvSpPr>
+          <p:cNvPr id="13" name="Text 11"/>
+          <p:cNvSpPr/>
+          <p:nvPr/>
+        </p:nvSpPr>
+        <p:spPr>
+          <a:xfrm>
+            <a:off x="3474720" y="2971800"/>
+            <a:ext cx="2148840" cy="2194560"/>
           </a:xfrm>
           <a:prstGeom prst="rect">
             <a:avLst/>
@@ -6141,7 +6792,7 @@
               <a:buNone/>
             </a:pPr>
             <a:r>
-              <a:rPr lang="en-US" sz="1400" dirty="0">
+              <a:rPr lang="en-US" sz="1350" dirty="0">
                 <a:solidFill>
                   <a:srgbClr val="1C1917"/>
                 </a:solidFill>
@@ -6149,44 +6800,88 @@
                 <a:ea typeface="Calibri" pitchFamily="34" charset="-122"/>
                 <a:cs typeface="Calibri" pitchFamily="34" charset="-120"/>
               </a:rPr>
-              <a:t>Model buatan kami menebak jenis pantangan dari teks komposisi. Hasilnya tampil di layar, misalnya kacang 92%.</a:t>
-            </a:r>
-            <a:endParaRPr lang="en-US" sz="1400" dirty="0"/>
-          </a:p>
-        </p:txBody>
-      </p:sp>
-      <p:sp>
-        <p:nvSpPr>
-          <p:cNvPr id="13" name="Shape 11"/>
-          <p:cNvSpPr/>
-          <p:nvPr/>
-        </p:nvSpPr>
-        <p:spPr>
-          <a:xfrm>
-            <a:off x="6309360" y="1097280"/>
-            <a:ext cx="2761488" cy="3931920"/>
+              <a:t>Model buatan kami memilah tiap kalimat: bahan, peringatan “dapat mengandung”, atau lain. Dilatih dari 1.197 kalimat 220 label sungguhan.</a:t>
+            </a:r>
+            <a:endParaRPr lang="en-US" sz="1350" dirty="0"/>
+          </a:p>
+        </p:txBody>
+      </p:sp>
+      <p:sp>
+        <p:nvSpPr>
+          <p:cNvPr id="14" name="Text 12"/>
+          <p:cNvSpPr/>
+          <p:nvPr/>
+        </p:nvSpPr>
+        <p:spPr>
+          <a:xfrm>
+            <a:off x="5788152" y="2743200"/>
+            <a:ext cx="228600" cy="365760"/>
+          </a:xfrm>
+          <a:prstGeom prst="rect">
+            <a:avLst/>
+          </a:prstGeom>
+          <a:noFill/>
+          <a:ln/>
+        </p:spPr>
+        <p:txBody>
+          <a:bodyPr wrap="square" lIns="0" tIns="0" rIns="0" bIns="0" rtlCol="0" anchor="ctr"/>
+          <a:lstStyle/>
+          <a:p>
+            <a:pPr algn="ctr" indent="0" marL="0">
+              <a:buNone/>
+            </a:pPr>
+            <a:r>
+              <a:rPr lang="en-US" sz="1800" dirty="0">
+                <a:solidFill>
+                  <a:srgbClr val="B85A3C"/>
+                </a:solidFill>
+                <a:latin typeface="Calibri" pitchFamily="34" charset="0"/>
+                <a:ea typeface="Calibri" pitchFamily="34" charset="-122"/>
+                <a:cs typeface="Calibri" pitchFamily="34" charset="-120"/>
+              </a:rPr>
+              <a:t>→</a:t>
+            </a:r>
+            <a:endParaRPr lang="en-US" sz="1800" dirty="0"/>
+          </a:p>
+        </p:txBody>
+      </p:sp>
+      <p:sp>
+        <p:nvSpPr>
+          <p:cNvPr id="15" name="Shape 13"/>
+          <p:cNvSpPr/>
+          <p:nvPr/>
+        </p:nvSpPr>
+        <p:spPr>
+          <a:xfrm>
+            <a:off x="5989320" y="1143000"/>
+            <a:ext cx="2560320" cy="3840480"/>
           </a:xfrm>
           <a:prstGeom prst="roundRect">
             <a:avLst>
-              <a:gd name="adj" fmla="val 3974"/>
+              <a:gd name="adj" fmla="val 4286"/>
             </a:avLst>
           </a:prstGeom>
           <a:solidFill>
             <a:srgbClr val="FFFCF8"/>
           </a:solidFill>
-          <a:ln/>
-        </p:spPr>
-      </p:sp>
-      <p:sp>
-        <p:nvSpPr>
-          <p:cNvPr id="14" name="Text 12"/>
-          <p:cNvSpPr/>
-          <p:nvPr/>
-        </p:nvSpPr>
-        <p:spPr>
-          <a:xfrm>
-            <a:off x="6510528" y="1280160"/>
-            <a:ext cx="2286000" cy="457200"/>
+          <a:ln w="9525">
+            <a:solidFill>
+              <a:srgbClr val="E4DDD4"/>
+            </a:solidFill>
+            <a:prstDash val="solid"/>
+          </a:ln>
+        </p:spPr>
+      </p:sp>
+      <p:sp>
+        <p:nvSpPr>
+          <p:cNvPr id="16" name="Text 14"/>
+          <p:cNvSpPr/>
+          <p:nvPr/>
+        </p:nvSpPr>
+        <p:spPr>
+          <a:xfrm>
+            <a:off x="6217920" y="1325880"/>
+            <a:ext cx="914400" cy="457200"/>
           </a:xfrm>
           <a:prstGeom prst="rect">
             <a:avLst/>
@@ -6218,14 +6913,14 @@
       </p:sp>
       <p:sp>
         <p:nvSpPr>
-          <p:cNvPr id="15" name="Text 13"/>
-          <p:cNvSpPr/>
-          <p:nvPr/>
-        </p:nvSpPr>
-        <p:spPr>
-          <a:xfrm>
-            <a:off x="6510528" y="1874520"/>
-            <a:ext cx="2359152" cy="502920"/>
+          <p:cNvPr id="17" name="Text 15"/>
+          <p:cNvSpPr/>
+          <p:nvPr/>
+        </p:nvSpPr>
+        <p:spPr>
+          <a:xfrm>
+            <a:off x="6217920" y="1828800"/>
+            <a:ext cx="2194560" cy="274320"/>
           </a:xfrm>
           <a:prstGeom prst="rect">
             <a:avLst/>
@@ -6241,7 +6936,7 @@
               <a:buNone/>
             </a:pPr>
             <a:r>
-              <a:rPr lang="en-US" sz="1200" dirty="0">
+              <a:rPr lang="en-US" sz="1100" dirty="0">
                 <a:solidFill>
                   <a:srgbClr val="6B6560"/>
                 </a:solidFill>
@@ -6251,36 +6946,36 @@
               </a:rPr>
               <a:t>Diajarkan  ·  sesi 2.6</a:t>
             </a:r>
-            <a:endParaRPr lang="en-US" sz="1200" dirty="0"/>
-          </a:p>
-        </p:txBody>
-      </p:sp>
-      <p:sp>
-        <p:nvSpPr>
-          <p:cNvPr id="16" name="Text 14"/>
-          <p:cNvSpPr/>
-          <p:nvPr/>
-        </p:nvSpPr>
-        <p:spPr>
-          <a:xfrm>
-            <a:off x="6510528" y="2377440"/>
-            <a:ext cx="2359152" cy="640080"/>
-          </a:xfrm>
-          <a:prstGeom prst="rect">
-            <a:avLst/>
-          </a:prstGeom>
-          <a:noFill/>
-          <a:ln/>
-        </p:spPr>
-        <p:txBody>
-          <a:bodyPr wrap="square" lIns="0" tIns="0" rIns="0" bIns="0" rtlCol="0" anchor="ctr"/>
+            <a:endParaRPr lang="en-US" sz="1100" dirty="0"/>
+          </a:p>
+        </p:txBody>
+      </p:sp>
+      <p:sp>
+        <p:nvSpPr>
+          <p:cNvPr id="18" name="Text 16"/>
+          <p:cNvSpPr/>
+          <p:nvPr/>
+        </p:nvSpPr>
+        <p:spPr>
+          <a:xfrm>
+            <a:off x="6217920" y="2148840"/>
+            <a:ext cx="2240280" cy="731520"/>
+          </a:xfrm>
+          <a:prstGeom prst="rect">
+            <a:avLst/>
+          </a:prstGeom>
+          <a:noFill/>
+          <a:ln/>
+        </p:spPr>
+        <p:txBody>
+          <a:bodyPr wrap="square" lIns="0" tIns="0" rIns="0" bIns="0" rtlCol="0" anchor="t"/>
           <a:lstStyle/>
           <a:p>
             <a:pPr indent="0" marL="0">
               <a:buNone/>
             </a:pPr>
             <a:r>
-              <a:rPr lang="en-US" sz="2200" dirty="0">
+              <a:rPr lang="en-US" sz="1900" dirty="0">
                 <a:solidFill>
                   <a:srgbClr val="1C1917"/>
                 </a:solidFill>
@@ -6290,20 +6985,20 @@
               </a:rPr>
               <a:t>Foundation Models</a:t>
             </a:r>
-            <a:endParaRPr lang="en-US" sz="2200" dirty="0"/>
-          </a:p>
-        </p:txBody>
-      </p:sp>
-      <p:sp>
-        <p:nvSpPr>
-          <p:cNvPr id="17" name="Text 15"/>
-          <p:cNvSpPr/>
-          <p:nvPr/>
-        </p:nvSpPr>
-        <p:spPr>
-          <a:xfrm>
-            <a:off x="6510528" y="3108960"/>
-            <a:ext cx="2359152" cy="1737360"/>
+            <a:endParaRPr lang="en-US" sz="1900" dirty="0"/>
+          </a:p>
+        </p:txBody>
+      </p:sp>
+      <p:sp>
+        <p:nvSpPr>
+          <p:cNvPr id="19" name="Text 17"/>
+          <p:cNvSpPr/>
+          <p:nvPr/>
+        </p:nvSpPr>
+        <p:spPr>
+          <a:xfrm>
+            <a:off x="6217920" y="2971800"/>
+            <a:ext cx="2148840" cy="2194560"/>
           </a:xfrm>
           <a:prstGeom prst="rect">
             <a:avLst/>
@@ -6319,7 +7014,7 @@
               <a:buNone/>
             </a:pPr>
             <a:r>
-              <a:rPr lang="en-US" sz="1400" dirty="0">
+              <a:rPr lang="en-US" sz="1350" dirty="0">
                 <a:solidFill>
                   <a:srgbClr val="1C1917"/>
                 </a:solidFill>
@@ -6327,99 +7022,38 @@
                 <a:ea typeface="Calibri" pitchFamily="34" charset="-122"/>
                 <a:cs typeface="Calibri" pitchFamily="34" charset="-120"/>
               </a:rPr>
-              <a:t>Model bahasa bawaan Apple Intelligence menyusun kalimat hasilnya, misalnya “Ada kacang di komposisi ini.”</a:t>
-            </a:r>
-            <a:endParaRPr lang="en-US" sz="1400" dirty="0"/>
-          </a:p>
-        </p:txBody>
-      </p:sp>
-      <p:sp>
-        <p:nvSpPr>
-          <p:cNvPr id="18" name="Shape 16"/>
-          <p:cNvSpPr/>
-          <p:nvPr/>
-        </p:nvSpPr>
-        <p:spPr>
-          <a:xfrm>
-            <a:off x="9235440" y="1097280"/>
-            <a:ext cx="2761488" cy="3931920"/>
-          </a:xfrm>
-          <a:prstGeom prst="roundRect">
-            <a:avLst>
-              <a:gd name="adj" fmla="val 3974"/>
-            </a:avLst>
-          </a:prstGeom>
-          <a:solidFill>
-            <a:srgbClr val="FFFCF8"/>
-          </a:solidFill>
-          <a:ln/>
-        </p:spPr>
-      </p:sp>
-      <p:sp>
-        <p:nvSpPr>
-          <p:cNvPr id="19" name="Text 17"/>
-          <p:cNvSpPr/>
-          <p:nvPr/>
-        </p:nvSpPr>
-        <p:spPr>
-          <a:xfrm>
-            <a:off x="9436608" y="1280160"/>
-            <a:ext cx="2286000" cy="457200"/>
-          </a:xfrm>
-          <a:prstGeom prst="rect">
-            <a:avLst/>
-          </a:prstGeom>
-          <a:noFill/>
-          <a:ln/>
-        </p:spPr>
-        <p:txBody>
-          <a:bodyPr wrap="square" lIns="0" tIns="0" rIns="0" bIns="0" rtlCol="0" anchor="ctr"/>
+              <a:t>Model bawaan Apple Intelligence menjelaskan kenapa, misalnya “Arachis hypogaea adalah nama ilmiah kacang tanah.”</a:t>
+            </a:r>
+            <a:endParaRPr lang="en-US" sz="1350" dirty="0"/>
+          </a:p>
+        </p:txBody>
+      </p:sp>
+      <p:sp>
+        <p:nvSpPr>
+          <p:cNvPr id="20" name="Text 18"/>
+          <p:cNvSpPr/>
+          <p:nvPr/>
+        </p:nvSpPr>
+        <p:spPr>
+          <a:xfrm>
+            <a:off x="502920" y="5166360"/>
+            <a:ext cx="8046720" cy="548640"/>
+          </a:xfrm>
+          <a:prstGeom prst="rect">
+            <a:avLst/>
+          </a:prstGeom>
+          <a:noFill/>
+          <a:ln/>
+        </p:spPr>
+        <p:txBody>
+          <a:bodyPr wrap="square" lIns="0" tIns="0" rIns="0" bIns="0" rtlCol="0" anchor="t"/>
           <a:lstStyle/>
           <a:p>
             <a:pPr indent="0" marL="0">
               <a:buNone/>
             </a:pPr>
             <a:r>
-              <a:rPr lang="en-US" sz="2800" dirty="0">
-                <a:solidFill>
-                  <a:srgbClr val="B85A3C"/>
-                </a:solidFill>
-                <a:latin typeface="Georgia" pitchFamily="34" charset="0"/>
-                <a:ea typeface="Georgia" pitchFamily="34" charset="-122"/>
-                <a:cs typeface="Georgia" pitchFamily="34" charset="-120"/>
-              </a:rPr>
-              <a:t>4</a:t>
-            </a:r>
-            <a:endParaRPr lang="en-US" sz="2800" dirty="0"/>
-          </a:p>
-        </p:txBody>
-      </p:sp>
-      <p:sp>
-        <p:nvSpPr>
-          <p:cNvPr id="20" name="Text 18"/>
-          <p:cNvSpPr/>
-          <p:nvPr/>
-        </p:nvSpPr>
-        <p:spPr>
-          <a:xfrm>
-            <a:off x="9436608" y="1874520"/>
-            <a:ext cx="2359152" cy="502920"/>
-          </a:xfrm>
-          <a:prstGeom prst="rect">
-            <a:avLst/>
-          </a:prstGeom>
-          <a:noFill/>
-          <a:ln/>
-        </p:spPr>
-        <p:txBody>
-          <a:bodyPr wrap="square" lIns="0" tIns="0" rIns="0" bIns="0" rtlCol="0" anchor="ctr"/>
-          <a:lstStyle/>
-          <a:p>
-            <a:pPr indent="0" marL="0">
-              <a:buNone/>
-            </a:pPr>
-            <a:r>
-              <a:rPr lang="en-US" sz="1200" dirty="0">
+              <a:rPr lang="en-US" sz="1400" dirty="0">
                 <a:solidFill>
                   <a:srgbClr val="6B6560"/>
                 </a:solidFill>
@@ -6427,22 +7061,46 @@
                 <a:ea typeface="Calibri" pitchFamily="34" charset="-122"/>
                 <a:cs typeface="Calibri" pitchFamily="34" charset="-120"/>
               </a:rPr>
-              <a:t>Side-app  ·  model di server</a:t>
-            </a:r>
-            <a:endParaRPr lang="en-US" sz="1200" dirty="0"/>
-          </a:p>
-        </p:txBody>
-      </p:sp>
-      <p:sp>
-        <p:nvSpPr>
-          <p:cNvPr id="21" name="Text 19"/>
-          <p:cNvSpPr/>
-          <p:nvPr/>
-        </p:nvSpPr>
-        <p:spPr>
-          <a:xfrm>
-            <a:off x="9436608" y="2377440"/>
-            <a:ext cx="2359152" cy="640080"/>
+              <a:t>Pantangan dicocokkan dengan daftar kata hanya di kalimat bahan. Kalimat peringatan jadi kotak kuning terpisah.</a:t>
+            </a:r>
+            <a:endParaRPr lang="en-US" sz="1400" dirty="0"/>
+          </a:p>
+        </p:txBody>
+      </p:sp>
+      <p:pic>
+        <p:nvPicPr>
+          <p:cNvPr id="21" name="Image 0" descr="Hasil AI dan penjelasan di layar app">    </p:cNvPr>
+          <p:cNvPicPr>
+            <a:picLocks noChangeAspect="1"/>
+          </p:cNvPicPr>
+          <p:nvPr/>
+        </p:nvPicPr>
+        <p:blipFill>
+          <a:blip r:embed="rId1"/>
+          <a:stretch>
+            <a:fillRect/>
+          </a:stretch>
+        </p:blipFill>
+        <p:spPr>
+          <a:xfrm>
+            <a:off x="8778240" y="1143000"/>
+            <a:ext cx="2926080" cy="2113280"/>
+          </a:xfrm>
+          <a:prstGeom prst="rect">
+            <a:avLst/>
+          </a:prstGeom>
+        </p:spPr>
+      </p:pic>
+      <p:sp>
+        <p:nvSpPr>
+          <p:cNvPr id="22" name="Text 19"/>
+          <p:cNvSpPr/>
+          <p:nvPr/>
+        </p:nvSpPr>
+        <p:spPr>
+          <a:xfrm>
+            <a:off x="8778240" y="3337560"/>
+            <a:ext cx="2926080" cy="274320"/>
           </a:xfrm>
           <a:prstGeom prst="rect">
             <a:avLst/>
@@ -6458,69 +7116,30 @@
               <a:buNone/>
             </a:pPr>
             <a:r>
-              <a:rPr lang="en-US" sz="2200" dirty="0">
-                <a:solidFill>
-                  <a:srgbClr val="1C1917"/>
-                </a:solidFill>
-                <a:latin typeface="Georgia" pitchFamily="34" charset="0"/>
-                <a:ea typeface="Georgia" pitchFamily="34" charset="-122"/>
-                <a:cs typeface="Georgia" pitchFamily="34" charset="-120"/>
-              </a:rPr>
-              <a:t>API Dicoding</a:t>
-            </a:r>
-            <a:endParaRPr lang="en-US" sz="2200" dirty="0"/>
-          </a:p>
-        </p:txBody>
-      </p:sp>
-      <p:sp>
-        <p:nvSpPr>
-          <p:cNvPr id="22" name="Text 20"/>
-          <p:cNvSpPr/>
-          <p:nvPr/>
-        </p:nvSpPr>
-        <p:spPr>
-          <a:xfrm>
-            <a:off x="9436608" y="3108960"/>
-            <a:ext cx="2359152" cy="1737360"/>
-          </a:xfrm>
-          <a:prstGeom prst="rect">
-            <a:avLst/>
-          </a:prstGeom>
-          <a:noFill/>
-          <a:ln/>
-        </p:spPr>
-        <p:txBody>
-          <a:bodyPr wrap="square" lIns="0" tIns="0" rIns="0" bIns="0" rtlCol="0" anchor="t"/>
-          <a:lstStyle/>
-          <a:p>
-            <a:pPr indent="0" marL="0">
-              <a:buNone/>
-            </a:pPr>
-            <a:r>
-              <a:rPr lang="en-US" sz="1400" dirty="0">
-                <a:solidFill>
-                  <a:srgbClr val="1C1917"/>
+              <a:rPr lang="en-US" sz="1100" dirty="0">
+                <a:solidFill>
+                  <a:srgbClr val="6B6560"/>
                 </a:solidFill>
                 <a:latin typeface="Calibri" pitchFamily="34" charset="0"/>
                 <a:ea typeface="Calibri" pitchFamily="34" charset="-122"/>
                 <a:cs typeface="Calibri" pitchFamily="34" charset="-120"/>
               </a:rPr>
-              <a:t>Kalau model Apple tidak tersedia, model di server Dicoding yang menyusun kalimatnya. Kalau internet mati, kalimat tetap keluar dan ada tombol Coba lagi.</a:t>
-            </a:r>
-            <a:endParaRPr lang="en-US" sz="1400" dirty="0"/>
-          </a:p>
-        </p:txBody>
-      </p:sp>
-      <p:sp>
-        <p:nvSpPr>
-          <p:cNvPr id="23" name="Text 21"/>
-          <p:cNvSpPr/>
-          <p:nvPr/>
-        </p:nvSpPr>
-        <p:spPr>
-          <a:xfrm>
-            <a:off x="502920" y="6510528"/>
-            <a:ext cx="7315200" cy="219456"/>
+              <a:t>Layar hasil: bagian HASIL AI dan KENAPA</a:t>
+            </a:r>
+            <a:endParaRPr lang="en-US" sz="1100" dirty="0"/>
+          </a:p>
+        </p:txBody>
+      </p:sp>
+      <p:sp>
+        <p:nvSpPr>
+          <p:cNvPr id="23" name="Text 20"/>
+          <p:cNvSpPr/>
+          <p:nvPr/>
+        </p:nvSpPr>
+        <p:spPr>
+          <a:xfrm>
+            <a:off x="502920" y="6446520"/>
+            <a:ext cx="7315200" cy="228600"/>
           </a:xfrm>
           <a:prstGeom prst="rect">
             <a:avLst/>
@@ -6610,8 +7229,8 @@
         </p:nvSpPr>
         <p:spPr>
           <a:xfrm>
-            <a:off x="777240" y="1965960"/>
-            <a:ext cx="3657600" cy="822960"/>
+            <a:off x="777240" y="1828800"/>
+            <a:ext cx="2743200" cy="822960"/>
           </a:xfrm>
           <a:prstGeom prst="rect">
             <a:avLst/>
@@ -6649,24 +7268,24 @@
         </p:nvSpPr>
         <p:spPr>
           <a:xfrm>
-            <a:off x="777240" y="2880360"/>
-            <a:ext cx="10058400" cy="1005840"/>
-          </a:xfrm>
-          <a:prstGeom prst="rect">
-            <a:avLst/>
-          </a:prstGeom>
-          <a:noFill/>
-          <a:ln/>
-        </p:spPr>
-        <p:txBody>
-          <a:bodyPr wrap="square" lIns="0" tIns="0" rIns="0" bIns="0" rtlCol="0" anchor="ctr"/>
+            <a:off x="777240" y="2743200"/>
+            <a:ext cx="6035040" cy="1097280"/>
+          </a:xfrm>
+          <a:prstGeom prst="rect">
+            <a:avLst/>
+          </a:prstGeom>
+          <a:noFill/>
+          <a:ln/>
+        </p:spPr>
+        <p:txBody>
+          <a:bodyPr wrap="square" lIns="0" tIns="0" rIns="0" bIns="0" rtlCol="0" anchor="t"/>
           <a:lstStyle/>
           <a:p>
             <a:pPr indent="0" marL="0">
               <a:buNone/>
             </a:pPr>
             <a:r>
-              <a:rPr lang="en-US" sz="4000" dirty="0">
+              <a:rPr lang="en-US" sz="3800" dirty="0">
                 <a:solidFill>
                   <a:srgbClr val="1C1917"/>
                 </a:solidFill>
@@ -6676,10 +7295,73 @@
               </a:rPr>
               <a:t>Demo Produk</a:t>
             </a:r>
-            <a:endParaRPr lang="en-US" sz="4000" dirty="0"/>
-          </a:p>
-        </p:txBody>
-      </p:sp>
+            <a:endParaRPr lang="en-US" sz="3800" dirty="0"/>
+          </a:p>
+        </p:txBody>
+      </p:sp>
+      <p:sp>
+        <p:nvSpPr>
+          <p:cNvPr id="5" name="Text 3"/>
+          <p:cNvSpPr/>
+          <p:nvPr/>
+        </p:nvSpPr>
+        <p:spPr>
+          <a:xfrm>
+            <a:off x="777240" y="3977640"/>
+            <a:ext cx="5669280" cy="914400"/>
+          </a:xfrm>
+          <a:prstGeom prst="rect">
+            <a:avLst/>
+          </a:prstGeom>
+          <a:noFill/>
+          <a:ln/>
+        </p:spPr>
+        <p:txBody>
+          <a:bodyPr wrap="square" lIns="0" tIns="0" rIns="0" bIns="0" rtlCol="0" anchor="t"/>
+          <a:lstStyle/>
+          <a:p>
+            <a:pPr indent="0" marL="0">
+              <a:buNone/>
+            </a:pPr>
+            <a:r>
+              <a:rPr lang="en-US" sz="1800" dirty="0">
+                <a:solidFill>
+                  <a:srgbClr val="6B6560"/>
+                </a:solidFill>
+                <a:latin typeface="Calibri" pitchFamily="34" charset="0"/>
+                <a:ea typeface="Calibri" pitchFamily="34" charset="-122"/>
+                <a:cs typeface="Calibri" pitchFamily="34" charset="-120"/>
+              </a:rPr>
+              <a:t>Satu kali foto, tiga kemungkinan hasil.</a:t>
+            </a:r>
+            <a:endParaRPr lang="en-US" sz="1800" dirty="0"/>
+          </a:p>
+        </p:txBody>
+      </p:sp>
+      <p:pic>
+        <p:nvPicPr>
+          <p:cNvPr id="6" name="Image 0" descr="Kartu hijau dengan peringatan dapat mengandung">    </p:cNvPr>
+          <p:cNvPicPr>
+            <a:picLocks noChangeAspect="1"/>
+          </p:cNvPicPr>
+          <p:nvPr/>
+        </p:nvPicPr>
+        <p:blipFill>
+          <a:blip r:embed="rId1"/>
+          <a:stretch>
+            <a:fillRect/>
+          </a:stretch>
+        </p:blipFill>
+        <p:spPr>
+          <a:xfrm>
+            <a:off x="7086600" y="2413000"/>
+            <a:ext cx="4572000" cy="2032000"/>
+          </a:xfrm>
+          <a:prstGeom prst="rect">
+            <a:avLst/>
+          </a:prstGeom>
+        </p:spPr>
+      </p:pic>
     </p:spTree>
   </p:cSld>
   <p:clrMapOvr>
@@ -6720,8 +7402,8 @@
         </p:nvSpPr>
         <p:spPr>
           <a:xfrm>
-            <a:off x="502920" y="292608"/>
-            <a:ext cx="11155680" cy="530352"/>
+            <a:off x="502920" y="320040"/>
+            <a:ext cx="11155680" cy="548640"/>
           </a:xfrm>
           <a:prstGeom prst="rect">
             <a:avLst/>
@@ -6761,13 +7443,14 @@
         </p:nvPicPr>
         <p:blipFill>
           <a:blip r:embed="rId1"/>
-          <a:srcRect l="0" r="0" t="0" b="0"/>
-          <a:stretch/>
+          <a:stretch>
+            <a:fillRect/>
+          </a:stretch>
         </p:blipFill>
         <p:spPr>
           <a:xfrm>
-            <a:off x="2648259" y="987552"/>
-            <a:ext cx="2042361" cy="4434840"/>
+            <a:off x="1130415" y="1005840"/>
+            <a:ext cx="2105526" cy="4572000"/>
           </a:xfrm>
           <a:prstGeom prst="rect">
             <a:avLst/>
@@ -6776,14 +7459,38 @@
       </p:pic>
       <p:sp>
         <p:nvSpPr>
-          <p:cNvPr id="4" name="Text 1"/>
-          <p:cNvSpPr/>
-          <p:nvPr/>
-        </p:nvSpPr>
-        <p:spPr>
-          <a:xfrm>
-            <a:off x="2511099" y="5532120"/>
-            <a:ext cx="2316681" cy="256032"/>
+          <p:cNvPr id="4" name="Shape 1"/>
+          <p:cNvSpPr/>
+          <p:nvPr/>
+        </p:nvSpPr>
+        <p:spPr>
+          <a:xfrm>
+            <a:off x="1130415" y="1005840"/>
+            <a:ext cx="2105526" cy="4572000"/>
+          </a:xfrm>
+          <a:prstGeom prst="roundRect">
+            <a:avLst>
+              <a:gd name="adj" fmla="val 7817"/>
+            </a:avLst>
+          </a:prstGeom>
+          <a:ln w="12700">
+            <a:solidFill>
+              <a:srgbClr val="E4DDD4"/>
+            </a:solidFill>
+            <a:prstDash val="solid"/>
+          </a:ln>
+        </p:spPr>
+      </p:sp>
+      <p:sp>
+        <p:nvSpPr>
+          <p:cNvPr id="5" name="Text 2"/>
+          <p:cNvSpPr/>
+          <p:nvPr/>
+        </p:nvSpPr>
+        <p:spPr>
+          <a:xfrm>
+            <a:off x="856095" y="5669280"/>
+            <a:ext cx="2654166" cy="274320"/>
           </a:xfrm>
           <a:prstGeom prst="rect">
             <a:avLst/>
@@ -6815,14 +7522,14 @@
       </p:sp>
       <p:sp>
         <p:nvSpPr>
-          <p:cNvPr id="5" name="Text 2"/>
-          <p:cNvSpPr/>
-          <p:nvPr/>
-        </p:nvSpPr>
-        <p:spPr>
-          <a:xfrm>
-            <a:off x="2419659" y="5779008"/>
-            <a:ext cx="2499561" cy="502920"/>
+          <p:cNvPr id="6" name="Text 3"/>
+          <p:cNvSpPr/>
+          <p:nvPr/>
+        </p:nvSpPr>
+        <p:spPr>
+          <a:xfrm>
+            <a:off x="856095" y="5943600"/>
+            <a:ext cx="2654166" cy="274320"/>
           </a:xfrm>
           <a:prstGeom prst="rect">
             <a:avLst/>
@@ -6854,7 +7561,7 @@
       </p:sp>
       <p:pic>
         <p:nvPicPr>
-          <p:cNvPr id="6" name="Image 1" descr="Foto lagi tanpa menutup app">    </p:cNvPr>
+          <p:cNvPr id="7" name="Image 1" descr="Foto lagi tanpa menutup app">    </p:cNvPr>
           <p:cNvPicPr>
             <a:picLocks noChangeAspect="1"/>
           </p:cNvPicPr>
@@ -6862,13 +7569,14 @@
         </p:nvPicPr>
         <p:blipFill>
           <a:blip r:embed="rId2"/>
-          <a:srcRect l="0" r="0" t="0" b="0"/>
-          <a:stretch/>
+          <a:stretch>
+            <a:fillRect/>
+          </a:stretch>
         </p:blipFill>
         <p:spPr>
           <a:xfrm>
-            <a:off x="5074667" y="987552"/>
-            <a:ext cx="2042361" cy="4434840"/>
+            <a:off x="3738861" y="1005840"/>
+            <a:ext cx="2105526" cy="4572000"/>
           </a:xfrm>
           <a:prstGeom prst="rect">
             <a:avLst/>
@@ -6877,14 +7585,38 @@
       </p:pic>
       <p:sp>
         <p:nvSpPr>
-          <p:cNvPr id="7" name="Text 3"/>
-          <p:cNvSpPr/>
-          <p:nvPr/>
-        </p:nvSpPr>
-        <p:spPr>
-          <a:xfrm>
-            <a:off x="4937507" y="5532120"/>
-            <a:ext cx="2316681" cy="256032"/>
+          <p:cNvPr id="8" name="Shape 4"/>
+          <p:cNvSpPr/>
+          <p:nvPr/>
+        </p:nvSpPr>
+        <p:spPr>
+          <a:xfrm>
+            <a:off x="3738861" y="1005840"/>
+            <a:ext cx="2105526" cy="4572000"/>
+          </a:xfrm>
+          <a:prstGeom prst="roundRect">
+            <a:avLst>
+              <a:gd name="adj" fmla="val 7817"/>
+            </a:avLst>
+          </a:prstGeom>
+          <a:ln w="12700">
+            <a:solidFill>
+              <a:srgbClr val="E4DDD4"/>
+            </a:solidFill>
+            <a:prstDash val="solid"/>
+          </a:ln>
+        </p:spPr>
+      </p:sp>
+      <p:sp>
+        <p:nvSpPr>
+          <p:cNvPr id="9" name="Text 5"/>
+          <p:cNvSpPr/>
+          <p:nvPr/>
+        </p:nvSpPr>
+        <p:spPr>
+          <a:xfrm>
+            <a:off x="3464541" y="5669280"/>
+            <a:ext cx="2654166" cy="274320"/>
           </a:xfrm>
           <a:prstGeom prst="rect">
             <a:avLst/>
@@ -6916,14 +7648,14 @@
       </p:sp>
       <p:sp>
         <p:nvSpPr>
-          <p:cNvPr id="8" name="Text 4"/>
-          <p:cNvSpPr/>
-          <p:nvPr/>
-        </p:nvSpPr>
-        <p:spPr>
-          <a:xfrm>
-            <a:off x="4846067" y="5779008"/>
-            <a:ext cx="2499561" cy="502920"/>
+          <p:cNvPr id="10" name="Text 6"/>
+          <p:cNvSpPr/>
+          <p:nvPr/>
+        </p:nvSpPr>
+        <p:spPr>
+          <a:xfrm>
+            <a:off x="3464541" y="5943600"/>
+            <a:ext cx="2654166" cy="274320"/>
           </a:xfrm>
           <a:prstGeom prst="rect">
             <a:avLst/>
@@ -6955,7 +7687,7 @@
       </p:sp>
       <p:pic>
         <p:nvPicPr>
-          <p:cNvPr id="9" name="Image 2" descr="Unhappy path">    </p:cNvPr>
+          <p:cNvPr id="11" name="Image 2" descr="Dapat mengandung">    </p:cNvPr>
           <p:cNvPicPr>
             <a:picLocks noChangeAspect="1"/>
           </p:cNvPicPr>
@@ -6963,13 +7695,14 @@
         </p:nvPicPr>
         <p:blipFill>
           <a:blip r:embed="rId3"/>
-          <a:srcRect l="0" r="0" t="0" b="0"/>
-          <a:stretch/>
+          <a:stretch>
+            <a:fillRect/>
+          </a:stretch>
         </p:blipFill>
         <p:spPr>
           <a:xfrm>
-            <a:off x="7501076" y="987552"/>
-            <a:ext cx="2042361" cy="4434840"/>
+            <a:off x="6347308" y="1005840"/>
+            <a:ext cx="2105526" cy="4572000"/>
           </a:xfrm>
           <a:prstGeom prst="rect">
             <a:avLst/>
@@ -6978,14 +7711,38 @@
       </p:pic>
       <p:sp>
         <p:nvSpPr>
-          <p:cNvPr id="10" name="Text 5"/>
-          <p:cNvSpPr/>
-          <p:nvPr/>
-        </p:nvSpPr>
-        <p:spPr>
-          <a:xfrm>
-            <a:off x="7363916" y="5532120"/>
-            <a:ext cx="2316681" cy="256032"/>
+          <p:cNvPr id="12" name="Shape 7"/>
+          <p:cNvSpPr/>
+          <p:nvPr/>
+        </p:nvSpPr>
+        <p:spPr>
+          <a:xfrm>
+            <a:off x="6347308" y="1005840"/>
+            <a:ext cx="2105526" cy="4572000"/>
+          </a:xfrm>
+          <a:prstGeom prst="roundRect">
+            <a:avLst>
+              <a:gd name="adj" fmla="val 7817"/>
+            </a:avLst>
+          </a:prstGeom>
+          <a:ln w="12700">
+            <a:solidFill>
+              <a:srgbClr val="E4DDD4"/>
+            </a:solidFill>
+            <a:prstDash val="solid"/>
+          </a:ln>
+        </p:spPr>
+      </p:sp>
+      <p:sp>
+        <p:nvSpPr>
+          <p:cNvPr id="13" name="Text 8"/>
+          <p:cNvSpPr/>
+          <p:nvPr/>
+        </p:nvSpPr>
+        <p:spPr>
+          <a:xfrm>
+            <a:off x="6072988" y="5669280"/>
+            <a:ext cx="2654166" cy="274320"/>
           </a:xfrm>
           <a:prstGeom prst="rect">
             <a:avLst/>
@@ -7009,7 +7766,7 @@
                 <a:ea typeface="Calibri" pitchFamily="34" charset="-122"/>
                 <a:cs typeface="Calibri" pitchFamily="34" charset="-120"/>
               </a:rPr>
-              <a:t>Unhappy path</a:t>
+              <a:t>Dapat mengandung</a:t>
             </a:r>
             <a:endParaRPr lang="en-US" sz="1300" dirty="0"/>
           </a:p>
@@ -7017,14 +7774,14 @@
       </p:sp>
       <p:sp>
         <p:nvSpPr>
-          <p:cNvPr id="11" name="Text 6"/>
-          <p:cNvSpPr/>
-          <p:nvPr/>
-        </p:nvSpPr>
-        <p:spPr>
-          <a:xfrm>
-            <a:off x="7272476" y="5779008"/>
-            <a:ext cx="2499561" cy="502920"/>
+          <p:cNvPr id="14" name="Text 9"/>
+          <p:cNvSpPr/>
+          <p:nvPr/>
+        </p:nvSpPr>
+        <p:spPr>
+          <a:xfrm>
+            <a:off x="6072988" y="5943600"/>
+            <a:ext cx="2654166" cy="274320"/>
           </a:xfrm>
           <a:prstGeom prst="rect">
             <a:avLst/>
@@ -7048,7 +7805,133 @@
                 <a:ea typeface="Calibri" pitchFamily="34" charset="-122"/>
                 <a:cs typeface="Calibri" pitchFamily="34" charset="-120"/>
               </a:rPr>
-              <a:t>Ditolak, bukan daftar komposisi.</a:t>
+              <a:t>Peringatan terpisah dari bahan.</a:t>
+            </a:r>
+            <a:endParaRPr lang="en-US" sz="1200" dirty="0"/>
+          </a:p>
+        </p:txBody>
+      </p:sp>
+      <p:pic>
+        <p:nvPicPr>
+          <p:cNvPr id="15" name="Image 3" descr="Unhappy path">    </p:cNvPr>
+          <p:cNvPicPr>
+            <a:picLocks noChangeAspect="1"/>
+          </p:cNvPicPr>
+          <p:nvPr/>
+        </p:nvPicPr>
+        <p:blipFill>
+          <a:blip r:embed="rId4"/>
+          <a:stretch>
+            <a:fillRect/>
+          </a:stretch>
+        </p:blipFill>
+        <p:spPr>
+          <a:xfrm>
+            <a:off x="8955754" y="1005840"/>
+            <a:ext cx="2105526" cy="4572000"/>
+          </a:xfrm>
+          <a:prstGeom prst="rect">
+            <a:avLst/>
+          </a:prstGeom>
+        </p:spPr>
+      </p:pic>
+      <p:sp>
+        <p:nvSpPr>
+          <p:cNvPr id="16" name="Shape 10"/>
+          <p:cNvSpPr/>
+          <p:nvPr/>
+        </p:nvSpPr>
+        <p:spPr>
+          <a:xfrm>
+            <a:off x="8955754" y="1005840"/>
+            <a:ext cx="2105526" cy="4572000"/>
+          </a:xfrm>
+          <a:prstGeom prst="roundRect">
+            <a:avLst>
+              <a:gd name="adj" fmla="val 7817"/>
+            </a:avLst>
+          </a:prstGeom>
+          <a:ln w="12700">
+            <a:solidFill>
+              <a:srgbClr val="E4DDD4"/>
+            </a:solidFill>
+            <a:prstDash val="solid"/>
+          </a:ln>
+        </p:spPr>
+      </p:sp>
+      <p:sp>
+        <p:nvSpPr>
+          <p:cNvPr id="17" name="Text 11"/>
+          <p:cNvSpPr/>
+          <p:nvPr/>
+        </p:nvSpPr>
+        <p:spPr>
+          <a:xfrm>
+            <a:off x="8681434" y="5669280"/>
+            <a:ext cx="2654166" cy="274320"/>
+          </a:xfrm>
+          <a:prstGeom prst="rect">
+            <a:avLst/>
+          </a:prstGeom>
+          <a:noFill/>
+          <a:ln/>
+        </p:spPr>
+        <p:txBody>
+          <a:bodyPr wrap="square" lIns="0" tIns="0" rIns="0" bIns="0" rtlCol="0" anchor="ctr"/>
+          <a:lstStyle/>
+          <a:p>
+            <a:pPr algn="ctr" indent="0" marL="0">
+              <a:buNone/>
+            </a:pPr>
+            <a:r>
+              <a:rPr lang="en-US" sz="1300" b="1" dirty="0">
+                <a:solidFill>
+                  <a:srgbClr val="1C1917"/>
+                </a:solidFill>
+                <a:latin typeface="Calibri" pitchFamily="34" charset="0"/>
+                <a:ea typeface="Calibri" pitchFamily="34" charset="-122"/>
+                <a:cs typeface="Calibri" pitchFamily="34" charset="-120"/>
+              </a:rPr>
+              <a:t>Unhappy path</a:t>
+            </a:r>
+            <a:endParaRPr lang="en-US" sz="1300" dirty="0"/>
+          </a:p>
+        </p:txBody>
+      </p:sp>
+      <p:sp>
+        <p:nvSpPr>
+          <p:cNvPr id="18" name="Text 12"/>
+          <p:cNvSpPr/>
+          <p:nvPr/>
+        </p:nvSpPr>
+        <p:spPr>
+          <a:xfrm>
+            <a:off x="8681434" y="5943600"/>
+            <a:ext cx="2654166" cy="274320"/>
+          </a:xfrm>
+          <a:prstGeom prst="rect">
+            <a:avLst/>
+          </a:prstGeom>
+          <a:noFill/>
+          <a:ln/>
+        </p:spPr>
+        <p:txBody>
+          <a:bodyPr wrap="square" lIns="0" tIns="0" rIns="0" bIns="0" rtlCol="0" anchor="ctr"/>
+          <a:lstStyle/>
+          <a:p>
+            <a:pPr algn="ctr" indent="0" marL="0">
+              <a:buNone/>
+            </a:pPr>
+            <a:r>
+              <a:rPr lang="en-US" sz="1200" dirty="0">
+                <a:solidFill>
+                  <a:srgbClr val="6B6560"/>
+                </a:solidFill>
+                <a:latin typeface="Calibri" pitchFamily="34" charset="0"/>
+                <a:ea typeface="Calibri" pitchFamily="34" charset="-122"/>
+                <a:cs typeface="Calibri" pitchFamily="34" charset="-120"/>
+              </a:rPr>
+              <a:t>Bukan daftar komposisi, ditolak.</a:t>
             </a:r>
             <a:endParaRPr lang="en-US" sz="1200" dirty="0"/>
           </a:p>

</xml_diff>

<commit_message>
HASIL AI: Pemilah Kalimat (model kami) dan Penjelasan (Apple Foundation Models); screenshot dan deck diperbarui
</commit_message>
<xml_diff>
--- a/presentasi/PantangMakan.pptx
+++ b/presentasi/PantangMakan.pptx
@@ -6322,8 +6322,8 @@
         </p:blipFill>
         <p:spPr>
           <a:xfrm>
-            <a:off x="7086600" y="1778000"/>
-            <a:ext cx="4572000" cy="3302000"/>
+            <a:off x="7086600" y="1596571"/>
+            <a:ext cx="4572000" cy="3664857"/>
           </a:xfrm>
           <a:prstGeom prst="rect">
             <a:avLst/>
@@ -7084,7 +7084,7 @@
         <p:spPr>
           <a:xfrm>
             <a:off x="8778240" y="1143000"/>
-            <a:ext cx="2926080" cy="2113280"/>
+            <a:ext cx="2926080" cy="2345509"/>
           </a:xfrm>
           <a:prstGeom prst="rect">
             <a:avLst/>

</xml_diff>

<commit_message>
HASIL AI dirinci per jenis kalimat, status bahasa Foundation Models + versi iOS, bersihkan markdown
</commit_message>
<xml_diff>
--- a/presentasi/PantangMakan.pptx
+++ b/presentasi/PantangMakan.pptx
@@ -6322,8 +6322,8 @@
         </p:blipFill>
         <p:spPr>
           <a:xfrm>
-            <a:off x="7086600" y="1596571"/>
-            <a:ext cx="4572000" cy="3664857"/>
+            <a:off x="7086600" y="959757"/>
+            <a:ext cx="4572000" cy="4938486"/>
           </a:xfrm>
           <a:prstGeom prst="rect">
             <a:avLst/>
@@ -7084,7 +7084,7 @@
         <p:spPr>
           <a:xfrm>
             <a:off x="8778240" y="1143000"/>
-            <a:ext cx="2926080" cy="2345509"/>
+            <a:ext cx="2926080" cy="3160631"/>
           </a:xfrm>
           <a:prstGeom prst="rect">
             <a:avLst/>
@@ -7099,7 +7099,7 @@
         </p:nvSpPr>
         <p:spPr>
           <a:xfrm>
-            <a:off x="8778240" y="3584448"/>
+            <a:off x="8778240" y="4343400"/>
             <a:ext cx="2926080" cy="274320"/>
           </a:xfrm>
           <a:prstGeom prst="rect">

</xml_diff>

<commit_message>
Perbaiki crop HASIL AI di deck
</commit_message>
<xml_diff>
--- a/presentasi/PantangMakan.pptx
+++ b/presentasi/PantangMakan.pptx
@@ -6322,8 +6322,8 @@
         </p:blipFill>
         <p:spPr>
           <a:xfrm>
-            <a:off x="7086600" y="959757"/>
-            <a:ext cx="4572000" cy="4938486"/>
+            <a:off x="7086600" y="970643"/>
+            <a:ext cx="4572000" cy="4916714"/>
           </a:xfrm>
           <a:prstGeom prst="rect">
             <a:avLst/>
@@ -7084,7 +7084,7 @@
         <p:spPr>
           <a:xfrm>
             <a:off x="8778240" y="1143000"/>
-            <a:ext cx="2926080" cy="3160631"/>
+            <a:ext cx="2926080" cy="3146697"/>
           </a:xfrm>
           <a:prstGeom prst="rect">
             <a:avLst/>

</xml_diff>

<commit_message>
UI hasil: kartu per bagian (Kenapa, Di label, Hasil AI), foto ringkas, tombol Foto ulang menempel, sorotan teks tidak pecah
</commit_message>
<xml_diff>
--- a/presentasi/PantangMakan.pptx
+++ b/presentasi/PantangMakan.pptx
@@ -6322,8 +6322,8 @@
         </p:blipFill>
         <p:spPr>
           <a:xfrm>
-            <a:off x="7086600" y="970643"/>
-            <a:ext cx="4572000" cy="4916714"/>
+            <a:off x="7086600" y="1188357"/>
+            <a:ext cx="4572000" cy="4481286"/>
           </a:xfrm>
           <a:prstGeom prst="rect">
             <a:avLst/>
@@ -7084,7 +7084,7 @@
         <p:spPr>
           <a:xfrm>
             <a:off x="8778240" y="1143000"/>
-            <a:ext cx="2926080" cy="3146697"/>
+            <a:ext cx="2926080" cy="2868023"/>
           </a:xfrm>
           <a:prstGeom prst="rect">
             <a:avLst/>
@@ -7124,7 +7124,7 @@
                 <a:ea typeface="Calibri" pitchFamily="34" charset="-122"/>
                 <a:cs typeface="Calibri" pitchFamily="34" charset="-120"/>
               </a:rPr>
-              <a:t>Layar hasil: bagian HASIL AI dan KENAPA</a:t>
+              <a:t>Layar hasil: kartu, KENAPA, dan isi label</a:t>
             </a:r>
             <a:endParaRPr lang="en-US" sz="1100" dirty="0"/>
           </a:p>

</xml_diff>